<commit_message>
docs: README·PPT에 최종 모델 선정, seed 재현성, Domain Adaptation 결과 반영
README: 최종 모델(tiny_cnn_c/96px/bicubic) 선정 근거 섹션, seed 42/123/2026
재현성 결과(평균±표준편차), AdaBN/TENT negative transfer 발견을 새 섹션으로
추가. 진행 상태·로드맵 표, 폴더 구조, 실행 순서도 함께 갱신.

PPT: 23장 → 26장. RESULT 5(최종 모델 선정)·6(seed 재현성)·7(Domain
Adaptation) 슬라이드를 기존 SUMMARY TABLE 슬라이드 양식으로 추가하고,
로드맵·표지·결론 슬라이드의 상태·날짜·다음 단계 텍스트를 갱신했다.

Co-Authored-By: Claude Sonnet 5 <noreply@anthropic.com>
</commit_message>
<xml_diff>
--- a/docs/CNN_토마토_병해분류_V2_진행보고.pptx
+++ b/docs/CNN_토마토_병해분류_V2_진행보고.pptx
@@ -26,6 +26,9 @@
     <p:sldId id="274" r:id="rId25"/>
     <p:sldId id="275" r:id="rId26"/>
     <p:sldId id="276" r:id="rId27"/>
+    <p:sldId id="279" r:id="rId30"/>
+    <p:sldId id="280" r:id="rId31"/>
+    <p:sldId id="281" r:id="rId32"/>
     <p:sldId id="277" r:id="rId28"/>
     <p:sldId id="278" r:id="rId29"/>
   </p:sldIdLst>
@@ -13003,7 +13006,7 @@
                 </a:solidFill>
                 <a:latin typeface="Calibri"/>
               </a:rPr>
-              <a:t>보류</a:t>
+              <a:t>완료</a:t>
             </a:r>
           </a:p>
         </p:txBody>
@@ -13541,7 +13544,7 @@
                 </a:solidFill>
                 <a:latin typeface="Calibri"/>
               </a:rPr>
-              <a:t>4개 평가 축(내부·효율·강건성·일반화) 결과와 그 해석</a:t>
+              <a:t>4개 평가 축(내부·효율·강건성·일반화) 결과 + 최종 모델 선정·DA 1차 실험</a:t>
             </a:r>
           </a:p>
         </p:txBody>
@@ -15507,6 +15510,1847 @@
                 </a:solidFill>
                 <a:latin typeface="Calibri"/>
               </a:rPr>
+              <a:t>RESULT 5 · FINAL MODEL</a:t>
+            </a:r>
+          </a:p>
+        </p:txBody>
+      </p:sp>
+      <p:sp>
+        <p:nvSpPr>
+          <p:cNvPr id="3" name="TextBox 2"/>
+          <p:cNvSpPr txBox="1"/>
+          <p:nvPr/>
+        </p:nvSpPr>
+        <p:spPr>
+          <a:xfrm>
+            <a:off x="548640" y="566928"/>
+            <a:ext cx="10972800" cy="548640"/>
+          </a:xfrm>
+          <a:prstGeom prst="rect">
+            <a:avLst/>
+          </a:prstGeom>
+          <a:noFill/>
+        </p:spPr>
+        <p:txBody>
+          <a:bodyPr wrap="square" anchor="t" lIns="0" rIns="0" tIns="0" bIns="0">
+            <a:spAutoFit/>
+          </a:bodyPr>
+          <a:lstStyle/>
+          <a:p>
+            <a:pPr algn="l"/>
+            <a:r>
+              <a:rPr sz="2400" b="1" i="0">
+                <a:solidFill>
+                  <a:srgbClr val="1E2761"/>
+                </a:solidFill>
+                <a:latin typeface="Cambria"/>
+              </a:rPr>
+              <a:t>최종 모델 선정 — tiny_cnn_c, 96px, bicubic</a:t>
+            </a:r>
+          </a:p>
+        </p:txBody>
+      </p:sp>
+      <p:sp>
+        <p:nvSpPr>
+          <p:cNvPr id="5" name="TextBox 4"/>
+          <p:cNvSpPr txBox="1"/>
+          <p:nvPr/>
+        </p:nvSpPr>
+        <p:spPr>
+          <a:xfrm>
+            <a:off x="548640" y="5760720"/>
+            <a:ext cx="11091672" cy="457200"/>
+          </a:xfrm>
+          <a:prstGeom prst="rect">
+            <a:avLst/>
+          </a:prstGeom>
+          <a:noFill/>
+        </p:spPr>
+        <p:txBody>
+          <a:bodyPr wrap="square" anchor="t" lIns="0" rIns="0" tIns="0" bIns="0">
+            <a:spAutoFit/>
+          </a:bodyPr>
+          <a:lstStyle/>
+          <a:p>
+            <a:pPr algn="l"/>
+            <a:r>
+              <a:rPr sz="1050" b="0" i="1">
+                <a:solidFill>
+                  <a:srgbClr val="5B5E6B"/>
+                </a:solidFill>
+                <a:latin typeface="Calibri"/>
+              </a:rPr>
+              <a:t>구조는 tiny_cnn_c(8배 작고 seed 재현성 최고)를 선택하고, 64/96/128/224px × 4개 보간법 13개 조합을 비교했다. 96px bicubic은 외부 1위(128px bicubic)와 0.1~0.3%p 차이면서 학습 시간은 21% 더 짧아 경량화 목표에 가장 부합하는 균형점으로 최종 선택했다.</a:t>
+            </a:r>
+          </a:p>
+        </p:txBody>
+      </p:sp>
+      <p:sp>
+        <p:nvSpPr>
+          <p:cNvPr id="6" name="TextBox 5"/>
+          <p:cNvSpPr txBox="1"/>
+          <p:nvPr/>
+        </p:nvSpPr>
+        <p:spPr>
+          <a:xfrm>
+            <a:off x="11430000" y="6446520"/>
+            <a:ext cx="548640" cy="274320"/>
+          </a:xfrm>
+          <a:prstGeom prst="rect">
+            <a:avLst/>
+          </a:prstGeom>
+          <a:noFill/>
+        </p:spPr>
+        <p:txBody>
+          <a:bodyPr wrap="square" anchor="t" lIns="0" rIns="0" tIns="0" bIns="0">
+            <a:spAutoFit/>
+          </a:bodyPr>
+          <a:lstStyle/>
+          <a:p>
+            <a:pPr algn="r"/>
+            <a:r>
+              <a:rPr sz="1000" b="0" i="0">
+                <a:solidFill>
+                  <a:srgbClr val="5B5E6B"/>
+                </a:solidFill>
+                <a:latin typeface="Calibri"/>
+              </a:rPr>
+              <a:t>21</a:t>
+            </a:r>
+          </a:p>
+        </p:txBody>
+      </p:sp>
+      <p:graphicFrame>
+        <p:nvGraphicFramePr>
+          <p:cNvPr id="7" name="Table 6"/>
+          <p:cNvGraphicFramePr>
+            <a:graphicFrameLocks noGrp="1"/>
+          </p:cNvGraphicFramePr>
+          <p:nvPr/>
+        </p:nvGraphicFramePr>
+        <p:xfrm>
+          <a:off x="548640" y="1600200"/>
+          <a:ext cx="9144000" cy="3931920"/>
+        </p:xfrm>
+        <a:graphic>
+          <a:graphicData uri="http://schemas.openxmlformats.org/drawingml/2006/table">
+            <a:tbl>
+              <a:tblPr firstRow="1" bandRow="1">
+                <a:tableStyleId>{5C22544A-7EE6-4342-B048-85BDC9FD1C3A}</a:tableStyleId>
+              </a:tblPr>
+              <a:tblGrid>
+                <a:gridCol w="3291840"/>
+                <a:gridCol w="2194560"/>
+                <a:gridCol w="1828800"/>
+                <a:gridCol w="1828800"/>
+              </a:tblGrid>
+              <a:tr h="786384">
+                <a:tc>
+                  <a:txBody>
+                    <a:bodyPr/>
+                    <a:lstStyle/>
+                    <a:p>
+                      <a:pPr algn="ctr"/>
+                      <a:r>
+                        <a:rPr sz="1050" b="1">
+                          <a:solidFill>
+                            <a:srgbClr val="FFFFFF"/>
+                          </a:solidFill>
+                        </a:rPr>
+                        <a:t>설정</a:t>
+                      </a:r>
+                    </a:p>
+                  </a:txBody>
+                  <a:tcPr>
+                    <a:solidFill>
+                      <a:srgbClr val="1E2761"/>
+                    </a:solidFill>
+                  </a:tcPr>
+                </a:tc>
+                <a:tc>
+                  <a:txBody>
+                    <a:bodyPr/>
+                    <a:lstStyle/>
+                    <a:p>
+                      <a:pPr algn="ctr"/>
+                      <a:r>
+                        <a:rPr sz="1050" b="1">
+                          <a:solidFill>
+                            <a:srgbClr val="FFFFFF"/>
+                          </a:solidFill>
+                        </a:rPr>
+                        <a:t>내부 정확도</a:t>
+                      </a:r>
+                    </a:p>
+                  </a:txBody>
+                  <a:tcPr>
+                    <a:solidFill>
+                      <a:srgbClr val="1E2761"/>
+                    </a:solidFill>
+                  </a:tcPr>
+                </a:tc>
+                <a:tc>
+                  <a:txBody>
+                    <a:bodyPr/>
+                    <a:lstStyle/>
+                    <a:p>
+                      <a:pPr algn="ctr"/>
+                      <a:r>
+                        <a:rPr sz="1050" b="1">
+                          <a:solidFill>
+                            <a:srgbClr val="FFFFFF"/>
+                          </a:solidFill>
+                        </a:rPr>
+                        <a:t>외부 평균</a:t>
+                      </a:r>
+                    </a:p>
+                  </a:txBody>
+                  <a:tcPr>
+                    <a:solidFill>
+                      <a:srgbClr val="1E2761"/>
+                    </a:solidFill>
+                  </a:tcPr>
+                </a:tc>
+                <a:tc>
+                  <a:txBody>
+                    <a:bodyPr/>
+                    <a:lstStyle/>
+                    <a:p>
+                      <a:pPr algn="ctr"/>
+                      <a:r>
+                        <a:rPr sz="1050" b="1">
+                          <a:solidFill>
+                            <a:srgbClr val="FFFFFF"/>
+                          </a:solidFill>
+                        </a:rPr>
+                        <a:t>학습 시간</a:t>
+                      </a:r>
+                    </a:p>
+                  </a:txBody>
+                  <a:tcPr>
+                    <a:solidFill>
+                      <a:srgbClr val="1E2761"/>
+                    </a:solidFill>
+                  </a:tcPr>
+                </a:tc>
+              </a:tr>
+              <a:tr h="786384">
+                <a:tc>
+                  <a:txBody>
+                    <a:bodyPr/>
+                    <a:lstStyle/>
+                    <a:p>
+                      <a:pPr algn="ctr"/>
+                      <a:r>
+                        <a:rPr sz="1050" b="0">
+                          <a:solidFill>
+                            <a:srgbClr val="1A1A1A"/>
+                          </a:solidFill>
+                        </a:rPr>
+                        <a:t>128px bilinear (기존 기준)</a:t>
+                      </a:r>
+                    </a:p>
+                  </a:txBody>
+                  <a:tcPr>
+                    <a:solidFill>
+                      <a:srgbClr val="FFFFFF"/>
+                    </a:solidFill>
+                  </a:tcPr>
+                </a:tc>
+                <a:tc>
+                  <a:txBody>
+                    <a:bodyPr/>
+                    <a:lstStyle/>
+                    <a:p>
+                      <a:pPr algn="ctr"/>
+                      <a:r>
+                        <a:rPr sz="1050" b="0">
+                          <a:solidFill>
+                            <a:srgbClr val="1A1A1A"/>
+                          </a:solidFill>
+                        </a:rPr>
+                        <a:t>96.26%</a:t>
+                      </a:r>
+                    </a:p>
+                  </a:txBody>
+                  <a:tcPr>
+                    <a:solidFill>
+                      <a:srgbClr val="FFFFFF"/>
+                    </a:solidFill>
+                  </a:tcPr>
+                </a:tc>
+                <a:tc>
+                  <a:txBody>
+                    <a:bodyPr/>
+                    <a:lstStyle/>
+                    <a:p>
+                      <a:pPr algn="ctr"/>
+                      <a:r>
+                        <a:rPr sz="1050" b="0">
+                          <a:solidFill>
+                            <a:srgbClr val="1A1A1A"/>
+                          </a:solidFill>
+                        </a:rPr>
+                        <a:t>20.21%</a:t>
+                      </a:r>
+                    </a:p>
+                  </a:txBody>
+                  <a:tcPr>
+                    <a:solidFill>
+                      <a:srgbClr val="FFFFFF"/>
+                    </a:solidFill>
+                  </a:tcPr>
+                </a:tc>
+                <a:tc>
+                  <a:txBody>
+                    <a:bodyPr/>
+                    <a:lstStyle/>
+                    <a:p>
+                      <a:pPr algn="ctr"/>
+                      <a:r>
+                        <a:rPr sz="1050" b="0">
+                          <a:solidFill>
+                            <a:srgbClr val="1A1A1A"/>
+                          </a:solidFill>
+                        </a:rPr>
+                        <a:t>68.5분</a:t>
+                      </a:r>
+                    </a:p>
+                  </a:txBody>
+                  <a:tcPr>
+                    <a:solidFill>
+                      <a:srgbClr val="FFFFFF"/>
+                    </a:solidFill>
+                  </a:tcPr>
+                </a:tc>
+              </a:tr>
+              <a:tr h="786384">
+                <a:tc>
+                  <a:txBody>
+                    <a:bodyPr/>
+                    <a:lstStyle/>
+                    <a:p>
+                      <a:pPr algn="ctr"/>
+                      <a:r>
+                        <a:rPr sz="1050" b="0">
+                          <a:solidFill>
+                            <a:srgbClr val="1A1A1A"/>
+                          </a:solidFill>
+                        </a:rPr>
+                        <a:t>128px area (내부 정확도 최고)</a:t>
+                      </a:r>
+                    </a:p>
+                  </a:txBody>
+                  <a:tcPr>
+                    <a:solidFill>
+                      <a:srgbClr val="EEF3FC"/>
+                    </a:solidFill>
+                  </a:tcPr>
+                </a:tc>
+                <a:tc>
+                  <a:txBody>
+                    <a:bodyPr/>
+                    <a:lstStyle/>
+                    <a:p>
+                      <a:pPr algn="ctr"/>
+                      <a:r>
+                        <a:rPr sz="1050" b="0">
+                          <a:solidFill>
+                            <a:srgbClr val="1A1A1A"/>
+                          </a:solidFill>
+                        </a:rPr>
+                        <a:t>96.96%</a:t>
+                      </a:r>
+                    </a:p>
+                  </a:txBody>
+                  <a:tcPr>
+                    <a:solidFill>
+                      <a:srgbClr val="EEF3FC"/>
+                    </a:solidFill>
+                  </a:tcPr>
+                </a:tc>
+                <a:tc>
+                  <a:txBody>
+                    <a:bodyPr/>
+                    <a:lstStyle/>
+                    <a:p>
+                      <a:pPr algn="ctr"/>
+                      <a:r>
+                        <a:rPr sz="1050" b="0">
+                          <a:solidFill>
+                            <a:srgbClr val="1A1A1A"/>
+                          </a:solidFill>
+                        </a:rPr>
+                        <a:t>21.89%</a:t>
+                      </a:r>
+                    </a:p>
+                  </a:txBody>
+                  <a:tcPr>
+                    <a:solidFill>
+                      <a:srgbClr val="EEF3FC"/>
+                    </a:solidFill>
+                  </a:tcPr>
+                </a:tc>
+                <a:tc>
+                  <a:txBody>
+                    <a:bodyPr/>
+                    <a:lstStyle/>
+                    <a:p>
+                      <a:pPr algn="ctr"/>
+                      <a:r>
+                        <a:rPr sz="1050" b="0">
+                          <a:solidFill>
+                            <a:srgbClr val="1A1A1A"/>
+                          </a:solidFill>
+                        </a:rPr>
+                        <a:t>113.3분</a:t>
+                      </a:r>
+                    </a:p>
+                  </a:txBody>
+                  <a:tcPr>
+                    <a:solidFill>
+                      <a:srgbClr val="EEF3FC"/>
+                    </a:solidFill>
+                  </a:tcPr>
+                </a:tc>
+              </a:tr>
+              <a:tr h="786384">
+                <a:tc>
+                  <a:txBody>
+                    <a:bodyPr/>
+                    <a:lstStyle/>
+                    <a:p>
+                      <a:pPr algn="ctr"/>
+                      <a:r>
+                        <a:rPr sz="1050" b="1">
+                          <a:solidFill>
+                            <a:srgbClr val="1A1A1A"/>
+                          </a:solidFill>
+                        </a:rPr>
+                        <a:t>96px bicubic (최종 선택)</a:t>
+                      </a:r>
+                    </a:p>
+                  </a:txBody>
+                  <a:tcPr>
+                    <a:solidFill>
+                      <a:srgbClr val="FFFFFF"/>
+                    </a:solidFill>
+                  </a:tcPr>
+                </a:tc>
+                <a:tc>
+                  <a:txBody>
+                    <a:bodyPr/>
+                    <a:lstStyle/>
+                    <a:p>
+                      <a:pPr algn="ctr"/>
+                      <a:r>
+                        <a:rPr sz="1050" b="1">
+                          <a:solidFill>
+                            <a:srgbClr val="1A1A1A"/>
+                          </a:solidFill>
+                        </a:rPr>
+                        <a:t>96.59%</a:t>
+                      </a:r>
+                    </a:p>
+                  </a:txBody>
+                  <a:tcPr>
+                    <a:solidFill>
+                      <a:srgbClr val="FFFFFF"/>
+                    </a:solidFill>
+                  </a:tcPr>
+                </a:tc>
+                <a:tc>
+                  <a:txBody>
+                    <a:bodyPr/>
+                    <a:lstStyle/>
+                    <a:p>
+                      <a:pPr algn="ctr"/>
+                      <a:r>
+                        <a:rPr sz="1050" b="1">
+                          <a:solidFill>
+                            <a:srgbClr val="1A1A1A"/>
+                          </a:solidFill>
+                        </a:rPr>
+                        <a:t>23.02%</a:t>
+                      </a:r>
+                    </a:p>
+                  </a:txBody>
+                  <a:tcPr>
+                    <a:solidFill>
+                      <a:srgbClr val="FFFFFF"/>
+                    </a:solidFill>
+                  </a:tcPr>
+                </a:tc>
+                <a:tc>
+                  <a:txBody>
+                    <a:bodyPr/>
+                    <a:lstStyle/>
+                    <a:p>
+                      <a:pPr algn="ctr"/>
+                      <a:r>
+                        <a:rPr sz="1050" b="1">
+                          <a:solidFill>
+                            <a:srgbClr val="1A1A1A"/>
+                          </a:solidFill>
+                        </a:rPr>
+                        <a:t>75.9분</a:t>
+                      </a:r>
+                    </a:p>
+                  </a:txBody>
+                  <a:tcPr>
+                    <a:solidFill>
+                      <a:srgbClr val="FFFFFF"/>
+                    </a:solidFill>
+                  </a:tcPr>
+                </a:tc>
+              </a:tr>
+              <a:tr h="786384">
+                <a:tc>
+                  <a:txBody>
+                    <a:bodyPr/>
+                    <a:lstStyle/>
+                    <a:p>
+                      <a:pPr algn="ctr"/>
+                      <a:r>
+                        <a:rPr sz="1050" b="0">
+                          <a:solidFill>
+                            <a:srgbClr val="1A1A1A"/>
+                          </a:solidFill>
+                        </a:rPr>
+                        <a:t>128px bicubic (외부 1위)</a:t>
+                      </a:r>
+                    </a:p>
+                  </a:txBody>
+                  <a:tcPr>
+                    <a:solidFill>
+                      <a:srgbClr val="EEF3FC"/>
+                    </a:solidFill>
+                  </a:tcPr>
+                </a:tc>
+                <a:tc>
+                  <a:txBody>
+                    <a:bodyPr/>
+                    <a:lstStyle/>
+                    <a:p>
+                      <a:pPr algn="ctr"/>
+                      <a:r>
+                        <a:rPr sz="1050" b="0">
+                          <a:solidFill>
+                            <a:srgbClr val="1A1A1A"/>
+                          </a:solidFill>
+                        </a:rPr>
+                        <a:t>96.66%</a:t>
+                      </a:r>
+                    </a:p>
+                  </a:txBody>
+                  <a:tcPr>
+                    <a:solidFill>
+                      <a:srgbClr val="EEF3FC"/>
+                    </a:solidFill>
+                  </a:tcPr>
+                </a:tc>
+                <a:tc>
+                  <a:txBody>
+                    <a:bodyPr/>
+                    <a:lstStyle/>
+                    <a:p>
+                      <a:pPr algn="ctr"/>
+                      <a:r>
+                        <a:rPr sz="1050" b="0">
+                          <a:solidFill>
+                            <a:srgbClr val="1A1A1A"/>
+                          </a:solidFill>
+                        </a:rPr>
+                        <a:t>23.31%</a:t>
+                      </a:r>
+                    </a:p>
+                  </a:txBody>
+                  <a:tcPr>
+                    <a:solidFill>
+                      <a:srgbClr val="EEF3FC"/>
+                    </a:solidFill>
+                  </a:tcPr>
+                </a:tc>
+                <a:tc>
+                  <a:txBody>
+                    <a:bodyPr/>
+                    <a:lstStyle/>
+                    <a:p>
+                      <a:pPr algn="ctr"/>
+                      <a:r>
+                        <a:rPr sz="1050" b="0">
+                          <a:solidFill>
+                            <a:srgbClr val="1A1A1A"/>
+                          </a:solidFill>
+                        </a:rPr>
+                        <a:t>95.7분</a:t>
+                      </a:r>
+                    </a:p>
+                  </a:txBody>
+                  <a:tcPr>
+                    <a:solidFill>
+                      <a:srgbClr val="EEF3FC"/>
+                    </a:solidFill>
+                  </a:tcPr>
+                </a:tc>
+              </a:tr>
+            </a:tbl>
+          </a:graphicData>
+        </a:graphic>
+      </p:graphicFrame>
+    </p:spTree>
+  </p:cSld>
+  <p:clrMapOvr>
+    <a:masterClrMapping/>
+  </p:clrMapOvr>
+</p:sld>
+</file>
+
+<file path=ppt/slides/slide23.xml><?xml version="1.0" encoding="utf-8"?>
+<p:sld xmlns:a="http://schemas.openxmlformats.org/drawingml/2006/main" xmlns:p="http://schemas.openxmlformats.org/presentationml/2006/main" xmlns:r="http://schemas.openxmlformats.org/officeDocument/2006/relationships">
+  <p:cSld>
+    <p:bg>
+      <p:bgPr>
+        <a:solidFill>
+          <a:srgbClr val="FFFFFF"/>
+        </a:solidFill>
+        <a:effectLst/>
+      </p:bgPr>
+    </p:bg>
+    <p:spTree>
+      <p:nvGrpSpPr>
+        <p:cNvPr id="1" name=""/>
+        <p:cNvGrpSpPr/>
+        <p:nvPr/>
+      </p:nvGrpSpPr>
+      <p:grpSpPr/>
+      <p:sp>
+        <p:nvSpPr>
+          <p:cNvPr id="2" name="TextBox 1"/>
+          <p:cNvSpPr txBox="1"/>
+          <p:nvPr/>
+        </p:nvSpPr>
+        <p:spPr>
+          <a:xfrm>
+            <a:off x="548640" y="292608"/>
+            <a:ext cx="9144000" cy="292608"/>
+          </a:xfrm>
+          <a:prstGeom prst="rect">
+            <a:avLst/>
+          </a:prstGeom>
+          <a:noFill/>
+        </p:spPr>
+        <p:txBody>
+          <a:bodyPr wrap="square" anchor="t" lIns="0" rIns="0" tIns="0" bIns="0">
+            <a:spAutoFit/>
+          </a:bodyPr>
+          <a:lstStyle/>
+          <a:p>
+            <a:pPr algn="l"/>
+            <a:r>
+              <a:rPr sz="1050" b="1" i="0" spc="150">
+                <a:solidFill>
+                  <a:srgbClr val="2A78D6"/>
+                </a:solidFill>
+                <a:latin typeface="Calibri"/>
+              </a:rPr>
+              <a:t>RESULT 6 · SEED REPRODUCIBILITY</a:t>
+            </a:r>
+          </a:p>
+        </p:txBody>
+      </p:sp>
+      <p:sp>
+        <p:nvSpPr>
+          <p:cNvPr id="3" name="TextBox 2"/>
+          <p:cNvSpPr txBox="1"/>
+          <p:nvPr/>
+        </p:nvSpPr>
+        <p:spPr>
+          <a:xfrm>
+            <a:off x="548640" y="566928"/>
+            <a:ext cx="10972800" cy="548640"/>
+          </a:xfrm>
+          <a:prstGeom prst="rect">
+            <a:avLst/>
+          </a:prstGeom>
+          <a:noFill/>
+        </p:spPr>
+        <p:txBody>
+          <a:bodyPr wrap="square" anchor="t" lIns="0" rIns="0" tIns="0" bIns="0">
+            <a:spAutoFit/>
+          </a:bodyPr>
+          <a:lstStyle/>
+          <a:p>
+            <a:pPr algn="l"/>
+            <a:r>
+              <a:rPr sz="2400" b="1" i="0">
+                <a:solidFill>
+                  <a:srgbClr val="1E2761"/>
+                </a:solidFill>
+                <a:latin typeface="Cambria"/>
+              </a:rPr>
+              <a:t>Seed 재현성 — 42 / 123 / 2026 반복실험</a:t>
+            </a:r>
+          </a:p>
+        </p:txBody>
+      </p:sp>
+      <p:sp>
+        <p:nvSpPr>
+          <p:cNvPr id="5" name="TextBox 4"/>
+          <p:cNvSpPr txBox="1"/>
+          <p:nvPr/>
+        </p:nvSpPr>
+        <p:spPr>
+          <a:xfrm>
+            <a:off x="548640" y="5760720"/>
+            <a:ext cx="11091672" cy="457200"/>
+          </a:xfrm>
+          <a:prstGeom prst="rect">
+            <a:avLst/>
+          </a:prstGeom>
+          <a:noFill/>
+        </p:spPr>
+        <p:txBody>
+          <a:bodyPr wrap="square" anchor="t" lIns="0" rIns="0" tIns="0" bIns="0">
+            <a:spAutoFit/>
+          </a:bodyPr>
+          <a:lstStyle/>
+          <a:p>
+            <a:pPr algn="l"/>
+            <a:r>
+              <a:rPr sz="1050" b="0" i="1">
+                <a:solidFill>
+                  <a:srgbClr val="5B5E6B"/>
+                </a:solidFill>
+                <a:latin typeface="Calibri"/>
+              </a:rPr>
+              <a:t>config.SEEDS=[42,123,2026] 3개 seed로 전부 재학습·재평가했다. tiny_cnn_b가 정확도는 가장 높지만 seed 간 편차도 가장 크고(±0.64%p), tiny_cnn_c는 편차가 0.25%p로 세 모델 중 가장 안정적이다 — 최종 모델 선정에서 이 재현성도 함께 고려했다.</a:t>
+            </a:r>
+          </a:p>
+        </p:txBody>
+      </p:sp>
+      <p:sp>
+        <p:nvSpPr>
+          <p:cNvPr id="6" name="TextBox 5"/>
+          <p:cNvSpPr txBox="1"/>
+          <p:nvPr/>
+        </p:nvSpPr>
+        <p:spPr>
+          <a:xfrm>
+            <a:off x="11430000" y="6446520"/>
+            <a:ext cx="548640" cy="274320"/>
+          </a:xfrm>
+          <a:prstGeom prst="rect">
+            <a:avLst/>
+          </a:prstGeom>
+          <a:noFill/>
+        </p:spPr>
+        <p:txBody>
+          <a:bodyPr wrap="square" anchor="t" lIns="0" rIns="0" tIns="0" bIns="0">
+            <a:spAutoFit/>
+          </a:bodyPr>
+          <a:lstStyle/>
+          <a:p>
+            <a:pPr algn="r"/>
+            <a:r>
+              <a:rPr sz="1000" b="0" i="0">
+                <a:solidFill>
+                  <a:srgbClr val="5B5E6B"/>
+                </a:solidFill>
+                <a:latin typeface="Calibri"/>
+              </a:rPr>
+              <a:t>22</a:t>
+            </a:r>
+          </a:p>
+        </p:txBody>
+      </p:sp>
+      <p:graphicFrame>
+        <p:nvGraphicFramePr>
+          <p:cNvPr id="7" name="Table 6"/>
+          <p:cNvGraphicFramePr>
+            <a:graphicFrameLocks noGrp="1"/>
+          </p:cNvGraphicFramePr>
+          <p:nvPr/>
+        </p:nvGraphicFramePr>
+        <p:xfrm>
+          <a:off x="548640" y="1600200"/>
+          <a:ext cx="9144000" cy="3931920"/>
+        </p:xfrm>
+        <a:graphic>
+          <a:graphicData uri="http://schemas.openxmlformats.org/drawingml/2006/table">
+            <a:tbl>
+              <a:tblPr firstRow="1" bandRow="1">
+                <a:tableStyleId>{5C22544A-7EE6-4342-B048-85BDC9FD1C3A}</a:tableStyleId>
+              </a:tblPr>
+              <a:tblGrid>
+                <a:gridCol w="2194560"/>
+                <a:gridCol w="2743200"/>
+                <a:gridCol w="2377440"/>
+                <a:gridCol w="1828800"/>
+              </a:tblGrid>
+              <a:tr h="982980">
+                <a:tc>
+                  <a:txBody>
+                    <a:bodyPr/>
+                    <a:lstStyle/>
+                    <a:p>
+                      <a:pPr algn="ctr"/>
+                      <a:r>
+                        <a:rPr sz="1050" b="1">
+                          <a:solidFill>
+                            <a:srgbClr val="FFFFFF"/>
+                          </a:solidFill>
+                        </a:rPr>
+                        <a:t>모델</a:t>
+                      </a:r>
+                    </a:p>
+                  </a:txBody>
+                  <a:tcPr>
+                    <a:solidFill>
+                      <a:srgbClr val="1E2761"/>
+                    </a:solidFill>
+                  </a:tcPr>
+                </a:tc>
+                <a:tc>
+                  <a:txBody>
+                    <a:bodyPr/>
+                    <a:lstStyle/>
+                    <a:p>
+                      <a:pPr algn="ctr"/>
+                      <a:r>
+                        <a:rPr sz="1050" b="1">
+                          <a:solidFill>
+                            <a:srgbClr val="FFFFFF"/>
+                          </a:solidFill>
+                        </a:rPr>
+                        <a:t>내부 정확도 (평균±표준편차)</a:t>
+                      </a:r>
+                    </a:p>
+                  </a:txBody>
+                  <a:tcPr>
+                    <a:solidFill>
+                      <a:srgbClr val="1E2761"/>
+                    </a:solidFill>
+                  </a:tcPr>
+                </a:tc>
+                <a:tc>
+                  <a:txBody>
+                    <a:bodyPr/>
+                    <a:lstStyle/>
+                    <a:p>
+                      <a:pPr algn="ctr"/>
+                      <a:r>
+                        <a:rPr sz="1050" b="1">
+                          <a:solidFill>
+                            <a:srgbClr val="FFFFFF"/>
+                          </a:solidFill>
+                        </a:rPr>
+                        <a:t>Corruption 평균 저하율</a:t>
+                      </a:r>
+                    </a:p>
+                  </a:txBody>
+                  <a:tcPr>
+                    <a:solidFill>
+                      <a:srgbClr val="1E2761"/>
+                    </a:solidFill>
+                  </a:tcPr>
+                </a:tc>
+                <a:tc>
+                  <a:txBody>
+                    <a:bodyPr/>
+                    <a:lstStyle/>
+                    <a:p>
+                      <a:pPr algn="ctr"/>
+                      <a:r>
+                        <a:rPr sz="1050" b="1">
+                          <a:solidFill>
+                            <a:srgbClr val="FFFFFF"/>
+                          </a:solidFill>
+                        </a:rPr>
+                        <a:t>비고</a:t>
+                      </a:r>
+                    </a:p>
+                  </a:txBody>
+                  <a:tcPr>
+                    <a:solidFill>
+                      <a:srgbClr val="1E2761"/>
+                    </a:solidFill>
+                  </a:tcPr>
+                </a:tc>
+              </a:tr>
+              <a:tr h="982980">
+                <a:tc>
+                  <a:txBody>
+                    <a:bodyPr/>
+                    <a:lstStyle/>
+                    <a:p>
+                      <a:pPr algn="ctr"/>
+                      <a:r>
+                        <a:rPr sz="1050" b="0">
+                          <a:solidFill>
+                            <a:srgbClr val="1A1A1A"/>
+                          </a:solidFill>
+                        </a:rPr>
+                        <a:t>tiny_cnn_a</a:t>
+                      </a:r>
+                    </a:p>
+                  </a:txBody>
+                  <a:tcPr>
+                    <a:solidFill>
+                      <a:srgbClr val="FFFFFF"/>
+                    </a:solidFill>
+                  </a:tcPr>
+                </a:tc>
+                <a:tc>
+                  <a:txBody>
+                    <a:bodyPr/>
+                    <a:lstStyle/>
+                    <a:p>
+                      <a:pPr algn="ctr"/>
+                      <a:r>
+                        <a:rPr sz="1050" b="0">
+                          <a:solidFill>
+                            <a:srgbClr val="1A1A1A"/>
+                          </a:solidFill>
+                        </a:rPr>
+                        <a:t>96.36% ± 0.46</a:t>
+                      </a:r>
+                    </a:p>
+                  </a:txBody>
+                  <a:tcPr>
+                    <a:solidFill>
+                      <a:srgbClr val="FFFFFF"/>
+                    </a:solidFill>
+                  </a:tcPr>
+                </a:tc>
+                <a:tc>
+                  <a:txBody>
+                    <a:bodyPr/>
+                    <a:lstStyle/>
+                    <a:p>
+                      <a:pPr algn="ctr"/>
+                      <a:r>
+                        <a:rPr sz="1050" b="0">
+                          <a:solidFill>
+                            <a:srgbClr val="1A1A1A"/>
+                          </a:solidFill>
+                        </a:rPr>
+                        <a:t>31.28%</a:t>
+                      </a:r>
+                    </a:p>
+                  </a:txBody>
+                  <a:tcPr>
+                    <a:solidFill>
+                      <a:srgbClr val="FFFFFF"/>
+                    </a:solidFill>
+                  </a:tcPr>
+                </a:tc>
+                <a:tc>
+                  <a:txBody>
+                    <a:bodyPr/>
+                    <a:lstStyle/>
+                    <a:p>
+                      <a:pPr algn="ctr"/>
+                      <a:r>
+                        <a:rPr sz="1050" b="0">
+                          <a:solidFill>
+                            <a:srgbClr val="1A1A1A"/>
+                          </a:solidFill>
+                        </a:rPr>
+                        <a:t> </a:t>
+                      </a:r>
+                    </a:p>
+                  </a:txBody>
+                  <a:tcPr>
+                    <a:solidFill>
+                      <a:srgbClr val="FFFFFF"/>
+                    </a:solidFill>
+                  </a:tcPr>
+                </a:tc>
+              </a:tr>
+              <a:tr h="982980">
+                <a:tc>
+                  <a:txBody>
+                    <a:bodyPr/>
+                    <a:lstStyle/>
+                    <a:p>
+                      <a:pPr algn="ctr"/>
+                      <a:r>
+                        <a:rPr sz="1050" b="0">
+                          <a:solidFill>
+                            <a:srgbClr val="1A1A1A"/>
+                          </a:solidFill>
+                        </a:rPr>
+                        <a:t>tiny_cnn_b</a:t>
+                      </a:r>
+                    </a:p>
+                  </a:txBody>
+                  <a:tcPr>
+                    <a:solidFill>
+                      <a:srgbClr val="EEF3FC"/>
+                    </a:solidFill>
+                  </a:tcPr>
+                </a:tc>
+                <a:tc>
+                  <a:txBody>
+                    <a:bodyPr/>
+                    <a:lstStyle/>
+                    <a:p>
+                      <a:pPr algn="ctr"/>
+                      <a:r>
+                        <a:rPr sz="1050" b="0">
+                          <a:solidFill>
+                            <a:srgbClr val="1A1A1A"/>
+                          </a:solidFill>
+                        </a:rPr>
+                        <a:t>97.64% ± 0.64</a:t>
+                      </a:r>
+                    </a:p>
+                  </a:txBody>
+                  <a:tcPr>
+                    <a:solidFill>
+                      <a:srgbClr val="EEF3FC"/>
+                    </a:solidFill>
+                  </a:tcPr>
+                </a:tc>
+                <a:tc>
+                  <a:txBody>
+                    <a:bodyPr/>
+                    <a:lstStyle/>
+                    <a:p>
+                      <a:pPr algn="ctr"/>
+                      <a:r>
+                        <a:rPr sz="1050" b="0">
+                          <a:solidFill>
+                            <a:srgbClr val="1A1A1A"/>
+                          </a:solidFill>
+                        </a:rPr>
+                        <a:t>26.37% (최선)</a:t>
+                      </a:r>
+                    </a:p>
+                  </a:txBody>
+                  <a:tcPr>
+                    <a:solidFill>
+                      <a:srgbClr val="EEF3FC"/>
+                    </a:solidFill>
+                  </a:tcPr>
+                </a:tc>
+                <a:tc>
+                  <a:txBody>
+                    <a:bodyPr/>
+                    <a:lstStyle/>
+                    <a:p>
+                      <a:pPr algn="ctr"/>
+                      <a:r>
+                        <a:rPr sz="1050" b="0">
+                          <a:solidFill>
+                            <a:srgbClr val="1A1A1A"/>
+                          </a:solidFill>
+                        </a:rPr>
+                        <a:t>편차 최대</a:t>
+                      </a:r>
+                    </a:p>
+                  </a:txBody>
+                  <a:tcPr>
+                    <a:solidFill>
+                      <a:srgbClr val="EEF3FC"/>
+                    </a:solidFill>
+                  </a:tcPr>
+                </a:tc>
+              </a:tr>
+              <a:tr h="982980">
+                <a:tc>
+                  <a:txBody>
+                    <a:bodyPr/>
+                    <a:lstStyle/>
+                    <a:p>
+                      <a:pPr algn="ctr"/>
+                      <a:r>
+                        <a:rPr sz="1050" b="1">
+                          <a:solidFill>
+                            <a:srgbClr val="1A1A1A"/>
+                          </a:solidFill>
+                        </a:rPr>
+                        <a:t>tiny_cnn_c</a:t>
+                      </a:r>
+                    </a:p>
+                  </a:txBody>
+                  <a:tcPr>
+                    <a:solidFill>
+                      <a:srgbClr val="FFFFFF"/>
+                    </a:solidFill>
+                  </a:tcPr>
+                </a:tc>
+                <a:tc>
+                  <a:txBody>
+                    <a:bodyPr/>
+                    <a:lstStyle/>
+                    <a:p>
+                      <a:pPr algn="ctr"/>
+                      <a:r>
+                        <a:rPr sz="1050" b="1">
+                          <a:solidFill>
+                            <a:srgbClr val="1A1A1A"/>
+                          </a:solidFill>
+                        </a:rPr>
+                        <a:t>96.46% ± 0.25</a:t>
+                      </a:r>
+                    </a:p>
+                  </a:txBody>
+                  <a:tcPr>
+                    <a:solidFill>
+                      <a:srgbClr val="FFFFFF"/>
+                    </a:solidFill>
+                  </a:tcPr>
+                </a:tc>
+                <a:tc>
+                  <a:txBody>
+                    <a:bodyPr/>
+                    <a:lstStyle/>
+                    <a:p>
+                      <a:pPr algn="ctr"/>
+                      <a:r>
+                        <a:rPr sz="1050" b="1">
+                          <a:solidFill>
+                            <a:srgbClr val="1A1A1A"/>
+                          </a:solidFill>
+                        </a:rPr>
+                        <a:t>29.74%</a:t>
+                      </a:r>
+                    </a:p>
+                  </a:txBody>
+                  <a:tcPr>
+                    <a:solidFill>
+                      <a:srgbClr val="FFFFFF"/>
+                    </a:solidFill>
+                  </a:tcPr>
+                </a:tc>
+                <a:tc>
+                  <a:txBody>
+                    <a:bodyPr/>
+                    <a:lstStyle/>
+                    <a:p>
+                      <a:pPr algn="ctr"/>
+                      <a:r>
+                        <a:rPr sz="1050" b="1">
+                          <a:solidFill>
+                            <a:srgbClr val="1A1A1A"/>
+                          </a:solidFill>
+                        </a:rPr>
+                        <a:t>재현성 최선</a:t>
+                      </a:r>
+                    </a:p>
+                  </a:txBody>
+                  <a:tcPr>
+                    <a:solidFill>
+                      <a:srgbClr val="FFFFFF"/>
+                    </a:solidFill>
+                  </a:tcPr>
+                </a:tc>
+              </a:tr>
+            </a:tbl>
+          </a:graphicData>
+        </a:graphic>
+      </p:graphicFrame>
+    </p:spTree>
+  </p:cSld>
+  <p:clrMapOvr>
+    <a:masterClrMapping/>
+  </p:clrMapOvr>
+</p:sld>
+</file>
+
+<file path=ppt/slides/slide24.xml><?xml version="1.0" encoding="utf-8"?>
+<p:sld xmlns:a="http://schemas.openxmlformats.org/drawingml/2006/main" xmlns:p="http://schemas.openxmlformats.org/presentationml/2006/main" xmlns:r="http://schemas.openxmlformats.org/officeDocument/2006/relationships">
+  <p:cSld>
+    <p:bg>
+      <p:bgPr>
+        <a:solidFill>
+          <a:srgbClr val="FFFFFF"/>
+        </a:solidFill>
+        <a:effectLst/>
+      </p:bgPr>
+    </p:bg>
+    <p:spTree>
+      <p:nvGrpSpPr>
+        <p:cNvPr id="1" name=""/>
+        <p:cNvGrpSpPr/>
+        <p:nvPr/>
+      </p:nvGrpSpPr>
+      <p:grpSpPr/>
+      <p:sp>
+        <p:nvSpPr>
+          <p:cNvPr id="2" name="TextBox 1"/>
+          <p:cNvSpPr txBox="1"/>
+          <p:nvPr/>
+        </p:nvSpPr>
+        <p:spPr>
+          <a:xfrm>
+            <a:off x="548640" y="292608"/>
+            <a:ext cx="9144000" cy="292608"/>
+          </a:xfrm>
+          <a:prstGeom prst="rect">
+            <a:avLst/>
+          </a:prstGeom>
+          <a:noFill/>
+        </p:spPr>
+        <p:txBody>
+          <a:bodyPr wrap="square" anchor="t" lIns="0" rIns="0" tIns="0" bIns="0">
+            <a:spAutoFit/>
+          </a:bodyPr>
+          <a:lstStyle/>
+          <a:p>
+            <a:pPr algn="l"/>
+            <a:r>
+              <a:rPr sz="1050" b="1" i="0" spc="150">
+                <a:solidFill>
+                  <a:srgbClr val="2A78D6"/>
+                </a:solidFill>
+                <a:latin typeface="Calibri"/>
+              </a:rPr>
+              <a:t>RESULT 7 · DOMAIN ADAPTATION</a:t>
+            </a:r>
+          </a:p>
+        </p:txBody>
+      </p:sp>
+      <p:sp>
+        <p:nvSpPr>
+          <p:cNvPr id="3" name="TextBox 2"/>
+          <p:cNvSpPr txBox="1"/>
+          <p:nvPr/>
+        </p:nvSpPr>
+        <p:spPr>
+          <a:xfrm>
+            <a:off x="548640" y="566928"/>
+            <a:ext cx="10972800" cy="548640"/>
+          </a:xfrm>
+          <a:prstGeom prst="rect">
+            <a:avLst/>
+          </a:prstGeom>
+          <a:noFill/>
+        </p:spPr>
+        <p:txBody>
+          <a:bodyPr wrap="square" anchor="t" lIns="0" rIns="0" tIns="0" bIns="0">
+            <a:spAutoFit/>
+          </a:bodyPr>
+          <a:lstStyle/>
+          <a:p>
+            <a:pPr algn="l"/>
+            <a:r>
+              <a:rPr sz="2400" b="1" i="0">
+                <a:solidFill>
+                  <a:srgbClr val="1E2761"/>
+                </a:solidFill>
+                <a:latin typeface="Cambria"/>
+              </a:rPr>
+              <a:t>Domain Adaptation (AdaBN / TENT) — 1차 실험</a:t>
+            </a:r>
+          </a:p>
+        </p:txBody>
+      </p:sp>
+      <p:sp>
+        <p:nvSpPr>
+          <p:cNvPr id="5" name="TextBox 4"/>
+          <p:cNvSpPr txBox="1"/>
+          <p:nvPr/>
+        </p:nvSpPr>
+        <p:spPr>
+          <a:xfrm>
+            <a:off x="548640" y="5760720"/>
+            <a:ext cx="11091672" cy="457200"/>
+          </a:xfrm>
+          <a:prstGeom prst="rect">
+            <a:avLst/>
+          </a:prstGeom>
+          <a:noFill/>
+        </p:spPr>
+        <p:txBody>
+          <a:bodyPr wrap="square" anchor="t" lIns="0" rIns="0" tIns="0" bIns="0">
+            <a:spAutoFit/>
+          </a:bodyPr>
+          <a:lstStyle/>
+          <a:p>
+            <a:pPr algn="l"/>
+            <a:r>
+              <a:rPr sz="1050" b="0" i="1">
+                <a:solidFill>
+                  <a:srgbClr val="5B5E6B"/>
+                </a:solidFill>
+                <a:latin typeface="Calibri"/>
+              </a:rPr>
+              <a:t>최종 모델에 source-free·target-label 미사용 조건으로 AdaBN/TENT를 적용했으나 둘 다 모든 데이터셋에서 source-only보다 악화됐다 — 예측이 target에 없는 클래스로 쏠리는 negative transfer 때문이며, 클래스 겹침이 적을수록(Taiwan) 저하가 더 컸다. Partial label-space mismatch(PADA) 문제가 실측으로 재현된 것으로, SHOT 등 partial-set 고려 방법이 다음 후보다.</a:t>
+            </a:r>
+          </a:p>
+        </p:txBody>
+      </p:sp>
+      <p:sp>
+        <p:nvSpPr>
+          <p:cNvPr id="6" name="TextBox 5"/>
+          <p:cNvSpPr txBox="1"/>
+          <p:nvPr/>
+        </p:nvSpPr>
+        <p:spPr>
+          <a:xfrm>
+            <a:off x="11430000" y="6446520"/>
+            <a:ext cx="548640" cy="274320"/>
+          </a:xfrm>
+          <a:prstGeom prst="rect">
+            <a:avLst/>
+          </a:prstGeom>
+          <a:noFill/>
+        </p:spPr>
+        <p:txBody>
+          <a:bodyPr wrap="square" anchor="t" lIns="0" rIns="0" tIns="0" bIns="0">
+            <a:spAutoFit/>
+          </a:bodyPr>
+          <a:lstStyle/>
+          <a:p>
+            <a:pPr algn="r"/>
+            <a:r>
+              <a:rPr sz="1000" b="0" i="0">
+                <a:solidFill>
+                  <a:srgbClr val="5B5E6B"/>
+                </a:solidFill>
+                <a:latin typeface="Calibri"/>
+              </a:rPr>
+              <a:t>23</a:t>
+            </a:r>
+          </a:p>
+        </p:txBody>
+      </p:sp>
+      <p:graphicFrame>
+        <p:nvGraphicFramePr>
+          <p:cNvPr id="7" name="Table 6"/>
+          <p:cNvGraphicFramePr>
+            <a:graphicFrameLocks noGrp="1"/>
+          </p:cNvGraphicFramePr>
+          <p:nvPr/>
+        </p:nvGraphicFramePr>
+        <p:xfrm>
+          <a:off x="548640" y="1600200"/>
+          <a:ext cx="8961120" cy="3931920"/>
+        </p:xfrm>
+        <a:graphic>
+          <a:graphicData uri="http://schemas.openxmlformats.org/drawingml/2006/table">
+            <a:tbl>
+              <a:tblPr firstRow="1" bandRow="1">
+                <a:tableStyleId>{5C22544A-7EE6-4342-B048-85BDC9FD1C3A}</a:tableStyleId>
+              </a:tblPr>
+              <a:tblGrid>
+                <a:gridCol w="2194560"/>
+                <a:gridCol w="1645920"/>
+                <a:gridCol w="1828800"/>
+                <a:gridCol w="1645920"/>
+                <a:gridCol w="1645920"/>
+              </a:tblGrid>
+              <a:tr h="982980">
+                <a:tc>
+                  <a:txBody>
+                    <a:bodyPr/>
+                    <a:lstStyle/>
+                    <a:p>
+                      <a:pPr algn="ctr"/>
+                      <a:r>
+                        <a:rPr sz="1050" b="1">
+                          <a:solidFill>
+                            <a:srgbClr val="FFFFFF"/>
+                          </a:solidFill>
+                        </a:rPr>
+                        <a:t>데이터셋</a:t>
+                      </a:r>
+                    </a:p>
+                  </a:txBody>
+                  <a:tcPr>
+                    <a:solidFill>
+                      <a:srgbClr val="1E2761"/>
+                    </a:solidFill>
+                  </a:tcPr>
+                </a:tc>
+                <a:tc>
+                  <a:txBody>
+                    <a:bodyPr/>
+                    <a:lstStyle/>
+                    <a:p>
+                      <a:pPr algn="ctr"/>
+                      <a:r>
+                        <a:rPr sz="1050" b="1">
+                          <a:solidFill>
+                            <a:srgbClr val="FFFFFF"/>
+                          </a:solidFill>
+                        </a:rPr>
+                        <a:t>클래스 겹침</a:t>
+                      </a:r>
+                    </a:p>
+                  </a:txBody>
+                  <a:tcPr>
+                    <a:solidFill>
+                      <a:srgbClr val="1E2761"/>
+                    </a:solidFill>
+                  </a:tcPr>
+                </a:tc>
+                <a:tc>
+                  <a:txBody>
+                    <a:bodyPr/>
+                    <a:lstStyle/>
+                    <a:p>
+                      <a:pPr algn="ctr"/>
+                      <a:r>
+                        <a:rPr sz="1050" b="1">
+                          <a:solidFill>
+                            <a:srgbClr val="FFFFFF"/>
+                          </a:solidFill>
+                        </a:rPr>
+                        <a:t>Source-only</a:t>
+                      </a:r>
+                    </a:p>
+                  </a:txBody>
+                  <a:tcPr>
+                    <a:solidFill>
+                      <a:srgbClr val="1E2761"/>
+                    </a:solidFill>
+                  </a:tcPr>
+                </a:tc>
+                <a:tc>
+                  <a:txBody>
+                    <a:bodyPr/>
+                    <a:lstStyle/>
+                    <a:p>
+                      <a:pPr algn="ctr"/>
+                      <a:r>
+                        <a:rPr sz="1050" b="1">
+                          <a:solidFill>
+                            <a:srgbClr val="FFFFFF"/>
+                          </a:solidFill>
+                        </a:rPr>
+                        <a:t>AdaBN</a:t>
+                      </a:r>
+                    </a:p>
+                  </a:txBody>
+                  <a:tcPr>
+                    <a:solidFill>
+                      <a:srgbClr val="1E2761"/>
+                    </a:solidFill>
+                  </a:tcPr>
+                </a:tc>
+                <a:tc>
+                  <a:txBody>
+                    <a:bodyPr/>
+                    <a:lstStyle/>
+                    <a:p>
+                      <a:pPr algn="ctr"/>
+                      <a:r>
+                        <a:rPr sz="1050" b="1">
+                          <a:solidFill>
+                            <a:srgbClr val="FFFFFF"/>
+                          </a:solidFill>
+                        </a:rPr>
+                        <a:t>TENT</a:t>
+                      </a:r>
+                    </a:p>
+                  </a:txBody>
+                  <a:tcPr>
+                    <a:solidFill>
+                      <a:srgbClr val="1E2761"/>
+                    </a:solidFill>
+                  </a:tcPr>
+                </a:tc>
+              </a:tr>
+              <a:tr h="982980">
+                <a:tc>
+                  <a:txBody>
+                    <a:bodyPr/>
+                    <a:lstStyle/>
+                    <a:p>
+                      <a:pPr algn="ctr"/>
+                      <a:r>
+                        <a:rPr sz="1050" b="0">
+                          <a:solidFill>
+                            <a:srgbClr val="1A1A1A"/>
+                          </a:solidFill>
+                        </a:rPr>
+                        <a:t>Taiwan</a:t>
+                      </a:r>
+                    </a:p>
+                  </a:txBody>
+                  <a:tcPr>
+                    <a:solidFill>
+                      <a:srgbClr val="FFFFFF"/>
+                    </a:solidFill>
+                  </a:tcPr>
+                </a:tc>
+                <a:tc>
+                  <a:txBody>
+                    <a:bodyPr/>
+                    <a:lstStyle/>
+                    <a:p>
+                      <a:pPr algn="ctr"/>
+                      <a:r>
+                        <a:rPr sz="1050" b="0">
+                          <a:solidFill>
+                            <a:srgbClr val="1A1A1A"/>
+                          </a:solidFill>
+                        </a:rPr>
+                        <a:t>3/10</a:t>
+                      </a:r>
+                    </a:p>
+                  </a:txBody>
+                  <a:tcPr>
+                    <a:solidFill>
+                      <a:srgbClr val="FFFFFF"/>
+                    </a:solidFill>
+                  </a:tcPr>
+                </a:tc>
+                <a:tc>
+                  <a:txBody>
+                    <a:bodyPr/>
+                    <a:lstStyle/>
+                    <a:p>
+                      <a:pPr algn="ctr"/>
+                      <a:r>
+                        <a:rPr sz="1050" b="1">
+                          <a:solidFill>
+                            <a:srgbClr val="1A1A1A"/>
+                          </a:solidFill>
+                        </a:rPr>
+                        <a:t>27.39%</a:t>
+                      </a:r>
+                    </a:p>
+                  </a:txBody>
+                  <a:tcPr>
+                    <a:solidFill>
+                      <a:srgbClr val="FFFFFF"/>
+                    </a:solidFill>
+                  </a:tcPr>
+                </a:tc>
+                <a:tc>
+                  <a:txBody>
+                    <a:bodyPr/>
+                    <a:lstStyle/>
+                    <a:p>
+                      <a:pPr algn="ctr"/>
+                      <a:r>
+                        <a:rPr sz="1050" b="0">
+                          <a:solidFill>
+                            <a:srgbClr val="1A1A1A"/>
+                          </a:solidFill>
+                        </a:rPr>
+                        <a:t>7.64%</a:t>
+                      </a:r>
+                    </a:p>
+                  </a:txBody>
+                  <a:tcPr>
+                    <a:solidFill>
+                      <a:srgbClr val="FFFFFF"/>
+                    </a:solidFill>
+                  </a:tcPr>
+                </a:tc>
+                <a:tc>
+                  <a:txBody>
+                    <a:bodyPr/>
+                    <a:lstStyle/>
+                    <a:p>
+                      <a:pPr algn="ctr"/>
+                      <a:r>
+                        <a:rPr sz="1050" b="0">
+                          <a:solidFill>
+                            <a:srgbClr val="1A1A1A"/>
+                          </a:solidFill>
+                        </a:rPr>
+                        <a:t>7.64%</a:t>
+                      </a:r>
+                    </a:p>
+                  </a:txBody>
+                  <a:tcPr>
+                    <a:solidFill>
+                      <a:srgbClr val="FFFFFF"/>
+                    </a:solidFill>
+                  </a:tcPr>
+                </a:tc>
+              </a:tr>
+              <a:tr h="982980">
+                <a:tc>
+                  <a:txBody>
+                    <a:bodyPr/>
+                    <a:lstStyle/>
+                    <a:p>
+                      <a:pPr algn="ctr"/>
+                      <a:r>
+                        <a:rPr sz="1050" b="0">
+                          <a:solidFill>
+                            <a:srgbClr val="1A1A1A"/>
+                          </a:solidFill>
+                        </a:rPr>
+                        <a:t>Bangladesh</a:t>
+                      </a:r>
+                    </a:p>
+                  </a:txBody>
+                  <a:tcPr>
+                    <a:solidFill>
+                      <a:srgbClr val="EEF3FC"/>
+                    </a:solidFill>
+                  </a:tcPr>
+                </a:tc>
+                <a:tc>
+                  <a:txBody>
+                    <a:bodyPr/>
+                    <a:lstStyle/>
+                    <a:p>
+                      <a:pPr algn="ctr"/>
+                      <a:r>
+                        <a:rPr sz="1050" b="0">
+                          <a:solidFill>
+                            <a:srgbClr val="1A1A1A"/>
+                          </a:solidFill>
+                        </a:rPr>
+                        <a:t>6/10</a:t>
+                      </a:r>
+                    </a:p>
+                  </a:txBody>
+                  <a:tcPr>
+                    <a:solidFill>
+                      <a:srgbClr val="EEF3FC"/>
+                    </a:solidFill>
+                  </a:tcPr>
+                </a:tc>
+                <a:tc>
+                  <a:txBody>
+                    <a:bodyPr/>
+                    <a:lstStyle/>
+                    <a:p>
+                      <a:pPr algn="ctr"/>
+                      <a:r>
+                        <a:rPr sz="1050" b="1">
+                          <a:solidFill>
+                            <a:srgbClr val="1A1A1A"/>
+                          </a:solidFill>
+                        </a:rPr>
+                        <a:t>21.80%</a:t>
+                      </a:r>
+                    </a:p>
+                  </a:txBody>
+                  <a:tcPr>
+                    <a:solidFill>
+                      <a:srgbClr val="EEF3FC"/>
+                    </a:solidFill>
+                  </a:tcPr>
+                </a:tc>
+                <a:tc>
+                  <a:txBody>
+                    <a:bodyPr/>
+                    <a:lstStyle/>
+                    <a:p>
+                      <a:pPr algn="ctr"/>
+                      <a:r>
+                        <a:rPr sz="1050" b="0">
+                          <a:solidFill>
+                            <a:srgbClr val="1A1A1A"/>
+                          </a:solidFill>
+                        </a:rPr>
+                        <a:t>10.17%</a:t>
+                      </a:r>
+                    </a:p>
+                  </a:txBody>
+                  <a:tcPr>
+                    <a:solidFill>
+                      <a:srgbClr val="EEF3FC"/>
+                    </a:solidFill>
+                  </a:tcPr>
+                </a:tc>
+                <a:tc>
+                  <a:txBody>
+                    <a:bodyPr/>
+                    <a:lstStyle/>
+                    <a:p>
+                      <a:pPr algn="ctr"/>
+                      <a:r>
+                        <a:rPr sz="1050" b="0">
+                          <a:solidFill>
+                            <a:srgbClr val="1A1A1A"/>
+                          </a:solidFill>
+                        </a:rPr>
+                        <a:t>9.17%</a:t>
+                      </a:r>
+                    </a:p>
+                  </a:txBody>
+                  <a:tcPr>
+                    <a:solidFill>
+                      <a:srgbClr val="EEF3FC"/>
+                    </a:solidFill>
+                  </a:tcPr>
+                </a:tc>
+              </a:tr>
+              <a:tr h="982980">
+                <a:tc>
+                  <a:txBody>
+                    <a:bodyPr/>
+                    <a:lstStyle/>
+                    <a:p>
+                      <a:pPr algn="ctr"/>
+                      <a:r>
+                        <a:rPr sz="1050" b="0">
+                          <a:solidFill>
+                            <a:srgbClr val="1A1A1A"/>
+                          </a:solidFill>
+                        </a:rPr>
+                        <a:t>PlantDoc</a:t>
+                      </a:r>
+                    </a:p>
+                  </a:txBody>
+                  <a:tcPr>
+                    <a:solidFill>
+                      <a:srgbClr val="FFFFFF"/>
+                    </a:solidFill>
+                  </a:tcPr>
+                </a:tc>
+                <a:tc>
+                  <a:txBody>
+                    <a:bodyPr/>
+                    <a:lstStyle/>
+                    <a:p>
+                      <a:pPr algn="ctr"/>
+                      <a:r>
+                        <a:rPr sz="1050" b="0">
+                          <a:solidFill>
+                            <a:srgbClr val="1A1A1A"/>
+                          </a:solidFill>
+                        </a:rPr>
+                        <a:t>8/10</a:t>
+                      </a:r>
+                    </a:p>
+                  </a:txBody>
+                  <a:tcPr>
+                    <a:solidFill>
+                      <a:srgbClr val="FFFFFF"/>
+                    </a:solidFill>
+                  </a:tcPr>
+                </a:tc>
+                <a:tc>
+                  <a:txBody>
+                    <a:bodyPr/>
+                    <a:lstStyle/>
+                    <a:p>
+                      <a:pPr algn="ctr"/>
+                      <a:r>
+                        <a:rPr sz="1050" b="1">
+                          <a:solidFill>
+                            <a:srgbClr val="1A1A1A"/>
+                          </a:solidFill>
+                        </a:rPr>
+                        <a:t>19.89%</a:t>
+                      </a:r>
+                    </a:p>
+                  </a:txBody>
+                  <a:tcPr>
+                    <a:solidFill>
+                      <a:srgbClr val="FFFFFF"/>
+                    </a:solidFill>
+                  </a:tcPr>
+                </a:tc>
+                <a:tc>
+                  <a:txBody>
+                    <a:bodyPr/>
+                    <a:lstStyle/>
+                    <a:p>
+                      <a:pPr algn="ctr"/>
+                      <a:r>
+                        <a:rPr sz="1050" b="0">
+                          <a:solidFill>
+                            <a:srgbClr val="1A1A1A"/>
+                          </a:solidFill>
+                        </a:rPr>
+                        <a:t>13.12%</a:t>
+                      </a:r>
+                    </a:p>
+                  </a:txBody>
+                  <a:tcPr>
+                    <a:solidFill>
+                      <a:srgbClr val="FFFFFF"/>
+                    </a:solidFill>
+                  </a:tcPr>
+                </a:tc>
+                <a:tc>
+                  <a:txBody>
+                    <a:bodyPr/>
+                    <a:lstStyle/>
+                    <a:p>
+                      <a:pPr algn="ctr"/>
+                      <a:r>
+                        <a:rPr sz="1050" b="0">
+                          <a:solidFill>
+                            <a:srgbClr val="1A1A1A"/>
+                          </a:solidFill>
+                        </a:rPr>
+                        <a:t>11.00%</a:t>
+                      </a:r>
+                    </a:p>
+                  </a:txBody>
+                  <a:tcPr>
+                    <a:solidFill>
+                      <a:srgbClr val="FFFFFF"/>
+                    </a:solidFill>
+                  </a:tcPr>
+                </a:tc>
+              </a:tr>
+            </a:tbl>
+          </a:graphicData>
+        </a:graphic>
+      </p:graphicFrame>
+    </p:spTree>
+  </p:cSld>
+  <p:clrMapOvr>
+    <a:masterClrMapping/>
+  </p:clrMapOvr>
+</p:sld>
+</file>
+
+<file path=ppt/slides/slide25.xml><?xml version="1.0" encoding="utf-8"?>
+<p:sld xmlns:a="http://schemas.openxmlformats.org/drawingml/2006/main" xmlns:p="http://schemas.openxmlformats.org/presentationml/2006/main" xmlns:r="http://schemas.openxmlformats.org/officeDocument/2006/relationships">
+  <p:cSld>
+    <p:bg>
+      <p:bgPr>
+        <a:solidFill>
+          <a:srgbClr val="FFFFFF"/>
+        </a:solidFill>
+        <a:effectLst/>
+      </p:bgPr>
+    </p:bg>
+    <p:spTree>
+      <p:nvGrpSpPr>
+        <p:cNvPr id="1" name=""/>
+        <p:cNvGrpSpPr/>
+        <p:nvPr/>
+      </p:nvGrpSpPr>
+      <p:grpSpPr/>
+      <p:sp>
+        <p:nvSpPr>
+          <p:cNvPr id="2" name="TextBox 1"/>
+          <p:cNvSpPr txBox="1"/>
+          <p:nvPr/>
+        </p:nvSpPr>
+        <p:spPr>
+          <a:xfrm>
+            <a:off x="548640" y="292608"/>
+            <a:ext cx="9144000" cy="292608"/>
+          </a:xfrm>
+          <a:prstGeom prst="rect">
+            <a:avLst/>
+          </a:prstGeom>
+          <a:noFill/>
+        </p:spPr>
+        <p:txBody>
+          <a:bodyPr wrap="square" anchor="t" lIns="0" rIns="0" tIns="0" bIns="0">
+            <a:spAutoFit/>
+          </a:bodyPr>
+          <a:lstStyle/>
+          <a:p>
+            <a:pPr algn="l"/>
+            <a:r>
+              <a:rPr sz="1050" b="1" i="0" spc="150">
+                <a:solidFill>
+                  <a:srgbClr val="2A78D6"/>
+                </a:solidFill>
+                <a:latin typeface="Calibri"/>
+              </a:rPr>
               <a:t>7단계 · WEB PROTOTYPE</a:t>
             </a:r>
           </a:p>
@@ -16462,7 +18306,7 @@
                 </a:solidFill>
                 <a:latin typeface="Calibri"/>
               </a:rPr>
-              <a:t>21</a:t>
+              <a:t>24</a:t>
             </a:r>
           </a:p>
         </p:txBody>
@@ -16475,7 +18319,7 @@
 </p:sld>
 </file>
 
-<file path=ppt/slides/slide23.xml><?xml version="1.0" encoding="utf-8"?>
+<file path=ppt/slides/slide26.xml><?xml version="1.0" encoding="utf-8"?>
 <p:sld xmlns:a="http://schemas.openxmlformats.org/drawingml/2006/main" xmlns:p="http://schemas.openxmlformats.org/presentationml/2006/main" xmlns:r="http://schemas.openxmlformats.org/officeDocument/2006/relationships">
   <p:cSld>
     <p:bg>
@@ -16981,7 +18825,7 @@
                 </a:solidFill>
                 <a:latin typeface="Calibri"/>
               </a:rPr>
-              <a:t>6단계 — 정확도·크기·강건성·일반화 중 우선순위를 함께 정하고 최종 모델을 선정한다. 선정 후 app/streamlit_app.py의 DEFAULT_MODEL만 교체하면 7단계 배포가 바로 완료된다.</a:t>
+              <a:t>6단계 완료 — tiny_cnn_c, 96px, bicubic을 최종 모델로 선정(경량화·내부·외부·학습시간 종합 고려). 8단계 1차 결과: AdaBN/TENT는 partial label-space mismatch로 오히려 성능이 악화됨을 확인 — 다음은 SHOT(partial-set 고려) 적용 검토. app/streamlit_app.py의 DEFAULT_MODEL 교체로 7단계 배포 가능.</a:t>
             </a:r>
           </a:p>
         </p:txBody>
@@ -17055,7 +18899,7 @@
                 </a:solidFill>
                 <a:latin typeface="Calibri"/>
               </a:rPr>
-              <a:t>PyTorch 전환 근거 · 4개 데이터셋 처리 과정(장수/클래스/방법/이유) · bbox 크롭 문제와 해결 · PlantDoc 품질검수 과정 · 모델 설계 원칙과 선택 이유 · 체크포인트 사고 · 조건별 강건성 원인 해석</a:t>
+              <a:t>최종 모델 선정(해상도×보간법 13개 조합 비교) · seed 42/123/2026 반복실험(재현성) · 체크포인트 재개 기능 · Domain Adaptation(AdaBN/TENT) 1차 실험과 negative transfer 발견</a:t>
             </a:r>
           </a:p>
         </p:txBody>
@@ -17090,7 +18934,7 @@
                 </a:solidFill>
                 <a:latin typeface="Calibri"/>
               </a:rPr>
-              <a:t>22</a:t>
+              <a:t>25</a:t>
             </a:r>
           </a:p>
         </p:txBody>

</xml_diff>

<commit_message>
feat: Domain Adaptation 마스킹/TENT 수정/AdaBN 블렌딩/SHOT 추가, SHOT을 최종 권장 방법으로 확정
AdaBN/TENT의 negative transfer 원인(partial label-space mismatch)을 진단한 데 이어
class-restriction 마스킹(class_info.py 매핑 기반, 추가 학습 없음)으로 1차 해결하고,
마스킹을 적응 과정에 반영한 mask-aware TENT(+collapse 방지용 diversity 정규화),
AdaBN momentum 블렌딩, SHOT(pseudo-labeling + information-maximization)을 추가로
시도했다. SHOT만 3개 외부 데이터셋 전부에서 collapse 없이 안정적으로 최고 성능을 내서
"마스킹 항상 적용 + SHOT을 기본 적응 방법으로" 를 최종 권장 파이프라인으로 확정하고
README/실행계획 문서/PPT(RESULT 7을 3슬라이드로 확장)에 반영했다.

Co-Authored-By: Claude Sonnet 5 <noreply@anthropic.com>
</commit_message>
<xml_diff>
--- a/docs/CNN_토마토_병해분류_V2_진행보고.pptx
+++ b/docs/CNN_토마토_병해분류_V2_진행보고.pptx
@@ -29,6 +29,8 @@
     <p:sldId id="279" r:id="rId30"/>
     <p:sldId id="280" r:id="rId31"/>
     <p:sldId id="281" r:id="rId32"/>
+    <p:sldId id="282" r:id="rId33"/>
+    <p:sldId id="283" r:id="rId34"/>
     <p:sldId id="277" r:id="rId28"/>
     <p:sldId id="278" r:id="rId29"/>
   </p:sldIdLst>
@@ -15837,7 +15839,7 @@
                             <a:srgbClr val="1A1A1A"/>
                           </a:solidFill>
                         </a:rPr>
-                        <a:t>128px area (내부 정확도 최고)</a:t>
+                        <a:t>128px box (내부 정확도 최고)</a:t>
                       </a:r>
                     </a:p>
                   </a:txBody>
@@ -16702,13 +16704,13 @@
           <a:p>
             <a:pPr algn="l"/>
             <a:r>
-              <a:rPr sz="1050" b="1" i="0" spc="150">
+              <a:rPr sz="1050" b="1" i="0">
                 <a:solidFill>
                   <a:srgbClr val="2A78D6"/>
                 </a:solidFill>
                 <a:latin typeface="Calibri"/>
               </a:rPr>
-              <a:t>RESULT 7 · DOMAIN ADAPTATION</a:t>
+              <a:t>RESULT 7 · DOMAIN ADAPTATION (1/3)</a:t>
             </a:r>
           </a:p>
         </p:txBody>
@@ -16743,21 +16745,21 @@
                 </a:solidFill>
                 <a:latin typeface="Cambria"/>
               </a:rPr>
-              <a:t>Domain Adaptation (AdaBN / TENT) — 1차 실험</a:t>
-            </a:r>
-          </a:p>
-        </p:txBody>
-      </p:sp>
-      <p:sp>
-        <p:nvSpPr>
-          <p:cNvPr id="5" name="TextBox 4"/>
+              <a:t>AdaBN / TENT 적용 — 그러나 전부 악화 (Negative Transfer)</a:t>
+            </a:r>
+          </a:p>
+        </p:txBody>
+      </p:sp>
+      <p:sp>
+        <p:nvSpPr>
+          <p:cNvPr id="4" name="TextBox 3"/>
           <p:cNvSpPr txBox="1"/>
           <p:nvPr/>
         </p:nvSpPr>
         <p:spPr>
           <a:xfrm>
-            <a:off x="548640" y="5760720"/>
-            <a:ext cx="11091672" cy="457200"/>
+            <a:off x="548640" y="1250000"/>
+            <a:ext cx="11091672" cy="750000"/>
           </a:xfrm>
           <a:prstGeom prst="rect">
             <a:avLst/>
@@ -16772,63 +16774,28 @@
           <a:p>
             <a:pPr algn="l"/>
             <a:r>
-              <a:rPr sz="1050" b="0" i="1">
-                <a:solidFill>
-                  <a:srgbClr val="5B5E6B"/>
+              <a:rPr sz="1050" b="0" i="0">
+                <a:solidFill>
+                  <a:srgbClr val="1A1A1A"/>
                 </a:solidFill>
                 <a:latin typeface="Calibri"/>
               </a:rPr>
-              <a:t>최종 모델에 source-free·target-label 미사용 조건으로 AdaBN/TENT를 적용했으나 둘 다 모든 데이터셋에서 source-only보다 악화됐다 — 예측이 target에 없는 클래스로 쏠리는 negative transfer 때문이며, 클래스 겹침이 적을수록(Taiwan) 저하가 더 컸다. Partial label-space mismatch(PADA) 문제가 실측으로 재현된 것으로, SHOT 등 partial-set 고려 방법이 다음 후보다.</a:t>
-            </a:r>
-          </a:p>
-        </p:txBody>
-      </p:sp>
-      <p:sp>
-        <p:nvSpPr>
-          <p:cNvPr id="6" name="TextBox 5"/>
-          <p:cNvSpPr txBox="1"/>
-          <p:nvPr/>
-        </p:nvSpPr>
-        <p:spPr>
-          <a:xfrm>
-            <a:off x="11430000" y="6446520"/>
-            <a:ext cx="548640" cy="274320"/>
-          </a:xfrm>
-          <a:prstGeom prst="rect">
-            <a:avLst/>
-          </a:prstGeom>
-          <a:noFill/>
-        </p:spPr>
-        <p:txBody>
-          <a:bodyPr wrap="square" anchor="t" lIns="0" rIns="0" tIns="0" bIns="0">
-            <a:spAutoFit/>
-          </a:bodyPr>
-          <a:lstStyle/>
-          <a:p>
-            <a:pPr algn="r"/>
-            <a:r>
-              <a:rPr sz="1000" b="0" i="0">
-                <a:solidFill>
-                  <a:srgbClr val="5B5E6B"/>
-                </a:solidFill>
-                <a:latin typeface="Calibri"/>
-              </a:rPr>
-              <a:t>23</a:t>
+              <a:t>AdaBN(Li et al., 2016)은 target 이미지로 forward pass만 수행해 BN running 통계를 완전 교체한다(역전파 없음). TENT(Wang et al., ICLR 2021, 공식 코드 DequanWang/tent 구조 참고)는 BN affine(γ,β)만 열고 라벨 없이 예측 entropy를 최소화한다(Adam, 1 epoch). 두 방법 모두 target label은 어떤 단계에서도 사용하지 않는다(source-free·label-free).</a:t>
             </a:r>
           </a:p>
         </p:txBody>
       </p:sp>
       <p:graphicFrame>
         <p:nvGraphicFramePr>
-          <p:cNvPr id="7" name="Table 6"/>
+          <p:cNvPr id="7" name="Table"/>
           <p:cNvGraphicFramePr>
             <a:graphicFrameLocks noGrp="1"/>
           </p:cNvGraphicFramePr>
           <p:nvPr/>
         </p:nvGraphicFramePr>
         <p:xfrm>
-          <a:off x="548640" y="1600200"/>
-          <a:ext cx="8961120" cy="3931920"/>
+          <a:off x="548640" y="2100000"/>
+          <a:ext cx="8961120" cy="2200000"/>
         </p:xfrm>
         <a:graphic>
           <a:graphicData uri="http://schemas.openxmlformats.org/drawingml/2006/table">
@@ -16843,7 +16810,7 @@
                 <a:gridCol w="1645920"/>
                 <a:gridCol w="1645920"/>
               </a:tblGrid>
-              <a:tr h="982980">
+              <a:tr h="550000">
                 <a:tc>
                   <a:txBody>
                     <a:bodyPr/>
@@ -16955,7 +16922,7 @@
                   </a:tcPr>
                 </a:tc>
               </a:tr>
-              <a:tr h="982980">
+              <a:tr h="550000">
                 <a:tc>
                   <a:txBody>
                     <a:bodyPr/>
@@ -17056,7 +17023,7 @@
                             <a:srgbClr val="1A1A1A"/>
                           </a:solidFill>
                         </a:rPr>
-                        <a:t>7.64%</a:t>
+                        <a:t>8.28%</a:t>
                       </a:r>
                     </a:p>
                   </a:txBody>
@@ -17067,7 +17034,7 @@
                   </a:tcPr>
                 </a:tc>
               </a:tr>
-              <a:tr h="982980">
+              <a:tr h="550000">
                 <a:tc>
                   <a:txBody>
                     <a:bodyPr/>
@@ -17168,7 +17135,7 @@
                             <a:srgbClr val="1A1A1A"/>
                           </a:solidFill>
                         </a:rPr>
-                        <a:t>9.17%</a:t>
+                        <a:t>8.63%</a:t>
                       </a:r>
                     </a:p>
                   </a:txBody>
@@ -17179,7 +17146,7 @@
                   </a:tcPr>
                 </a:tc>
               </a:tr>
-              <a:tr h="982980">
+              <a:tr h="550000">
                 <a:tc>
                   <a:txBody>
                     <a:bodyPr/>
@@ -17280,7 +17247,7 @@
                             <a:srgbClr val="1A1A1A"/>
                           </a:solidFill>
                         </a:rPr>
-                        <a:t>11.00%</a:t>
+                        <a:t>11.14%</a:t>
                       </a:r>
                     </a:p>
                   </a:txBody>
@@ -17295,6 +17262,76 @@
           </a:graphicData>
         </a:graphic>
       </p:graphicFrame>
+      <p:sp>
+        <p:nvSpPr>
+          <p:cNvPr id="6" name="TextBox 4"/>
+          <p:cNvSpPr txBox="1"/>
+          <p:nvPr/>
+        </p:nvSpPr>
+        <p:spPr>
+          <a:xfrm>
+            <a:off x="548640" y="4450000"/>
+            <a:ext cx="11091672" cy="1150000"/>
+          </a:xfrm>
+          <a:prstGeom prst="rect">
+            <a:avLst/>
+          </a:prstGeom>
+          <a:noFill/>
+        </p:spPr>
+        <p:txBody>
+          <a:bodyPr wrap="square" anchor="t" lIns="0" rIns="0" tIns="0" bIns="0">
+            <a:spAutoFit/>
+          </a:bodyPr>
+          <a:lstStyle/>
+          <a:p>
+            <a:pPr algn="l"/>
+            <a:r>
+              <a:rPr sz="1050" b="0" i="1">
+                <a:solidFill>
+                  <a:srgbClr val="5B5E6B"/>
+                </a:solidFill>
+                <a:latin typeface="Calibri"/>
+              </a:rPr>
+              <a:t>예측 분포 분석(prediction_distribution.csv) 결과, AdaBN/TENT 적용 후 예측이 target에 없는 클래스로 쏠렸다 — partial label-space mismatch(PADA/ETN 이론)로 인한 negative transfer다. 클래스 겹침이 적을수록(Taiwan 3/10) 저하가 더 컸다. 다음 슬라이드에서 이 문제를 해결하는 class-restriction 마스킹을 다룬다.</a:t>
+            </a:r>
+          </a:p>
+        </p:txBody>
+      </p:sp>
+      <p:sp>
+        <p:nvSpPr>
+          <p:cNvPr id="8" name="TextBox 5"/>
+          <p:cNvSpPr txBox="1"/>
+          <p:nvPr/>
+        </p:nvSpPr>
+        <p:spPr>
+          <a:xfrm>
+            <a:off x="11430000" y="6446520"/>
+            <a:ext cx="548640" cy="274320"/>
+          </a:xfrm>
+          <a:prstGeom prst="rect">
+            <a:avLst/>
+          </a:prstGeom>
+          <a:noFill/>
+        </p:spPr>
+        <p:txBody>
+          <a:bodyPr wrap="square" anchor="t" lIns="0" rIns="0" tIns="0" bIns="0">
+            <a:spAutoFit/>
+          </a:bodyPr>
+          <a:lstStyle/>
+          <a:p>
+            <a:pPr algn="r"/>
+            <a:r>
+              <a:rPr sz="1000" b="0" i="0">
+                <a:solidFill>
+                  <a:srgbClr val="5B5E6B"/>
+                </a:solidFill>
+                <a:latin typeface="Calibri"/>
+              </a:rPr>
+              <a:t>23</a:t>
+            </a:r>
+          </a:p>
+        </p:txBody>
+      </p:sp>
     </p:spTree>
   </p:cSld>
   <p:clrMapOvr>
@@ -18306,7 +18343,7 @@
                 </a:solidFill>
                 <a:latin typeface="Calibri"/>
               </a:rPr>
-              <a:t>24</a:t>
+              <a:t>26</a:t>
             </a:r>
           </a:p>
         </p:txBody>
@@ -18907,6 +18944,1432 @@
       <p:sp>
         <p:nvSpPr>
           <p:cNvPr id="16" name="TextBox 15"/>
+          <p:cNvSpPr txBox="1"/>
+          <p:nvPr/>
+        </p:nvSpPr>
+        <p:spPr>
+          <a:xfrm>
+            <a:off x="11430000" y="6446520"/>
+            <a:ext cx="548640" cy="274320"/>
+          </a:xfrm>
+          <a:prstGeom prst="rect">
+            <a:avLst/>
+          </a:prstGeom>
+          <a:noFill/>
+        </p:spPr>
+        <p:txBody>
+          <a:bodyPr wrap="square" anchor="t" lIns="0" rIns="0" tIns="0" bIns="0">
+            <a:spAutoFit/>
+          </a:bodyPr>
+          <a:lstStyle/>
+          <a:p>
+            <a:pPr algn="r"/>
+            <a:r>
+              <a:rPr sz="1000" b="0" i="0">
+                <a:solidFill>
+                  <a:srgbClr val="5B5E6B"/>
+                </a:solidFill>
+                <a:latin typeface="Calibri"/>
+              </a:rPr>
+              <a:t>27</a:t>
+            </a:r>
+          </a:p>
+        </p:txBody>
+      </p:sp>
+    </p:spTree>
+  </p:cSld>
+  <p:clrMapOvr>
+    <a:masterClrMapping/>
+  </p:clrMapOvr>
+</p:sld>
+</file>
+
+<file path=ppt/slides/slide27.xml><?xml version="1.0" encoding="utf-8"?>
+<p:sld xmlns:a="http://schemas.openxmlformats.org/drawingml/2006/main" xmlns:p="http://schemas.openxmlformats.org/presentationml/2006/main" xmlns:r="http://schemas.openxmlformats.org/officeDocument/2006/relationships">
+  <p:cSld>
+    <p:bg>
+      <p:bgPr>
+        <a:solidFill>
+          <a:srgbClr val="FFFFFF"/>
+        </a:solidFill>
+        <a:effectLst/>
+      </p:bgPr>
+    </p:bg>
+    <p:spTree>
+      <p:nvGrpSpPr>
+        <p:cNvPr id="1" name=""/>
+        <p:cNvGrpSpPr/>
+        <p:nvPr/>
+      </p:nvGrpSpPr>
+      <p:grpSpPr/>
+      <p:sp>
+        <p:nvSpPr>
+          <p:cNvPr id="2" name="TextBox 1"/>
+          <p:cNvSpPr txBox="1"/>
+          <p:nvPr/>
+        </p:nvSpPr>
+        <p:spPr>
+          <a:xfrm>
+            <a:off x="548640" y="292608"/>
+            <a:ext cx="9144000" cy="292608"/>
+          </a:xfrm>
+          <a:prstGeom prst="rect">
+            <a:avLst/>
+          </a:prstGeom>
+          <a:noFill/>
+        </p:spPr>
+        <p:txBody>
+          <a:bodyPr wrap="square" anchor="t" lIns="0" rIns="0" tIns="0" bIns="0">
+            <a:spAutoFit/>
+          </a:bodyPr>
+          <a:lstStyle/>
+          <a:p>
+            <a:pPr algn="l"/>
+            <a:r>
+              <a:rPr sz="1050" b="1" i="0">
+                <a:solidFill>
+                  <a:srgbClr val="2A78D6"/>
+                </a:solidFill>
+                <a:latin typeface="Calibri"/>
+              </a:rPr>
+              <a:t>RESULT 7 · DOMAIN ADAPTATION (2/3)</a:t>
+            </a:r>
+          </a:p>
+        </p:txBody>
+      </p:sp>
+      <p:sp>
+        <p:nvSpPr>
+          <p:cNvPr id="3" name="TextBox 2"/>
+          <p:cNvSpPr txBox="1"/>
+          <p:nvPr/>
+        </p:nvSpPr>
+        <p:spPr>
+          <a:xfrm>
+            <a:off x="548640" y="566928"/>
+            <a:ext cx="10972800" cy="548640"/>
+          </a:xfrm>
+          <a:prstGeom prst="rect">
+            <a:avLst/>
+          </a:prstGeom>
+          <a:noFill/>
+        </p:spPr>
+        <p:txBody>
+          <a:bodyPr wrap="square" anchor="t" lIns="0" rIns="0" tIns="0" bIns="0">
+            <a:spAutoFit/>
+          </a:bodyPr>
+          <a:lstStyle/>
+          <a:p>
+            <a:pPr algn="l"/>
+            <a:r>
+              <a:rPr sz="2400" b="1" i="0">
+                <a:solidFill>
+                  <a:srgbClr val="1E2761"/>
+                </a:solidFill>
+                <a:latin typeface="Cambria"/>
+              </a:rPr>
+              <a:t>Class-restriction 마스킹으로 해결 + 다음 시도</a:t>
+            </a:r>
+          </a:p>
+        </p:txBody>
+      </p:sp>
+      <p:sp>
+        <p:nvSpPr>
+          <p:cNvPr id="4" name="TextBox 3"/>
+          <p:cNvSpPr txBox="1"/>
+          <p:nvPr/>
+        </p:nvSpPr>
+        <p:spPr>
+          <a:xfrm>
+            <a:off x="548640" y="1250000"/>
+            <a:ext cx="11091672" cy="750000"/>
+          </a:xfrm>
+          <a:prstGeom prst="rect">
+            <a:avLst/>
+          </a:prstGeom>
+          <a:noFill/>
+        </p:spPr>
+        <p:txBody>
+          <a:bodyPr wrap="square" anchor="t" lIns="0" rIns="0" tIns="0" bIns="0">
+            <a:spAutoFit/>
+          </a:bodyPr>
+          <a:lstStyle/>
+          <a:p>
+            <a:pPr algn="l"/>
+            <a:r>
+              <a:rPr sz="1050" b="0" i="0">
+                <a:solidFill>
+                  <a:srgbClr val="1A1A1A"/>
+                </a:solidFill>
+                <a:latin typeface="Calibri"/>
+              </a:rPr>
+              <a:t>class_info.py에 설계 단계부터 있던 클래스 매핑으로 target에 없는 클래스의 로짓을 -inf 마스킹한다(추가 학습 없음, zero-cost). 모든 데이터셋에서 마스킹 단독만으로도 source-only보다 개선됐다.</a:t>
+            </a:r>
+          </a:p>
+        </p:txBody>
+      </p:sp>
+      <p:graphicFrame>
+        <p:nvGraphicFramePr>
+          <p:cNvPr id="7" name="Table"/>
+          <p:cNvGraphicFramePr>
+            <a:graphicFrameLocks noGrp="1"/>
+          </p:cNvGraphicFramePr>
+          <p:nvPr/>
+        </p:nvGraphicFramePr>
+        <p:xfrm>
+          <a:off x="548640" y="2100000"/>
+          <a:ext cx="10200000" cy="2100000"/>
+        </p:xfrm>
+        <a:graphic>
+          <a:graphicData uri="http://schemas.openxmlformats.org/drawingml/2006/table">
+            <a:tbl>
+              <a:tblPr firstRow="1" bandRow="1">
+                <a:tableStyleId>{5C22544A-7EE6-4342-B048-85BDC9FD1C3A}</a:tableStyleId>
+              </a:tblPr>
+              <a:tblGrid>
+                <a:gridCol w="1900000"/>
+                <a:gridCol w="1850000"/>
+                <a:gridCol w="1850000"/>
+                <a:gridCol w="2300000"/>
+                <a:gridCol w="2300000"/>
+              </a:tblGrid>
+              <a:tr h="525000">
+                <a:tc>
+                  <a:txBody>
+                    <a:bodyPr/>
+                    <a:lstStyle/>
+                    <a:p>
+                      <a:pPr algn="ctr"/>
+                      <a:r>
+                        <a:rPr sz="1050" b="1">
+                          <a:solidFill>
+                            <a:srgbClr val="FFFFFF"/>
+                          </a:solidFill>
+                        </a:rPr>
+                        <a:t>데이터셋</a:t>
+                      </a:r>
+                    </a:p>
+                  </a:txBody>
+                  <a:tcPr>
+                    <a:solidFill>
+                      <a:srgbClr val="1E2761"/>
+                    </a:solidFill>
+                  </a:tcPr>
+                </a:tc>
+                <a:tc>
+                  <a:txBody>
+                    <a:bodyPr/>
+                    <a:lstStyle/>
+                    <a:p>
+                      <a:pPr algn="ctr"/>
+                      <a:r>
+                        <a:rPr sz="1050" b="1">
+                          <a:solidFill>
+                            <a:srgbClr val="FFFFFF"/>
+                          </a:solidFill>
+                        </a:rPr>
+                        <a:t>Source-only</a:t>
+                      </a:r>
+                    </a:p>
+                  </a:txBody>
+                  <a:tcPr>
+                    <a:solidFill>
+                      <a:srgbClr val="1E2761"/>
+                    </a:solidFill>
+                  </a:tcPr>
+                </a:tc>
+                <a:tc>
+                  <a:txBody>
+                    <a:bodyPr/>
+                    <a:lstStyle/>
+                    <a:p>
+                      <a:pPr algn="ctr"/>
+                      <a:r>
+                        <a:rPr sz="1050" b="1">
+                          <a:solidFill>
+                            <a:srgbClr val="FFFFFF"/>
+                          </a:solidFill>
+                        </a:rPr>
+                        <a:t>+마스킹만</a:t>
+                      </a:r>
+                    </a:p>
+                  </a:txBody>
+                  <a:tcPr>
+                    <a:solidFill>
+                      <a:srgbClr val="1E2761"/>
+                    </a:solidFill>
+                  </a:tcPr>
+                </a:tc>
+                <a:tc>
+                  <a:txBody>
+                    <a:bodyPr/>
+                    <a:lstStyle/>
+                    <a:p>
+                      <a:pPr algn="ctr"/>
+                      <a:r>
+                        <a:rPr sz="1050" b="1">
+                          <a:solidFill>
+                            <a:srgbClr val="FFFFFF"/>
+                          </a:solidFill>
+                        </a:rPr>
+                        <a:t>AdaBN+마스킹</a:t>
+                      </a:r>
+                    </a:p>
+                  </a:txBody>
+                  <a:tcPr>
+                    <a:solidFill>
+                      <a:srgbClr val="1E2761"/>
+                    </a:solidFill>
+                  </a:tcPr>
+                </a:tc>
+                <a:tc>
+                  <a:txBody>
+                    <a:bodyPr/>
+                    <a:lstStyle/>
+                    <a:p>
+                      <a:pPr algn="ctr"/>
+                      <a:r>
+                        <a:rPr sz="1050" b="1">
+                          <a:solidFill>
+                            <a:srgbClr val="FFFFFF"/>
+                          </a:solidFill>
+                        </a:rPr>
+                        <a:t>TENT+마스킹</a:t>
+                      </a:r>
+                    </a:p>
+                  </a:txBody>
+                  <a:tcPr>
+                    <a:solidFill>
+                      <a:srgbClr val="1E2761"/>
+                    </a:solidFill>
+                  </a:tcPr>
+                </a:tc>
+              </a:tr>
+              <a:tr h="525000">
+                <a:tc>
+                  <a:txBody>
+                    <a:bodyPr/>
+                    <a:lstStyle/>
+                    <a:p>
+                      <a:pPr algn="ctr"/>
+                      <a:r>
+                        <a:rPr sz="1050" b="0">
+                          <a:solidFill>
+                            <a:srgbClr val="1A1A1A"/>
+                          </a:solidFill>
+                        </a:rPr>
+                        <a:t>Taiwan</a:t>
+                      </a:r>
+                    </a:p>
+                  </a:txBody>
+                  <a:tcPr>
+                    <a:solidFill>
+                      <a:srgbClr val="FFFFFF"/>
+                    </a:solidFill>
+                  </a:tcPr>
+                </a:tc>
+                <a:tc>
+                  <a:txBody>
+                    <a:bodyPr/>
+                    <a:lstStyle/>
+                    <a:p>
+                      <a:pPr algn="ctr"/>
+                      <a:r>
+                        <a:rPr sz="1050" b="0">
+                          <a:solidFill>
+                            <a:srgbClr val="1A1A1A"/>
+                          </a:solidFill>
+                        </a:rPr>
+                        <a:t>27.39%</a:t>
+                      </a:r>
+                    </a:p>
+                  </a:txBody>
+                  <a:tcPr>
+                    <a:solidFill>
+                      <a:srgbClr val="FFFFFF"/>
+                    </a:solidFill>
+                  </a:tcPr>
+                </a:tc>
+                <a:tc>
+                  <a:txBody>
+                    <a:bodyPr/>
+                    <a:lstStyle/>
+                    <a:p>
+                      <a:pPr algn="ctr"/>
+                      <a:r>
+                        <a:rPr sz="1050" b="0">
+                          <a:solidFill>
+                            <a:srgbClr val="1A1A1A"/>
+                          </a:solidFill>
+                        </a:rPr>
+                        <a:t>32.48%</a:t>
+                      </a:r>
+                    </a:p>
+                  </a:txBody>
+                  <a:tcPr>
+                    <a:solidFill>
+                      <a:srgbClr val="FFFFFF"/>
+                    </a:solidFill>
+                  </a:tcPr>
+                </a:tc>
+                <a:tc>
+                  <a:txBody>
+                    <a:bodyPr/>
+                    <a:lstStyle/>
+                    <a:p>
+                      <a:pPr algn="ctr"/>
+                      <a:r>
+                        <a:rPr sz="1050" b="1">
+                          <a:solidFill>
+                            <a:srgbClr val="1A1A1A"/>
+                          </a:solidFill>
+                        </a:rPr>
+                        <a:t>38.85%</a:t>
+                      </a:r>
+                    </a:p>
+                  </a:txBody>
+                  <a:tcPr>
+                    <a:solidFill>
+                      <a:srgbClr val="FFFFFF"/>
+                    </a:solidFill>
+                  </a:tcPr>
+                </a:tc>
+                <a:tc>
+                  <a:txBody>
+                    <a:bodyPr/>
+                    <a:lstStyle/>
+                    <a:p>
+                      <a:pPr algn="ctr"/>
+                      <a:r>
+                        <a:rPr sz="1050" b="0">
+                          <a:solidFill>
+                            <a:srgbClr val="1A1A1A"/>
+                          </a:solidFill>
+                        </a:rPr>
+                        <a:t>30.25%</a:t>
+                      </a:r>
+                    </a:p>
+                  </a:txBody>
+                  <a:tcPr>
+                    <a:solidFill>
+                      <a:srgbClr val="FFFFFF"/>
+                    </a:solidFill>
+                  </a:tcPr>
+                </a:tc>
+              </a:tr>
+              <a:tr h="525000">
+                <a:tc>
+                  <a:txBody>
+                    <a:bodyPr/>
+                    <a:lstStyle/>
+                    <a:p>
+                      <a:pPr algn="ctr"/>
+                      <a:r>
+                        <a:rPr sz="1050" b="0">
+                          <a:solidFill>
+                            <a:srgbClr val="1A1A1A"/>
+                          </a:solidFill>
+                        </a:rPr>
+                        <a:t>Bangladesh</a:t>
+                      </a:r>
+                    </a:p>
+                  </a:txBody>
+                  <a:tcPr>
+                    <a:solidFill>
+                      <a:srgbClr val="EEF3FC"/>
+                    </a:solidFill>
+                  </a:tcPr>
+                </a:tc>
+                <a:tc>
+                  <a:txBody>
+                    <a:bodyPr/>
+                    <a:lstStyle/>
+                    <a:p>
+                      <a:pPr algn="ctr"/>
+                      <a:r>
+                        <a:rPr sz="1050" b="0">
+                          <a:solidFill>
+                            <a:srgbClr val="1A1A1A"/>
+                          </a:solidFill>
+                        </a:rPr>
+                        <a:t>21.80%</a:t>
+                      </a:r>
+                    </a:p>
+                  </a:txBody>
+                  <a:tcPr>
+                    <a:solidFill>
+                      <a:srgbClr val="EEF3FC"/>
+                    </a:solidFill>
+                  </a:tcPr>
+                </a:tc>
+                <a:tc>
+                  <a:txBody>
+                    <a:bodyPr/>
+                    <a:lstStyle/>
+                    <a:p>
+                      <a:pPr algn="ctr"/>
+                      <a:r>
+                        <a:rPr sz="1050" b="1">
+                          <a:solidFill>
+                            <a:srgbClr val="1A1A1A"/>
+                          </a:solidFill>
+                        </a:rPr>
+                        <a:t>22.34%</a:t>
+                      </a:r>
+                    </a:p>
+                  </a:txBody>
+                  <a:tcPr>
+                    <a:solidFill>
+                      <a:srgbClr val="EEF3FC"/>
+                    </a:solidFill>
+                  </a:tcPr>
+                </a:tc>
+                <a:tc>
+                  <a:txBody>
+                    <a:bodyPr/>
+                    <a:lstStyle/>
+                    <a:p>
+                      <a:pPr algn="ctr"/>
+                      <a:r>
+                        <a:rPr sz="1050" b="0">
+                          <a:solidFill>
+                            <a:srgbClr val="1A1A1A"/>
+                          </a:solidFill>
+                        </a:rPr>
+                        <a:t>15.71%</a:t>
+                      </a:r>
+                    </a:p>
+                  </a:txBody>
+                  <a:tcPr>
+                    <a:solidFill>
+                      <a:srgbClr val="EEF3FC"/>
+                    </a:solidFill>
+                  </a:tcPr>
+                </a:tc>
+                <a:tc>
+                  <a:txBody>
+                    <a:bodyPr/>
+                    <a:lstStyle/>
+                    <a:p>
+                      <a:pPr algn="ctr"/>
+                      <a:r>
+                        <a:rPr sz="1050" b="0">
+                          <a:solidFill>
+                            <a:srgbClr val="1A1A1A"/>
+                          </a:solidFill>
+                        </a:rPr>
+                        <a:t>14.71%</a:t>
+                      </a:r>
+                    </a:p>
+                  </a:txBody>
+                  <a:tcPr>
+                    <a:solidFill>
+                      <a:srgbClr val="EEF3FC"/>
+                    </a:solidFill>
+                  </a:tcPr>
+                </a:tc>
+              </a:tr>
+              <a:tr h="525000">
+                <a:tc>
+                  <a:txBody>
+                    <a:bodyPr/>
+                    <a:lstStyle/>
+                    <a:p>
+                      <a:pPr algn="ctr"/>
+                      <a:r>
+                        <a:rPr sz="1050" b="0">
+                          <a:solidFill>
+                            <a:srgbClr val="1A1A1A"/>
+                          </a:solidFill>
+                        </a:rPr>
+                        <a:t>PlantDoc</a:t>
+                      </a:r>
+                    </a:p>
+                  </a:txBody>
+                  <a:tcPr>
+                    <a:solidFill>
+                      <a:srgbClr val="FFFFFF"/>
+                    </a:solidFill>
+                  </a:tcPr>
+                </a:tc>
+                <a:tc>
+                  <a:txBody>
+                    <a:bodyPr/>
+                    <a:lstStyle/>
+                    <a:p>
+                      <a:pPr algn="ctr"/>
+                      <a:r>
+                        <a:rPr sz="1050" b="0">
+                          <a:solidFill>
+                            <a:srgbClr val="1A1A1A"/>
+                          </a:solidFill>
+                        </a:rPr>
+                        <a:t>19.89%</a:t>
+                      </a:r>
+                    </a:p>
+                  </a:txBody>
+                  <a:tcPr>
+                    <a:solidFill>
+                      <a:srgbClr val="FFFFFF"/>
+                    </a:solidFill>
+                  </a:tcPr>
+                </a:tc>
+                <a:tc>
+                  <a:txBody>
+                    <a:bodyPr/>
+                    <a:lstStyle/>
+                    <a:p>
+                      <a:pPr algn="ctr"/>
+                      <a:r>
+                        <a:rPr sz="1050" b="1">
+                          <a:solidFill>
+                            <a:srgbClr val="1A1A1A"/>
+                          </a:solidFill>
+                        </a:rPr>
+                        <a:t>20.31%</a:t>
+                      </a:r>
+                    </a:p>
+                  </a:txBody>
+                  <a:tcPr>
+                    <a:solidFill>
+                      <a:srgbClr val="FFFFFF"/>
+                    </a:solidFill>
+                  </a:tcPr>
+                </a:tc>
+                <a:tc>
+                  <a:txBody>
+                    <a:bodyPr/>
+                    <a:lstStyle/>
+                    <a:p>
+                      <a:pPr algn="ctr"/>
+                      <a:r>
+                        <a:rPr sz="1050" b="0">
+                          <a:solidFill>
+                            <a:srgbClr val="1A1A1A"/>
+                          </a:solidFill>
+                        </a:rPr>
+                        <a:t>14.81%</a:t>
+                      </a:r>
+                    </a:p>
+                  </a:txBody>
+                  <a:tcPr>
+                    <a:solidFill>
+                      <a:srgbClr val="FFFFFF"/>
+                    </a:solidFill>
+                  </a:tcPr>
+                </a:tc>
+                <a:tc>
+                  <a:txBody>
+                    <a:bodyPr/>
+                    <a:lstStyle/>
+                    <a:p>
+                      <a:pPr algn="ctr"/>
+                      <a:r>
+                        <a:rPr sz="1050" b="0">
+                          <a:solidFill>
+                            <a:srgbClr val="1A1A1A"/>
+                          </a:solidFill>
+                        </a:rPr>
+                        <a:t>12.41%</a:t>
+                      </a:r>
+                    </a:p>
+                  </a:txBody>
+                  <a:tcPr>
+                    <a:solidFill>
+                      <a:srgbClr val="FFFFFF"/>
+                    </a:solidFill>
+                  </a:tcPr>
+                </a:tc>
+              </a:tr>
+            </a:tbl>
+          </a:graphicData>
+        </a:graphic>
+      </p:graphicFrame>
+      <p:sp>
+        <p:nvSpPr>
+          <p:cNvPr id="6" name="TextBox 4"/>
+          <p:cNvSpPr txBox="1"/>
+          <p:nvPr/>
+        </p:nvSpPr>
+        <p:spPr>
+          <a:xfrm>
+            <a:off x="548640" y="4400000"/>
+            <a:ext cx="11091672" cy="900000"/>
+          </a:xfrm>
+          <a:prstGeom prst="rect">
+            <a:avLst/>
+          </a:prstGeom>
+          <a:noFill/>
+        </p:spPr>
+        <p:txBody>
+          <a:bodyPr wrap="square" anchor="t" lIns="0" rIns="0" tIns="0" bIns="0">
+            <a:spAutoFit/>
+          </a:bodyPr>
+          <a:lstStyle/>
+          <a:p>
+            <a:pPr algn="l"/>
+            <a:r>
+              <a:rPr sz="1050" b="0" i="1">
+                <a:solidFill>
+                  <a:srgbClr val="5B5E6B"/>
+                </a:solidFill>
+                <a:latin typeface="Calibri"/>
+              </a:rPr>
+              <a:t>클래스 3개뿐인 Taiwan은 AdaBN+마스킹이 최고다(38.85%, source 대비 +11.5%p) — BN 통계 교체의 부작용이 작기 때문. 반면 클래스가 많고 불균형한 Bangladesh(6개)·PlantDoc(8개)은 AdaBN/TENT가 마스킹과 결합해도 마스킹 단독보다 나쁘다 — BN 통계 전체 교체 자체가 여전히 해롭다는 뜻이다.</a:t>
+            </a:r>
+          </a:p>
+        </p:txBody>
+      </p:sp>
+      <p:sp>
+        <p:nvSpPr>
+          <p:cNvPr id="9" name="TextBox 4"/>
+          <p:cNvSpPr txBox="1"/>
+          <p:nvPr/>
+        </p:nvSpPr>
+        <p:spPr>
+          <a:xfrm>
+            <a:off x="548640" y="5400000"/>
+            <a:ext cx="11091672" cy="850000"/>
+          </a:xfrm>
+          <a:prstGeom prst="rect">
+            <a:avLst/>
+          </a:prstGeom>
+          <a:noFill/>
+        </p:spPr>
+        <p:txBody>
+          <a:bodyPr wrap="square" anchor="t" lIns="0" rIns="0" tIns="0" bIns="0">
+            <a:spAutoFit/>
+          </a:bodyPr>
+          <a:lstStyle/>
+          <a:p>
+            <a:pPr algn="l"/>
+            <a:r>
+              <a:rPr sz="1050" b="0" i="1">
+                <a:solidFill>
+                  <a:srgbClr val="5B5E6B"/>
+                </a:solidFill>
+                <a:latin typeface="Calibri"/>
+              </a:rPr>
+              <a:t>다음 시도: ① 마스킹을 적응 과정(entropy loss·BN 통계 계산) 자체에 반영하는 mask-aware adaptation  ② AdaBN 통계 완전 교체 대신 source/target 블렌딩으로 부작용 완화  ③ seed42 단일 결과 → 3-seed 통계 검증  ④ 개선이 제한적이면 보류했던 SHOT(마스킹된 라벨 공간 내 pseudo-labeling) 재검토</a:t>
+            </a:r>
+          </a:p>
+        </p:txBody>
+      </p:sp>
+      <p:sp>
+        <p:nvSpPr>
+          <p:cNvPr id="8" name="TextBox 5"/>
+          <p:cNvSpPr txBox="1"/>
+          <p:nvPr/>
+        </p:nvSpPr>
+        <p:spPr>
+          <a:xfrm>
+            <a:off x="11430000" y="6446520"/>
+            <a:ext cx="548640" cy="274320"/>
+          </a:xfrm>
+          <a:prstGeom prst="rect">
+            <a:avLst/>
+          </a:prstGeom>
+          <a:noFill/>
+        </p:spPr>
+        <p:txBody>
+          <a:bodyPr wrap="square" anchor="t" lIns="0" rIns="0" tIns="0" bIns="0">
+            <a:spAutoFit/>
+          </a:bodyPr>
+          <a:lstStyle/>
+          <a:p>
+            <a:pPr algn="r"/>
+            <a:r>
+              <a:rPr sz="1000" b="0" i="0">
+                <a:solidFill>
+                  <a:srgbClr val="5B5E6B"/>
+                </a:solidFill>
+                <a:latin typeface="Calibri"/>
+              </a:rPr>
+              <a:t>24</a:t>
+            </a:r>
+          </a:p>
+        </p:txBody>
+      </p:sp>
+    </p:spTree>
+  </p:cSld>
+  <p:clrMapOvr>
+    <a:masterClrMapping/>
+  </p:clrMapOvr>
+</p:sld>
+</file>
+
+<file path=ppt/slides/slide28.xml><?xml version="1.0" encoding="utf-8"?>
+<p:sld xmlns:a="http://schemas.openxmlformats.org/drawingml/2006/main" xmlns:p="http://schemas.openxmlformats.org/presentationml/2006/main" xmlns:r="http://schemas.openxmlformats.org/officeDocument/2006/relationships">
+  <p:cSld>
+    <p:bg>
+      <p:bgPr>
+        <a:solidFill>
+          <a:srgbClr val="FFFFFF"/>
+        </a:solidFill>
+        <a:effectLst/>
+      </p:bgPr>
+    </p:bg>
+    <p:spTree>
+      <p:nvGrpSpPr>
+        <p:cNvPr id="1" name=""/>
+        <p:cNvGrpSpPr/>
+        <p:nvPr/>
+      </p:nvGrpSpPr>
+      <p:grpSpPr/>
+      <p:sp>
+        <p:nvSpPr>
+          <p:cNvPr id="2" name="TextBox 1"/>
+          <p:cNvSpPr txBox="1"/>
+          <p:nvPr/>
+        </p:nvSpPr>
+        <p:spPr>
+          <a:xfrm>
+            <a:off x="548640" y="292608"/>
+            <a:ext cx="9144000" cy="292608"/>
+          </a:xfrm>
+          <a:prstGeom prst="rect">
+            <a:avLst/>
+          </a:prstGeom>
+          <a:noFill/>
+        </p:spPr>
+        <p:txBody>
+          <a:bodyPr wrap="square" anchor="t" lIns="0" rIns="0" tIns="0" bIns="0">
+            <a:spAutoFit/>
+          </a:bodyPr>
+          <a:lstStyle/>
+          <a:p>
+            <a:pPr algn="l"/>
+            <a:r>
+              <a:rPr sz="1050" b="1" i="0">
+                <a:solidFill>
+                  <a:srgbClr val="2A78D6"/>
+                </a:solidFill>
+                <a:latin typeface="Calibri"/>
+              </a:rPr>
+              <a:t>RESULT 7 · DOMAIN ADAPTATION (3/3)</a:t>
+            </a:r>
+          </a:p>
+        </p:txBody>
+      </p:sp>
+      <p:sp>
+        <p:nvSpPr>
+          <p:cNvPr id="3" name="TextBox 2"/>
+          <p:cNvSpPr txBox="1"/>
+          <p:nvPr/>
+        </p:nvSpPr>
+        <p:spPr>
+          <a:xfrm>
+            <a:off x="548640" y="566928"/>
+            <a:ext cx="10972800" cy="548640"/>
+          </a:xfrm>
+          <a:prstGeom prst="rect">
+            <a:avLst/>
+          </a:prstGeom>
+          <a:noFill/>
+        </p:spPr>
+        <p:txBody>
+          <a:bodyPr wrap="square" anchor="t" lIns="0" rIns="0" tIns="0" bIns="0">
+            <a:spAutoFit/>
+          </a:bodyPr>
+          <a:lstStyle/>
+          <a:p>
+            <a:pPr algn="l"/>
+            <a:r>
+              <a:rPr sz="2400" b="1" i="0">
+                <a:solidFill>
+                  <a:srgbClr val="1E2761"/>
+                </a:solidFill>
+                <a:latin typeface="Cambria"/>
+              </a:rPr>
+              <a:t>다음 시도 3가지 — SHOT이 최종 승자</a:t>
+            </a:r>
+          </a:p>
+        </p:txBody>
+      </p:sp>
+      <p:sp>
+        <p:nvSpPr>
+          <p:cNvPr id="4" name="TextBox 3"/>
+          <p:cNvSpPr txBox="1"/>
+          <p:nvPr/>
+        </p:nvSpPr>
+        <p:spPr>
+          <a:xfrm>
+            <a:off x="548640" y="1250000"/>
+            <a:ext cx="11091672" cy="750000"/>
+          </a:xfrm>
+          <a:prstGeom prst="rect">
+            <a:avLst/>
+          </a:prstGeom>
+          <a:noFill/>
+        </p:spPr>
+        <p:txBody>
+          <a:bodyPr wrap="square" anchor="t" lIns="0" rIns="0" tIns="0" bIns="0">
+            <a:spAutoFit/>
+          </a:bodyPr>
+          <a:lstStyle/>
+          <a:p>
+            <a:pPr algn="l"/>
+            <a:r>
+              <a:rPr sz="1050" b="0" i="0">
+                <a:solidFill>
+                  <a:srgbClr val="1A1A1A"/>
+                </a:solidFill>
+                <a:latin typeface="Calibri"/>
+              </a:rPr>
+              <a:t>① TENT에 batch-diversity 정규화 추가(collapse 방지) ② AdaBN을 완전 교체 대신 momentum 블렌딩(0.05~0.3) ③ SHOT(Liang et al., ICML 2020) — pseudo-labeling+information-maximization으로 classifier는 고정하고 feature extractor 전체를 미세조정. 셋 다 class-restriction 마스킹과 결합해 비교했다.</a:t>
+            </a:r>
+          </a:p>
+        </p:txBody>
+      </p:sp>
+      <p:graphicFrame>
+        <p:nvGraphicFramePr>
+          <p:cNvPr id="7" name="Table"/>
+          <p:cNvGraphicFramePr>
+            <a:graphicFrameLocks noGrp="1"/>
+          </p:cNvGraphicFramePr>
+          <p:nvPr/>
+        </p:nvGraphicFramePr>
+        <p:xfrm>
+          <a:off x="548640" y="2100000"/>
+          <a:ext cx="10950000" cy="2100000"/>
+        </p:xfrm>
+        <a:graphic>
+          <a:graphicData uri="http://schemas.openxmlformats.org/drawingml/2006/table">
+            <a:tbl>
+              <a:tblPr firstRow="1" bandRow="1">
+                <a:tableStyleId>{5C22544A-7EE6-4342-B048-85BDC9FD1C3A}</a:tableStyleId>
+              </a:tblPr>
+              <a:tblGrid>
+                <a:gridCol w="1900000"/>
+                <a:gridCol w="2100000"/>
+                <a:gridCol w="2100000"/>
+                <a:gridCol w="2550000"/>
+                <a:gridCol w="2300000"/>
+              </a:tblGrid>
+              <a:tr h="525000">
+                <a:tc>
+                  <a:txBody>
+                    <a:bodyPr/>
+                    <a:lstStyle/>
+                    <a:p>
+                      <a:pPr algn="ctr"/>
+                      <a:r>
+                        <a:rPr sz="1050" b="1">
+                          <a:solidFill>
+                            <a:srgbClr val="FFFFFF"/>
+                          </a:solidFill>
+                        </a:rPr>
+                        <a:t>데이터셋</a:t>
+                      </a:r>
+                    </a:p>
+                  </a:txBody>
+                  <a:tcPr>
+                    <a:solidFill>
+                      <a:srgbClr val="1E2761"/>
+                    </a:solidFill>
+                  </a:tcPr>
+                </a:tc>
+                <a:tc>
+                  <a:txBody>
+                    <a:bodyPr/>
+                    <a:lstStyle/>
+                    <a:p>
+                      <a:pPr algn="ctr"/>
+                      <a:r>
+                        <a:rPr sz="1050" b="1">
+                          <a:solidFill>
+                            <a:srgbClr val="FFFFFF"/>
+                          </a:solidFill>
+                        </a:rPr>
+                        <a:t>Source+마스킹</a:t>
+                      </a:r>
+                    </a:p>
+                  </a:txBody>
+                  <a:tcPr>
+                    <a:solidFill>
+                      <a:srgbClr val="1E2761"/>
+                    </a:solidFill>
+                  </a:tcPr>
+                </a:tc>
+                <a:tc>
+                  <a:txBody>
+                    <a:bodyPr/>
+                    <a:lstStyle/>
+                    <a:p>
+                      <a:pPr algn="ctr"/>
+                      <a:r>
+                        <a:rPr sz="1050" b="1">
+                          <a:solidFill>
+                            <a:srgbClr val="FFFFFF"/>
+                          </a:solidFill>
+                        </a:rPr>
+                        <a:t>AdaBN+마스킹</a:t>
+                      </a:r>
+                    </a:p>
+                  </a:txBody>
+                  <a:tcPr>
+                    <a:solidFill>
+                      <a:srgbClr val="1E2761"/>
+                    </a:solidFill>
+                  </a:tcPr>
+                </a:tc>
+                <a:tc>
+                  <a:txBody>
+                    <a:bodyPr/>
+                    <a:lstStyle/>
+                    <a:p>
+                      <a:pPr algn="ctr"/>
+                      <a:r>
+                        <a:rPr sz="1050" b="1">
+                          <a:solidFill>
+                            <a:srgbClr val="FFFFFF"/>
+                          </a:solidFill>
+                        </a:rPr>
+                        <a:t>TENT+마스킹(수정판)</a:t>
+                      </a:r>
+                    </a:p>
+                  </a:txBody>
+                  <a:tcPr>
+                    <a:solidFill>
+                      <a:srgbClr val="1E2761"/>
+                    </a:solidFill>
+                  </a:tcPr>
+                </a:tc>
+                <a:tc>
+                  <a:txBody>
+                    <a:bodyPr/>
+                    <a:lstStyle/>
+                    <a:p>
+                      <a:pPr algn="ctr"/>
+                      <a:r>
+                        <a:rPr sz="1050" b="1">
+                          <a:solidFill>
+                            <a:srgbClr val="FFFFFF"/>
+                          </a:solidFill>
+                        </a:rPr>
+                        <a:t>SHOT+마스킹</a:t>
+                      </a:r>
+                    </a:p>
+                  </a:txBody>
+                  <a:tcPr>
+                    <a:solidFill>
+                      <a:srgbClr val="1E2761"/>
+                    </a:solidFill>
+                  </a:tcPr>
+                </a:tc>
+              </a:tr>
+              <a:tr h="525000">
+                <a:tc>
+                  <a:txBody>
+                    <a:bodyPr/>
+                    <a:lstStyle/>
+                    <a:p>
+                      <a:pPr algn="ctr"/>
+                      <a:r>
+                        <a:rPr sz="1050" b="0">
+                          <a:solidFill>
+                            <a:srgbClr val="1A1A1A"/>
+                          </a:solidFill>
+                        </a:rPr>
+                        <a:t>Taiwan</a:t>
+                      </a:r>
+                    </a:p>
+                  </a:txBody>
+                  <a:tcPr>
+                    <a:solidFill>
+                      <a:srgbClr val="FFFFFF"/>
+                    </a:solidFill>
+                  </a:tcPr>
+                </a:tc>
+                <a:tc>
+                  <a:txBody>
+                    <a:bodyPr/>
+                    <a:lstStyle/>
+                    <a:p>
+                      <a:pPr algn="ctr"/>
+                      <a:r>
+                        <a:rPr sz="1050" b="0">
+                          <a:solidFill>
+                            <a:srgbClr val="1A1A1A"/>
+                          </a:solidFill>
+                        </a:rPr>
+                        <a:t>32.48%</a:t>
+                      </a:r>
+                    </a:p>
+                  </a:txBody>
+                  <a:tcPr>
+                    <a:solidFill>
+                      <a:srgbClr val="FFFFFF"/>
+                    </a:solidFill>
+                  </a:tcPr>
+                </a:tc>
+                <a:tc>
+                  <a:txBody>
+                    <a:bodyPr/>
+                    <a:lstStyle/>
+                    <a:p>
+                      <a:pPr algn="ctr"/>
+                      <a:r>
+                        <a:rPr sz="1050" b="1">
+                          <a:solidFill>
+                            <a:srgbClr val="1A1A1A"/>
+                          </a:solidFill>
+                        </a:rPr>
+                        <a:t>38.85%</a:t>
+                      </a:r>
+                    </a:p>
+                  </a:txBody>
+                  <a:tcPr>
+                    <a:solidFill>
+                      <a:srgbClr val="FFFFFF"/>
+                    </a:solidFill>
+                  </a:tcPr>
+                </a:tc>
+                <a:tc>
+                  <a:txBody>
+                    <a:bodyPr/>
+                    <a:lstStyle/>
+                    <a:p>
+                      <a:pPr algn="ctr"/>
+                      <a:r>
+                        <a:rPr sz="1050" b="0">
+                          <a:solidFill>
+                            <a:srgbClr val="1A1A1A"/>
+                          </a:solidFill>
+                        </a:rPr>
+                        <a:t>29.94%</a:t>
+                      </a:r>
+                    </a:p>
+                  </a:txBody>
+                  <a:tcPr>
+                    <a:solidFill>
+                      <a:srgbClr val="FFFFFF"/>
+                    </a:solidFill>
+                  </a:tcPr>
+                </a:tc>
+                <a:tc>
+                  <a:txBody>
+                    <a:bodyPr/>
+                    <a:lstStyle/>
+                    <a:p>
+                      <a:pPr algn="ctr"/>
+                      <a:r>
+                        <a:rPr sz="1050" b="0">
+                          <a:solidFill>
+                            <a:srgbClr val="1A1A1A"/>
+                          </a:solidFill>
+                        </a:rPr>
+                        <a:t>38.54%</a:t>
+                      </a:r>
+                    </a:p>
+                  </a:txBody>
+                  <a:tcPr>
+                    <a:solidFill>
+                      <a:srgbClr val="FFFFFF"/>
+                    </a:solidFill>
+                  </a:tcPr>
+                </a:tc>
+              </a:tr>
+              <a:tr h="525000">
+                <a:tc>
+                  <a:txBody>
+                    <a:bodyPr/>
+                    <a:lstStyle/>
+                    <a:p>
+                      <a:pPr algn="ctr"/>
+                      <a:r>
+                        <a:rPr sz="1050" b="0">
+                          <a:solidFill>
+                            <a:srgbClr val="1A1A1A"/>
+                          </a:solidFill>
+                        </a:rPr>
+                        <a:t>Bangladesh</a:t>
+                      </a:r>
+                    </a:p>
+                  </a:txBody>
+                  <a:tcPr>
+                    <a:solidFill>
+                      <a:srgbClr val="EEF3FC"/>
+                    </a:solidFill>
+                  </a:tcPr>
+                </a:tc>
+                <a:tc>
+                  <a:txBody>
+                    <a:bodyPr/>
+                    <a:lstStyle/>
+                    <a:p>
+                      <a:pPr algn="ctr"/>
+                      <a:r>
+                        <a:rPr sz="1050" b="0">
+                          <a:solidFill>
+                            <a:srgbClr val="1A1A1A"/>
+                          </a:solidFill>
+                        </a:rPr>
+                        <a:t>22.34%</a:t>
+                      </a:r>
+                    </a:p>
+                  </a:txBody>
+                  <a:tcPr>
+                    <a:solidFill>
+                      <a:srgbClr val="EEF3FC"/>
+                    </a:solidFill>
+                  </a:tcPr>
+                </a:tc>
+                <a:tc>
+                  <a:txBody>
+                    <a:bodyPr/>
+                    <a:lstStyle/>
+                    <a:p>
+                      <a:pPr algn="ctr"/>
+                      <a:r>
+                        <a:rPr sz="1050" b="0">
+                          <a:solidFill>
+                            <a:srgbClr val="1A1A1A"/>
+                          </a:solidFill>
+                        </a:rPr>
+                        <a:t>15.71%</a:t>
+                      </a:r>
+                    </a:p>
+                  </a:txBody>
+                  <a:tcPr>
+                    <a:solidFill>
+                      <a:srgbClr val="EEF3FC"/>
+                    </a:solidFill>
+                  </a:tcPr>
+                </a:tc>
+                <a:tc>
+                  <a:txBody>
+                    <a:bodyPr/>
+                    <a:lstStyle/>
+                    <a:p>
+                      <a:pPr algn="ctr"/>
+                      <a:r>
+                        <a:rPr sz="1050" b="0">
+                          <a:solidFill>
+                            <a:srgbClr val="1A1A1A"/>
+                          </a:solidFill>
+                        </a:rPr>
+                        <a:t>13.71%</a:t>
+                      </a:r>
+                    </a:p>
+                  </a:txBody>
+                  <a:tcPr>
+                    <a:solidFill>
+                      <a:srgbClr val="EEF3FC"/>
+                    </a:solidFill>
+                  </a:tcPr>
+                </a:tc>
+                <a:tc>
+                  <a:txBody>
+                    <a:bodyPr/>
+                    <a:lstStyle/>
+                    <a:p>
+                      <a:pPr algn="ctr"/>
+                      <a:r>
+                        <a:rPr sz="1050" b="1">
+                          <a:solidFill>
+                            <a:srgbClr val="1A1A1A"/>
+                          </a:solidFill>
+                        </a:rPr>
+                        <a:t>27.97%</a:t>
+                      </a:r>
+                    </a:p>
+                  </a:txBody>
+                  <a:tcPr>
+                    <a:solidFill>
+                      <a:srgbClr val="EEF3FC"/>
+                    </a:solidFill>
+                  </a:tcPr>
+                </a:tc>
+              </a:tr>
+              <a:tr h="525000">
+                <a:tc>
+                  <a:txBody>
+                    <a:bodyPr/>
+                    <a:lstStyle/>
+                    <a:p>
+                      <a:pPr algn="ctr"/>
+                      <a:r>
+                        <a:rPr sz="1050" b="0">
+                          <a:solidFill>
+                            <a:srgbClr val="1A1A1A"/>
+                          </a:solidFill>
+                        </a:rPr>
+                        <a:t>PlantDoc</a:t>
+                      </a:r>
+                    </a:p>
+                  </a:txBody>
+                  <a:tcPr>
+                    <a:solidFill>
+                      <a:srgbClr val="FFFFFF"/>
+                    </a:solidFill>
+                  </a:tcPr>
+                </a:tc>
+                <a:tc>
+                  <a:txBody>
+                    <a:bodyPr/>
+                    <a:lstStyle/>
+                    <a:p>
+                      <a:pPr algn="ctr"/>
+                      <a:r>
+                        <a:rPr sz="1050" b="1">
+                          <a:solidFill>
+                            <a:srgbClr val="1A1A1A"/>
+                          </a:solidFill>
+                        </a:rPr>
+                        <a:t>20.31%</a:t>
+                      </a:r>
+                    </a:p>
+                  </a:txBody>
+                  <a:tcPr>
+                    <a:solidFill>
+                      <a:srgbClr val="FFFFFF"/>
+                    </a:solidFill>
+                  </a:tcPr>
+                </a:tc>
+                <a:tc>
+                  <a:txBody>
+                    <a:bodyPr/>
+                    <a:lstStyle/>
+                    <a:p>
+                      <a:pPr algn="ctr"/>
+                      <a:r>
+                        <a:rPr sz="1050" b="0">
+                          <a:solidFill>
+                            <a:srgbClr val="1A1A1A"/>
+                          </a:solidFill>
+                        </a:rPr>
+                        <a:t>14.81%</a:t>
+                      </a:r>
+                    </a:p>
+                  </a:txBody>
+                  <a:tcPr>
+                    <a:solidFill>
+                      <a:srgbClr val="FFFFFF"/>
+                    </a:solidFill>
+                  </a:tcPr>
+                </a:tc>
+                <a:tc>
+                  <a:txBody>
+                    <a:bodyPr/>
+                    <a:lstStyle/>
+                    <a:p>
+                      <a:pPr algn="ctr"/>
+                      <a:r>
+                        <a:rPr sz="1050" b="0">
+                          <a:solidFill>
+                            <a:srgbClr val="1A1A1A"/>
+                          </a:solidFill>
+                        </a:rPr>
+                        <a:t>12.83%</a:t>
+                      </a:r>
+                    </a:p>
+                  </a:txBody>
+                  <a:tcPr>
+                    <a:solidFill>
+                      <a:srgbClr val="FFFFFF"/>
+                    </a:solidFill>
+                  </a:tcPr>
+                </a:tc>
+                <a:tc>
+                  <a:txBody>
+                    <a:bodyPr/>
+                    <a:lstStyle/>
+                    <a:p>
+                      <a:pPr algn="ctr"/>
+                      <a:r>
+                        <a:rPr sz="1050" b="0">
+                          <a:solidFill>
+                            <a:srgbClr val="1A1A1A"/>
+                          </a:solidFill>
+                        </a:rPr>
+                        <a:t>18.05%</a:t>
+                      </a:r>
+                    </a:p>
+                  </a:txBody>
+                  <a:tcPr>
+                    <a:solidFill>
+                      <a:srgbClr val="FFFFFF"/>
+                    </a:solidFill>
+                  </a:tcPr>
+                </a:tc>
+              </a:tr>
+            </a:tbl>
+          </a:graphicData>
+        </a:graphic>
+      </p:graphicFrame>
+      <p:sp>
+        <p:nvSpPr>
+          <p:cNvPr id="6" name="TextBox 4"/>
+          <p:cNvSpPr txBox="1"/>
+          <p:nvPr/>
+        </p:nvSpPr>
+        <p:spPr>
+          <a:xfrm>
+            <a:off x="548640" y="4400000"/>
+            <a:ext cx="11091672" cy="950000"/>
+          </a:xfrm>
+          <a:prstGeom prst="rect">
+            <a:avLst/>
+          </a:prstGeom>
+          <a:noFill/>
+        </p:spPr>
+        <p:txBody>
+          <a:bodyPr wrap="square" anchor="t" lIns="0" rIns="0" tIns="0" bIns="0">
+            <a:spAutoFit/>
+          </a:bodyPr>
+          <a:lstStyle/>
+          <a:p>
+            <a:pPr algn="l"/>
+            <a:r>
+              <a:rPr sz="1050" b="0" i="1">
+                <a:solidFill>
+                  <a:srgbClr val="5B5E6B"/>
+                </a:solidFill>
+                <a:latin typeface="Calibri"/>
+              </a:rPr>
+              <a:t>①TENT는 collapse(한 클래스만 100% 예측)를 고쳤지만 그래도 전부 마스킹-only보다 나빠 최종안에서 제외했다. ②AdaBN 블렌딩은 얼마나 약하게 섞어도 Bangladesh·PlantDoc에서 마스킹-only를 못 넘었다 — BN 통계를 조금이라도 건드리는 것 자체가 해로웠다는 뜻. ③SHOT은 유일하게 3개 데이터셋 모두에서 collapse 없이 안정적으로 잘 됐다 — Taiwan은 AdaBN과 거의 동률, Bangladesh는 전체 방법 중 최고, PlantDoc은 정확도는 비슷해도 macro F1이 전체 중 가장 높다.</a:t>
+            </a:r>
+          </a:p>
+        </p:txBody>
+      </p:sp>
+      <p:sp>
+        <p:nvSpPr>
+          <p:cNvPr id="9" name="TextBox 4"/>
+          <p:cNvSpPr txBox="1"/>
+          <p:nvPr/>
+        </p:nvSpPr>
+        <p:spPr>
+          <a:xfrm>
+            <a:off x="548640" y="5400000"/>
+            <a:ext cx="11091672" cy="850000"/>
+          </a:xfrm>
+          <a:prstGeom prst="rect">
+            <a:avLst/>
+          </a:prstGeom>
+          <a:noFill/>
+        </p:spPr>
+        <p:txBody>
+          <a:bodyPr wrap="square" anchor="t" lIns="0" rIns="0" tIns="0" bIns="0">
+            <a:spAutoFit/>
+          </a:bodyPr>
+          <a:lstStyle/>
+          <a:p>
+            <a:pPr algn="l"/>
+            <a:r>
+              <a:rPr sz="1050" b="0" i="1">
+                <a:solidFill>
+                  <a:srgbClr val="5B5E6B"/>
+                </a:solidFill>
+                <a:latin typeface="Calibri"/>
+              </a:rPr>
+              <a:t>최종 권장 파이프라인: class-restriction 마스킹은 항상 적용 + 적응 방법은 SHOT을 기본으로 사용한다 (데이터셋마다 다른 방법을 골라야 했던 AdaBN/TENT와 달리 튜닝 없이 3개 전부에서 통한 유일한 방법). 현재 seed42 단일 결과이며, tiny_cnn_c(96px·bicubic) seed123/2026 재학습 후 3-seed로 재검증 중이다.</a:t>
+            </a:r>
+          </a:p>
+        </p:txBody>
+      </p:sp>
+      <p:sp>
+        <p:nvSpPr>
+          <p:cNvPr id="8" name="TextBox 5"/>
           <p:cNvSpPr txBox="1"/>
           <p:nvPr/>
         </p:nvSpPr>

</xml_diff>

<commit_message>
docs: RESULT 7 (1/3) 슬라이드에 negative transfer 근거 그래프 삽입
AdaBN/TENT 적용 후 예측이 target에 없는 클래스로 쏠린다는 주장을 뒷받침하는
negative_transfer_evidence.png(방법별 "없는 클래스로 예측된 비율" 비교)를
RESULT 7 (1/3) 슬라이드에 넣고, 표를 압축해 공간을 확보했다.

Co-Authored-By: Claude Sonnet 5 <noreply@anthropic.com>
</commit_message>
<xml_diff>
--- a/docs/CNN_토마토_병해분류_V2_진행보고.pptx
+++ b/docs/CNN_토마토_병해분류_V2_진행보고.pptx
@@ -16795,7 +16795,7 @@
         </p:nvGraphicFramePr>
         <p:xfrm>
           <a:off x="548640" y="2100000"/>
-          <a:ext cx="8961120" cy="2200000"/>
+          <a:ext cx="5350000" cy="1760000"/>
         </p:xfrm>
         <a:graphic>
           <a:graphicData uri="http://schemas.openxmlformats.org/drawingml/2006/table">
@@ -16804,21 +16804,21 @@
                 <a:tableStyleId>{5C22544A-7EE6-4342-B048-85BDC9FD1C3A}</a:tableStyleId>
               </a:tblPr>
               <a:tblGrid>
-                <a:gridCol w="2194560"/>
-                <a:gridCol w="1645920"/>
-                <a:gridCol w="1828800"/>
-                <a:gridCol w="1645920"/>
-                <a:gridCol w="1645920"/>
+                <a:gridCol w="1300000"/>
+                <a:gridCol w="900000"/>
+                <a:gridCol w="1150000"/>
+                <a:gridCol w="1000000"/>
+                <a:gridCol w="1000000"/>
               </a:tblGrid>
-              <a:tr h="550000">
-                <a:tc>
-                  <a:txBody>
-                    <a:bodyPr/>
-                    <a:lstStyle/>
-                    <a:p>
-                      <a:pPr algn="ctr"/>
-                      <a:r>
-                        <a:rPr sz="1050" b="1">
+              <a:tr h="440000">
+                <a:tc>
+                  <a:txBody>
+                    <a:bodyPr/>
+                    <a:lstStyle/>
+                    <a:p>
+                      <a:pPr algn="ctr"/>
+                      <a:r>
+                        <a:rPr sz="950" b="1">
                           <a:solidFill>
                             <a:srgbClr val="FFFFFF"/>
                           </a:solidFill>
@@ -16840,7 +16840,7 @@
                     <a:p>
                       <a:pPr algn="ctr"/>
                       <a:r>
-                        <a:rPr sz="1050" b="1">
+                        <a:rPr sz="950" b="1">
                           <a:solidFill>
                             <a:srgbClr val="FFFFFF"/>
                           </a:solidFill>
@@ -16862,7 +16862,7 @@
                     <a:p>
                       <a:pPr algn="ctr"/>
                       <a:r>
-                        <a:rPr sz="1050" b="1">
+                        <a:rPr sz="950" b="1">
                           <a:solidFill>
                             <a:srgbClr val="FFFFFF"/>
                           </a:solidFill>
@@ -16884,7 +16884,7 @@
                     <a:p>
                       <a:pPr algn="ctr"/>
                       <a:r>
-                        <a:rPr sz="1050" b="1">
+                        <a:rPr sz="950" b="1">
                           <a:solidFill>
                             <a:srgbClr val="FFFFFF"/>
                           </a:solidFill>
@@ -16906,7 +16906,7 @@
                     <a:p>
                       <a:pPr algn="ctr"/>
                       <a:r>
-                        <a:rPr sz="1050" b="1">
+                        <a:rPr sz="950" b="1">
                           <a:solidFill>
                             <a:srgbClr val="FFFFFF"/>
                           </a:solidFill>
@@ -16922,15 +16922,15 @@
                   </a:tcPr>
                 </a:tc>
               </a:tr>
-              <a:tr h="550000">
-                <a:tc>
-                  <a:txBody>
-                    <a:bodyPr/>
-                    <a:lstStyle/>
-                    <a:p>
-                      <a:pPr algn="ctr"/>
-                      <a:r>
-                        <a:rPr sz="1050" b="0">
+              <a:tr h="440000">
+                <a:tc>
+                  <a:txBody>
+                    <a:bodyPr/>
+                    <a:lstStyle/>
+                    <a:p>
+                      <a:pPr algn="ctr"/>
+                      <a:r>
+                        <a:rPr sz="950" b="0">
                           <a:solidFill>
                             <a:srgbClr val="1A1A1A"/>
                           </a:solidFill>
@@ -16952,7 +16952,7 @@
                     <a:p>
                       <a:pPr algn="ctr"/>
                       <a:r>
-                        <a:rPr sz="1050" b="0">
+                        <a:rPr sz="950" b="0">
                           <a:solidFill>
                             <a:srgbClr val="1A1A1A"/>
                           </a:solidFill>
@@ -16974,7 +16974,7 @@
                     <a:p>
                       <a:pPr algn="ctr"/>
                       <a:r>
-                        <a:rPr sz="1050" b="1">
+                        <a:rPr sz="950" b="1">
                           <a:solidFill>
                             <a:srgbClr val="1A1A1A"/>
                           </a:solidFill>
@@ -16996,7 +16996,7 @@
                     <a:p>
                       <a:pPr algn="ctr"/>
                       <a:r>
-                        <a:rPr sz="1050" b="0">
+                        <a:rPr sz="950" b="0">
                           <a:solidFill>
                             <a:srgbClr val="1A1A1A"/>
                           </a:solidFill>
@@ -17018,7 +17018,7 @@
                     <a:p>
                       <a:pPr algn="ctr"/>
                       <a:r>
-                        <a:rPr sz="1050" b="0">
+                        <a:rPr sz="950" b="0">
                           <a:solidFill>
                             <a:srgbClr val="1A1A1A"/>
                           </a:solidFill>
@@ -17034,15 +17034,15 @@
                   </a:tcPr>
                 </a:tc>
               </a:tr>
-              <a:tr h="550000">
-                <a:tc>
-                  <a:txBody>
-                    <a:bodyPr/>
-                    <a:lstStyle/>
-                    <a:p>
-                      <a:pPr algn="ctr"/>
-                      <a:r>
-                        <a:rPr sz="1050" b="0">
+              <a:tr h="440000">
+                <a:tc>
+                  <a:txBody>
+                    <a:bodyPr/>
+                    <a:lstStyle/>
+                    <a:p>
+                      <a:pPr algn="ctr"/>
+                      <a:r>
+                        <a:rPr sz="950" b="0">
                           <a:solidFill>
                             <a:srgbClr val="1A1A1A"/>
                           </a:solidFill>
@@ -17064,7 +17064,7 @@
                     <a:p>
                       <a:pPr algn="ctr"/>
                       <a:r>
-                        <a:rPr sz="1050" b="0">
+                        <a:rPr sz="950" b="0">
                           <a:solidFill>
                             <a:srgbClr val="1A1A1A"/>
                           </a:solidFill>
@@ -17086,7 +17086,7 @@
                     <a:p>
                       <a:pPr algn="ctr"/>
                       <a:r>
-                        <a:rPr sz="1050" b="1">
+                        <a:rPr sz="950" b="1">
                           <a:solidFill>
                             <a:srgbClr val="1A1A1A"/>
                           </a:solidFill>
@@ -17108,7 +17108,7 @@
                     <a:p>
                       <a:pPr algn="ctr"/>
                       <a:r>
-                        <a:rPr sz="1050" b="0">
+                        <a:rPr sz="950" b="0">
                           <a:solidFill>
                             <a:srgbClr val="1A1A1A"/>
                           </a:solidFill>
@@ -17130,7 +17130,7 @@
                     <a:p>
                       <a:pPr algn="ctr"/>
                       <a:r>
-                        <a:rPr sz="1050" b="0">
+                        <a:rPr sz="950" b="0">
                           <a:solidFill>
                             <a:srgbClr val="1A1A1A"/>
                           </a:solidFill>
@@ -17146,15 +17146,15 @@
                   </a:tcPr>
                 </a:tc>
               </a:tr>
-              <a:tr h="550000">
-                <a:tc>
-                  <a:txBody>
-                    <a:bodyPr/>
-                    <a:lstStyle/>
-                    <a:p>
-                      <a:pPr algn="ctr"/>
-                      <a:r>
-                        <a:rPr sz="1050" b="0">
+              <a:tr h="440000">
+                <a:tc>
+                  <a:txBody>
+                    <a:bodyPr/>
+                    <a:lstStyle/>
+                    <a:p>
+                      <a:pPr algn="ctr"/>
+                      <a:r>
+                        <a:rPr sz="950" b="0">
                           <a:solidFill>
                             <a:srgbClr val="1A1A1A"/>
                           </a:solidFill>
@@ -17176,7 +17176,7 @@
                     <a:p>
                       <a:pPr algn="ctr"/>
                       <a:r>
-                        <a:rPr sz="1050" b="0">
+                        <a:rPr sz="950" b="0">
                           <a:solidFill>
                             <a:srgbClr val="1A1A1A"/>
                           </a:solidFill>
@@ -17198,7 +17198,7 @@
                     <a:p>
                       <a:pPr algn="ctr"/>
                       <a:r>
-                        <a:rPr sz="1050" b="1">
+                        <a:rPr sz="950" b="1">
                           <a:solidFill>
                             <a:srgbClr val="1A1A1A"/>
                           </a:solidFill>
@@ -17220,7 +17220,7 @@
                     <a:p>
                       <a:pPr algn="ctr"/>
                       <a:r>
-                        <a:rPr sz="1050" b="0">
+                        <a:rPr sz="950" b="0">
                           <a:solidFill>
                             <a:srgbClr val="1A1A1A"/>
                           </a:solidFill>
@@ -17242,7 +17242,7 @@
                     <a:p>
                       <a:pPr algn="ctr"/>
                       <a:r>
-                        <a:rPr sz="1050" b="0">
+                        <a:rPr sz="950" b="0">
                           <a:solidFill>
                             <a:srgbClr val="1A1A1A"/>
                           </a:solidFill>
@@ -17262,6 +17262,30 @@
           </a:graphicData>
         </a:graphic>
       </p:graphicFrame>
+      <p:pic>
+        <p:nvPicPr>
+          <p:cNvPr id="10" name="Picture" descr="Negative transfer evidence: absent-class prediction rate by method"/>
+          <p:cNvPicPr>
+            <a:picLocks noChangeAspect="1"/>
+          </p:cNvPicPr>
+          <p:nvPr/>
+        </p:nvPicPr>
+        <p:blipFill>
+          <a:blip r:embed="rId2"/>
+          <a:stretch>
+            <a:fillRect/>
+          </a:stretch>
+        </p:blipFill>
+        <p:spPr>
+          <a:xfrm>
+            <a:off x="6700000" y="2100000"/>
+            <a:ext cx="4941672" cy="2678000"/>
+          </a:xfrm>
+          <a:prstGeom prst="rect">
+            <a:avLst/>
+          </a:prstGeom>
+        </p:spPr>
+      </p:pic>
       <p:sp>
         <p:nvSpPr>
           <p:cNvPr id="6" name="TextBox 4"/>
@@ -17270,8 +17294,8 @@
         </p:nvSpPr>
         <p:spPr>
           <a:xfrm>
-            <a:off x="548640" y="4450000"/>
-            <a:ext cx="11091672" cy="1150000"/>
+            <a:off x="548640" y="4950000"/>
+            <a:ext cx="11091672" cy="1300000"/>
           </a:xfrm>
           <a:prstGeom prst="rect">
             <a:avLst/>
@@ -17292,7 +17316,7 @@
                 </a:solidFill>
                 <a:latin typeface="Calibri"/>
               </a:rPr>
-              <a:t>예측 분포 분석(prediction_distribution.csv) 결과, AdaBN/TENT 적용 후 예측이 target에 없는 클래스로 쏠렸다 — partial label-space mismatch(PADA/ETN 이론)로 인한 negative transfer다. 클래스 겹침이 적을수록(Taiwan 3/10) 저하가 더 컸다. 다음 슬라이드에서 이 문제를 해결하는 class-restriction 마스킹을 다룬다.</a:t>
+              <a:t>예측 분포 분석(prediction_distribution.csv) 결과, AdaBN/TENT 적용 후 예측이 target에 없는 클래스로 쏠렸다 — partial label-space mismatch(PADA/ETN 이론)로 인한 negative transfer다. 오른쪽 그래프처럼 클래스 겹침이 적을수록(Taiwan 3/10) 저하가 더 컸다(21.7%→83.1%/78.0%). 다음 슬라이드에서 이 문제를 해결하는 class-restriction 마스킹을 다룬다.</a:t>
             </a:r>
           </a:p>
         </p:txBody>

</xml_diff>

<commit_message>
docs: RESULT 7에 (6/6) 슬라이드 추가 — tiny_cnn_c_lite 모델 크기 축소 검증
교수님 피드백(SHOT 과적합을 모델 용량 축소로 완화)을 반영한 tiny_cnn_c_lite 실험
결과를 새 슬라이드로 추가했다. Bangladesh는 과적합이 완화됐지만 PlantDoc은 더 빨리
과적합되는 등 가설이 절반만 맞았다는 점을 비교표와 epoch 민감도 그래프로 정리했다.

Co-Authored-By: Claude Sonnet 5 <noreply@anthropic.com>
</commit_message>
<xml_diff>
--- a/docs/CNN_토마토_병해분류_V2_진행보고.pptx
+++ b/docs/CNN_토마토_병해분류_V2_진행보고.pptx
@@ -33,6 +33,7 @@
     <p:sldId id="283" r:id="rId27"/>
     <p:sldId id="284" r:id="rId28"/>
     <p:sldId id="285" r:id="rId29"/>
+    <p:sldId id="286" r:id="rId36"/>
     <p:sldId id="277" r:id="rId30"/>
     <p:sldId id="278" r:id="rId31"/>
   </p:sldIdLst>
@@ -17549,7 +17550,7 @@
                 </a:solidFill>
                 <a:latin typeface="Calibri"/>
               </a:rPr>
-              <a:t>RESULT 7 · DOMAIN ADAPTATION (1/5)</a:t>
+              <a:t>RESULT 7 · DOMAIN ADAPTATION (1/6)</a:t>
             </a:r>
           </a:p>
         </p:txBody>
@@ -18308,7 +18309,7 @@
                 </a:solidFill>
                 <a:latin typeface="Calibri"/>
               </a:rPr>
-              <a:t>RESULT 7 · DOMAIN ADAPTATION (2/5)</a:t>
+              <a:t>RESULT 7 · DOMAIN ADAPTATION (2/6)</a:t>
             </a:r>
           </a:p>
         </p:txBody>
@@ -18948,7 +18949,7 @@
                 </a:solidFill>
                 <a:latin typeface="Calibri"/>
               </a:rPr>
-              <a:t>RESULT 7 · DOMAIN ADAPTATION (3/5)</a:t>
+              <a:t>RESULT 7 · DOMAIN ADAPTATION (3/6)</a:t>
             </a:r>
           </a:p>
         </p:txBody>
@@ -19786,7 +19787,7 @@
                 </a:solidFill>
                 <a:latin typeface="Calibri"/>
               </a:rPr>
-              <a:t>RESULT 7 · DOMAIN ADAPTATION (4/5)</a:t>
+              <a:t>RESULT 7 · DOMAIN ADAPTATION (4/6)</a:t>
             </a:r>
           </a:p>
         </p:txBody>
@@ -20315,7 +20316,7 @@
                 </a:solidFill>
                 <a:latin typeface="Calibri"/>
               </a:rPr>
-              <a:t>RESULT 7 · DOMAIN ADAPTATION (5/5)</a:t>
+              <a:t>RESULT 7 · DOMAIN ADAPTATION (5/6)</a:t>
             </a:r>
           </a:p>
         </p:txBody>
@@ -21522,7 +21523,7 @@
                 </a:solidFill>
                 <a:latin typeface="Calibri"/>
               </a:rPr>
-              <a:t>28</a:t>
+              <a:t>29</a:t>
             </a:r>
           </a:p>
         </p:txBody>
@@ -22944,7 +22945,599 @@
                 </a:solidFill>
                 <a:latin typeface="Calibri"/>
               </a:rPr>
-              <a:t>29</a:t>
+              <a:t>30</a:t>
+            </a:r>
+          </a:p>
+        </p:txBody>
+      </p:sp>
+    </p:spTree>
+  </p:cSld>
+  <p:clrMapOvr>
+    <a:masterClrMapping/>
+  </p:clrMapOvr>
+</p:sld>
+</file>
+
+<file path=ppt/slides/slide31.xml><?xml version="1.0" encoding="utf-8"?>
+<p:sld xmlns:a="http://schemas.openxmlformats.org/drawingml/2006/main" xmlns:p="http://schemas.openxmlformats.org/presentationml/2006/main" xmlns:r="http://schemas.openxmlformats.org/officeDocument/2006/relationships">
+  <p:cSld>
+    <p:bg>
+      <p:bgPr>
+        <a:solidFill>
+          <a:srgbClr val="FFFFFF"/>
+        </a:solidFill>
+        <a:effectLst/>
+      </p:bgPr>
+    </p:bg>
+    <p:spTree>
+      <p:nvGrpSpPr>
+        <p:cNvPr id="1" name=""/>
+        <p:cNvGrpSpPr/>
+        <p:nvPr/>
+      </p:nvGrpSpPr>
+      <p:grpSpPr/>
+      <p:sp>
+        <p:nvSpPr>
+          <p:cNvPr id="2" name="TextBox 1"/>
+          <p:cNvSpPr txBox="1"/>
+          <p:nvPr/>
+        </p:nvSpPr>
+        <p:spPr>
+          <a:xfrm>
+            <a:off x="548640" y="292608"/>
+            <a:ext cx="9144000" cy="292608"/>
+          </a:xfrm>
+          <a:prstGeom prst="rect">
+            <a:avLst/>
+          </a:prstGeom>
+          <a:noFill/>
+        </p:spPr>
+        <p:txBody>
+          <a:bodyPr wrap="square" anchor="t" lIns="0" rIns="0" tIns="0" bIns="0">
+            <a:spAutoFit/>
+          </a:bodyPr>
+          <a:lstStyle/>
+          <a:p>
+            <a:pPr algn="l"/>
+            <a:r>
+              <a:rPr sz="1050" b="1" i="0">
+                <a:solidFill>
+                  <a:srgbClr val="2A78D6"/>
+                </a:solidFill>
+                <a:latin typeface="Calibri"/>
+              </a:rPr>
+              <a:t>RESULT 7 · DOMAIN ADAPTATION (6/6)</a:t>
+            </a:r>
+          </a:p>
+        </p:txBody>
+      </p:sp>
+      <p:sp>
+        <p:nvSpPr>
+          <p:cNvPr id="3" name="TextBox 2"/>
+          <p:cNvSpPr txBox="1"/>
+          <p:nvPr/>
+        </p:nvSpPr>
+        <p:spPr>
+          <a:xfrm>
+            <a:off x="548640" y="566928"/>
+            <a:ext cx="10972800" cy="548640"/>
+          </a:xfrm>
+          <a:prstGeom prst="rect">
+            <a:avLst/>
+          </a:prstGeom>
+          <a:noFill/>
+        </p:spPr>
+        <p:txBody>
+          <a:bodyPr wrap="square" anchor="t" lIns="0" rIns="0" tIns="0" bIns="0">
+            <a:spAutoFit/>
+          </a:bodyPr>
+          <a:lstStyle/>
+          <a:p>
+            <a:pPr algn="l"/>
+            <a:r>
+              <a:rPr sz="2400" b="1" i="0">
+                <a:solidFill>
+                  <a:srgbClr val="1E2761"/>
+                </a:solidFill>
+                <a:latin typeface="Cambria"/>
+              </a:rPr>
+              <a:t>추가 검증: 모델을 더 줄이면 과적합이 줄어들까?</a:t>
+            </a:r>
+          </a:p>
+        </p:txBody>
+      </p:sp>
+      <p:sp>
+        <p:nvSpPr>
+          <p:cNvPr id="4" name="TextBox 3"/>
+          <p:cNvSpPr txBox="1"/>
+          <p:nvPr/>
+        </p:nvSpPr>
+        <p:spPr>
+          <a:xfrm>
+            <a:off x="548640" y="1200000"/>
+            <a:ext cx="11091672" cy="950000"/>
+          </a:xfrm>
+          <a:prstGeom prst="rect">
+            <a:avLst/>
+          </a:prstGeom>
+          <a:noFill/>
+        </p:spPr>
+        <p:txBody>
+          <a:bodyPr wrap="square" anchor="t" lIns="0" rIns="0" tIns="0" bIns="0">
+            <a:spAutoFit/>
+          </a:bodyPr>
+          <a:lstStyle/>
+          <a:p>
+            <a:pPr algn="l"/>
+            <a:r>
+              <a:rPr sz="1300" b="0" i="0">
+                <a:solidFill>
+                  <a:srgbClr val="1A1A1A"/>
+                </a:solidFill>
+                <a:latin typeface="Calibri"/>
+              </a:rPr>
+              <a:t>교수님 피드백: SHOT이 epoch 2만 넘어도 과적합되는 건 모델 용량 때문 아니냐 — 채널을 32→32→64→64로 절반 줄여보라는 제안. tiny_cnn_c_lite(10.2K 파라미터, 기존의 약 1/3)를 96px·bilinear로 추가 학습해 검증했다.</a:t>
+            </a:r>
+          </a:p>
+        </p:txBody>
+      </p:sp>
+      <p:graphicFrame>
+        <p:nvGraphicFramePr>
+          <p:cNvPr id="7" name="Table"/>
+          <p:cNvGraphicFramePr>
+            <a:graphicFrameLocks noGrp="1"/>
+          </p:cNvGraphicFramePr>
+          <p:nvPr/>
+        </p:nvGraphicFramePr>
+        <p:xfrm>
+          <a:off x="548640" y="2250000"/>
+          <a:ext cx="6700000" cy="2400000"/>
+        </p:xfrm>
+        <a:graphic>
+          <a:graphicData uri="http://schemas.openxmlformats.org/drawingml/2006/table">
+            <a:tbl>
+              <a:tblPr firstRow="1" bandRow="1">
+                <a:tableStyleId>{5C22544A-7EE6-4342-B048-85BDC9FD1C3A}</a:tableStyleId>
+              </a:tblPr>
+              <a:tblGrid>
+                <a:gridCol w="2900000"/>
+                <a:gridCol w="1900000"/>
+                <a:gridCol w="1900000"/>
+              </a:tblGrid>
+              <a:tr h="480000">
+                <a:tc>
+                  <a:txBody>
+                    <a:bodyPr/>
+                    <a:lstStyle/>
+                    <a:p>
+                      <a:pPr algn="ctr"/>
+                      <a:r>
+                        <a:rPr sz="1200" b="1">
+                          <a:solidFill>
+                            <a:srgbClr val="FFFFFF"/>
+                          </a:solidFill>
+                        </a:rPr>
+                        <a:t>항목</a:t>
+                      </a:r>
+                    </a:p>
+                  </a:txBody>
+                  <a:tcPr anchor="ctr">
+                    <a:solidFill>
+                      <a:srgbClr val="1E2761"/>
+                    </a:solidFill>
+                  </a:tcPr>
+                </a:tc>
+                <a:tc>
+                  <a:txBody>
+                    <a:bodyPr/>
+                    <a:lstStyle/>
+                    <a:p>
+                      <a:pPr algn="ctr"/>
+                      <a:r>
+                        <a:rPr sz="1200" b="1">
+                          <a:solidFill>
+                            <a:srgbClr val="FFFFFF"/>
+                          </a:solidFill>
+                        </a:rPr>
+                        <a:t>tiny_cnn_c (31.5K)</a:t>
+                      </a:r>
+                    </a:p>
+                  </a:txBody>
+                  <a:tcPr anchor="ctr">
+                    <a:solidFill>
+                      <a:srgbClr val="1E2761"/>
+                    </a:solidFill>
+                  </a:tcPr>
+                </a:tc>
+                <a:tc>
+                  <a:txBody>
+                    <a:bodyPr/>
+                    <a:lstStyle/>
+                    <a:p>
+                      <a:pPr algn="ctr"/>
+                      <a:r>
+                        <a:rPr sz="1200" b="1">
+                          <a:solidFill>
+                            <a:srgbClr val="FFFFFF"/>
+                          </a:solidFill>
+                        </a:rPr>
+                        <a:t>tiny_cnn_c_lite (10.2K)</a:t>
+                      </a:r>
+                    </a:p>
+                  </a:txBody>
+                  <a:tcPr anchor="ctr">
+                    <a:solidFill>
+                      <a:srgbClr val="1E2761"/>
+                    </a:solidFill>
+                  </a:tcPr>
+                </a:tc>
+              </a:tr>
+              <a:tr h="480000">
+                <a:tc>
+                  <a:txBody>
+                    <a:bodyPr/>
+                    <a:lstStyle/>
+                    <a:p>
+                      <a:pPr algn="ctr"/>
+                      <a:r>
+                        <a:rPr sz="1200" b="0">
+                          <a:solidFill>
+                            <a:srgbClr val="1A1A1A"/>
+                          </a:solidFill>
+                        </a:rPr>
+                        <a:t>내부 정확도</a:t>
+                      </a:r>
+                    </a:p>
+                  </a:txBody>
+                  <a:tcPr anchor="ctr">
+                    <a:solidFill>
+                      <a:srgbClr val="FFFFFF"/>
+                    </a:solidFill>
+                  </a:tcPr>
+                </a:tc>
+                <a:tc>
+                  <a:txBody>
+                    <a:bodyPr/>
+                    <a:lstStyle/>
+                    <a:p>
+                      <a:pPr algn="ctr"/>
+                      <a:r>
+                        <a:rPr sz="1200" b="1">
+                          <a:solidFill>
+                            <a:srgbClr val="1A1A1A"/>
+                          </a:solidFill>
+                        </a:rPr>
+                        <a:t>96.59%</a:t>
+                      </a:r>
+                    </a:p>
+                  </a:txBody>
+                  <a:tcPr anchor="ctr">
+                    <a:solidFill>
+                      <a:srgbClr val="FFFFFF"/>
+                    </a:solidFill>
+                  </a:tcPr>
+                </a:tc>
+                <a:tc>
+                  <a:txBody>
+                    <a:bodyPr/>
+                    <a:lstStyle/>
+                    <a:p>
+                      <a:pPr algn="ctr"/>
+                      <a:r>
+                        <a:rPr sz="1200" b="0">
+                          <a:solidFill>
+                            <a:srgbClr val="1A1A1A"/>
+                          </a:solidFill>
+                        </a:rPr>
+                        <a:t>95.34%</a:t>
+                      </a:r>
+                    </a:p>
+                  </a:txBody>
+                  <a:tcPr anchor="ctr">
+                    <a:solidFill>
+                      <a:srgbClr val="FFFFFF"/>
+                    </a:solidFill>
+                  </a:tcPr>
+                </a:tc>
+              </a:tr>
+              <a:tr h="480000">
+                <a:tc>
+                  <a:txBody>
+                    <a:bodyPr/>
+                    <a:lstStyle/>
+                    <a:p>
+                      <a:pPr algn="ctr"/>
+                      <a:r>
+                        <a:rPr sz="1200" b="0">
+                          <a:solidFill>
+                            <a:srgbClr val="1A1A1A"/>
+                          </a:solidFill>
+                        </a:rPr>
+                        <a:t>Taiwan (SHOT ep2)</a:t>
+                      </a:r>
+                    </a:p>
+                  </a:txBody>
+                  <a:tcPr anchor="ctr">
+                    <a:solidFill>
+                      <a:srgbClr val="EEF3FC"/>
+                    </a:solidFill>
+                  </a:tcPr>
+                </a:tc>
+                <a:tc>
+                  <a:txBody>
+                    <a:bodyPr/>
+                    <a:lstStyle/>
+                    <a:p>
+                      <a:pPr algn="ctr"/>
+                      <a:r>
+                        <a:rPr sz="1200" b="1">
+                          <a:solidFill>
+                            <a:srgbClr val="1A1A1A"/>
+                          </a:solidFill>
+                        </a:rPr>
+                        <a:t>42.04%</a:t>
+                      </a:r>
+                    </a:p>
+                  </a:txBody>
+                  <a:tcPr anchor="ctr">
+                    <a:solidFill>
+                      <a:srgbClr val="EEF3FC"/>
+                    </a:solidFill>
+                  </a:tcPr>
+                </a:tc>
+                <a:tc>
+                  <a:txBody>
+                    <a:bodyPr/>
+                    <a:lstStyle/>
+                    <a:p>
+                      <a:pPr algn="ctr"/>
+                      <a:r>
+                        <a:rPr sz="1200" b="0">
+                          <a:solidFill>
+                            <a:srgbClr val="1A1A1A"/>
+                          </a:solidFill>
+                        </a:rPr>
+                        <a:t>37.90%</a:t>
+                      </a:r>
+                    </a:p>
+                  </a:txBody>
+                  <a:tcPr anchor="ctr">
+                    <a:solidFill>
+                      <a:srgbClr val="EEF3FC"/>
+                    </a:solidFill>
+                  </a:tcPr>
+                </a:tc>
+              </a:tr>
+              <a:tr h="480000">
+                <a:tc>
+                  <a:txBody>
+                    <a:bodyPr/>
+                    <a:lstStyle/>
+                    <a:p>
+                      <a:pPr algn="ctr"/>
+                      <a:r>
+                        <a:rPr sz="1200" b="0">
+                          <a:solidFill>
+                            <a:srgbClr val="1A1A1A"/>
+                          </a:solidFill>
+                        </a:rPr>
+                        <a:t>Bangladesh (SHOT ep2)</a:t>
+                      </a:r>
+                    </a:p>
+                  </a:txBody>
+                  <a:tcPr anchor="ctr">
+                    <a:solidFill>
+                      <a:srgbClr val="FFFFFF"/>
+                    </a:solidFill>
+                  </a:tcPr>
+                </a:tc>
+                <a:tc>
+                  <a:txBody>
+                    <a:bodyPr/>
+                    <a:lstStyle/>
+                    <a:p>
+                      <a:pPr algn="ctr"/>
+                      <a:r>
+                        <a:rPr sz="1200" b="1">
+                          <a:solidFill>
+                            <a:srgbClr val="1A1A1A"/>
+                          </a:solidFill>
+                        </a:rPr>
+                        <a:t>30.79%</a:t>
+                      </a:r>
+                    </a:p>
+                  </a:txBody>
+                  <a:tcPr anchor="ctr">
+                    <a:solidFill>
+                      <a:srgbClr val="FFFFFF"/>
+                    </a:solidFill>
+                  </a:tcPr>
+                </a:tc>
+                <a:tc>
+                  <a:txBody>
+                    <a:bodyPr/>
+                    <a:lstStyle/>
+                    <a:p>
+                      <a:pPr algn="ctr"/>
+                      <a:r>
+                        <a:rPr sz="1200" b="0">
+                          <a:solidFill>
+                            <a:srgbClr val="1A1A1A"/>
+                          </a:solidFill>
+                        </a:rPr>
+                        <a:t>21.07%</a:t>
+                      </a:r>
+                    </a:p>
+                  </a:txBody>
+                  <a:tcPr anchor="ctr">
+                    <a:solidFill>
+                      <a:srgbClr val="FFFFFF"/>
+                    </a:solidFill>
+                  </a:tcPr>
+                </a:tc>
+              </a:tr>
+              <a:tr h="480000">
+                <a:tc>
+                  <a:txBody>
+                    <a:bodyPr/>
+                    <a:lstStyle/>
+                    <a:p>
+                      <a:pPr algn="ctr"/>
+                      <a:r>
+                        <a:rPr sz="1200" b="0">
+                          <a:solidFill>
+                            <a:srgbClr val="1A1A1A"/>
+                          </a:solidFill>
+                        </a:rPr>
+                        <a:t>PlantDoc (SHOT ep2)</a:t>
+                      </a:r>
+                    </a:p>
+                  </a:txBody>
+                  <a:tcPr anchor="ctr">
+                    <a:solidFill>
+                      <a:srgbClr val="EEF3FC"/>
+                    </a:solidFill>
+                  </a:tcPr>
+                </a:tc>
+                <a:tc>
+                  <a:txBody>
+                    <a:bodyPr/>
+                    <a:lstStyle/>
+                    <a:p>
+                      <a:pPr algn="ctr"/>
+                      <a:r>
+                        <a:rPr sz="1200" b="0">
+                          <a:solidFill>
+                            <a:srgbClr val="1A1A1A"/>
+                          </a:solidFill>
+                        </a:rPr>
+                        <a:t>19.46% (F1 0.18)</a:t>
+                      </a:r>
+                    </a:p>
+                  </a:txBody>
+                  <a:tcPr anchor="ctr">
+                    <a:solidFill>
+                      <a:srgbClr val="EEF3FC"/>
+                    </a:solidFill>
+                  </a:tcPr>
+                </a:tc>
+                <a:tc>
+                  <a:txBody>
+                    <a:bodyPr/>
+                    <a:lstStyle/>
+                    <a:p>
+                      <a:pPr algn="ctr"/>
+                      <a:r>
+                        <a:rPr sz="1200" b="1">
+                          <a:solidFill>
+                            <a:srgbClr val="1A1A1A"/>
+                          </a:solidFill>
+                        </a:rPr>
+                        <a:t>22.57% (F1 0.20)</a:t>
+                      </a:r>
+                    </a:p>
+                  </a:txBody>
+                  <a:tcPr anchor="ctr">
+                    <a:solidFill>
+                      <a:srgbClr val="EEF3FC"/>
+                    </a:solidFill>
+                  </a:tcPr>
+                </a:tc>
+              </a:tr>
+            </a:tbl>
+          </a:graphicData>
+        </a:graphic>
+      </p:graphicFrame>
+      <p:pic>
+        <p:nvPicPr>
+          <p:cNvPr id="10" name="Picture" descr="SHOT epoch sensitivity chart (tiny_cnn_c_lite)"/>
+          <p:cNvPicPr>
+            <a:picLocks noChangeAspect="1"/>
+          </p:cNvPicPr>
+          <p:nvPr/>
+        </p:nvPicPr>
+        <p:blipFill>
+          <a:blip r:embed="rId2"/>
+          <a:stretch>
+            <a:fillRect/>
+          </a:stretch>
+        </p:blipFill>
+        <p:spPr>
+          <a:xfrm>
+            <a:off x="7548640" y="2250000"/>
+            <a:ext cx="4000000" cy="2599935"/>
+          </a:xfrm>
+          <a:prstGeom prst="rect">
+            <a:avLst/>
+          </a:prstGeom>
+        </p:spPr>
+      </p:pic>
+      <p:sp>
+        <p:nvSpPr>
+          <p:cNvPr id="6" name="TextBox 4"/>
+          <p:cNvSpPr txBox="1"/>
+          <p:nvPr/>
+        </p:nvSpPr>
+        <p:spPr>
+          <a:xfrm>
+            <a:off x="548640" y="4999935"/>
+            <a:ext cx="11091672" cy="1100000"/>
+          </a:xfrm>
+          <a:prstGeom prst="rect">
+            <a:avLst/>
+          </a:prstGeom>
+          <a:noFill/>
+        </p:spPr>
+        <p:txBody>
+          <a:bodyPr wrap="square" anchor="t" lIns="0" rIns="0" tIns="0" bIns="0">
+            <a:spAutoFit/>
+          </a:bodyPr>
+          <a:lstStyle/>
+          <a:p>
+            <a:pPr algn="l"/>
+            <a:r>
+              <a:rPr sz="1300" b="0" i="1">
+                <a:solidFill>
+                  <a:srgbClr val="5B5E6B"/>
+                </a:solidFill>
+                <a:latin typeface="Calibri"/>
+              </a:rPr>
+              <a:t>가설은 절반만 맞았다 — Bangladesh는 과적합이 완화됐지만(epoch 5까지 계속 개선) PlantDoc은 오히려 더 빨리 과적합됐다(epoch 1에서 이미 정점). 내부 정확도·Taiwan·Bangladesh는 전반적으로 더 낮아져, 모델 축소가 일관된 해결책은 아니었다 — 과적합 억제는 epoch 수를 고정하는 기존 방식이 더 안정적이다.</a:t>
+            </a:r>
+          </a:p>
+        </p:txBody>
+      </p:sp>
+      <p:sp>
+        <p:nvSpPr>
+          <p:cNvPr id="8" name="TextBox 5"/>
+          <p:cNvSpPr txBox="1"/>
+          <p:nvPr/>
+        </p:nvSpPr>
+        <p:spPr>
+          <a:xfrm>
+            <a:off x="11430000" y="6446520"/>
+            <a:ext cx="548640" cy="274320"/>
+          </a:xfrm>
+          <a:prstGeom prst="rect">
+            <a:avLst/>
+          </a:prstGeom>
+          <a:noFill/>
+        </p:spPr>
+        <p:txBody>
+          <a:bodyPr wrap="square" anchor="t" lIns="0" rIns="0" tIns="0" bIns="0">
+            <a:spAutoFit/>
+          </a:bodyPr>
+          <a:lstStyle/>
+          <a:p>
+            <a:pPr algn="r"/>
+            <a:r>
+              <a:rPr sz="1000" b="0" i="0">
+                <a:solidFill>
+                  <a:srgbClr val="5B5E6B"/>
+                </a:solidFill>
+                <a:latin typeface="Calibri"/>
+              </a:rPr>
+              <a:t>28</a:t>
             </a:r>
           </a:p>
         </p:txBody>

</xml_diff>

<commit_message>
docs: RESULT 7에 (7/8) EATA 추가 시도 슬라이드 추가
TENT의 최신 후속작 EATA(ICML 2022, 공식 코드 mr-eggplant/EATA)를 추가로 시도했으나
3개 데이터셋 전부 SHOT을 넘지 못했다는 결과와, 논문 기본 하이퍼파라미터가 우리
스케일(클래스 3~8개)엔 안 맞아 lr을 100배 올려 캘리브레이션해야 했다는 점을
한 페이지로 정리했다. SHOT이 최종 권장안 자리를 유지한다.

Co-Authored-By: Claude Sonnet 5 <noreply@anthropic.com>
</commit_message>
<xml_diff>
--- a/docs/CNN_토마토_병해분류_V2_진행보고.pptx
+++ b/docs/CNN_토마토_병해분류_V2_진행보고.pptx
@@ -34,6 +34,7 @@
     <p:sldId id="283" r:id="rId27"/>
     <p:sldId id="284" r:id="rId28"/>
     <p:sldId id="285" r:id="rId29"/>
+    <p:sldId id="288" r:id="rId38"/>
     <p:sldId id="286" r:id="rId36"/>
     <p:sldId id="277" r:id="rId30"/>
     <p:sldId id="278" r:id="rId31"/>
@@ -17551,7 +17552,7 @@
                 </a:solidFill>
                 <a:latin typeface="Calibri"/>
               </a:rPr>
-              <a:t>RESULT 7 · DOMAIN ADAPTATION (1/7)</a:t>
+              <a:t>RESULT 7 · DOMAIN ADAPTATION (1/8)</a:t>
             </a:r>
           </a:p>
         </p:txBody>
@@ -18310,7 +18311,7 @@
                 </a:solidFill>
                 <a:latin typeface="Calibri"/>
               </a:rPr>
-              <a:t>RESULT 7 · DOMAIN ADAPTATION (2/7)</a:t>
+              <a:t>RESULT 7 · DOMAIN ADAPTATION (2/8)</a:t>
             </a:r>
           </a:p>
         </p:txBody>
@@ -18950,7 +18951,7 @@
                 </a:solidFill>
                 <a:latin typeface="Calibri"/>
               </a:rPr>
-              <a:t>RESULT 7 · DOMAIN ADAPTATION (4/7)</a:t>
+              <a:t>RESULT 7 · DOMAIN ADAPTATION (4/8)</a:t>
             </a:r>
           </a:p>
         </p:txBody>
@@ -19788,7 +19789,7 @@
                 </a:solidFill>
                 <a:latin typeface="Calibri"/>
               </a:rPr>
-              <a:t>RESULT 7 · DOMAIN ADAPTATION (5/7)</a:t>
+              <a:t>RESULT 7 · DOMAIN ADAPTATION (5/8)</a:t>
             </a:r>
           </a:p>
         </p:txBody>
@@ -20317,7 +20318,7 @@
                 </a:solidFill>
                 <a:latin typeface="Calibri"/>
               </a:rPr>
-              <a:t>RESULT 7 · DOMAIN ADAPTATION (6/7)</a:t>
+              <a:t>RESULT 7 · DOMAIN ADAPTATION (6/8)</a:t>
             </a:r>
           </a:p>
         </p:txBody>
@@ -21524,7 +21525,7 @@
                 </a:solidFill>
                 <a:latin typeface="Calibri"/>
               </a:rPr>
-              <a:t>30</a:t>
+              <a:t>31</a:t>
             </a:r>
           </a:p>
         </p:txBody>
@@ -22946,7 +22947,7 @@
                 </a:solidFill>
                 <a:latin typeface="Calibri"/>
               </a:rPr>
-              <a:t>31</a:t>
+              <a:t>32</a:t>
             </a:r>
           </a:p>
         </p:txBody>
@@ -23007,7 +23008,7 @@
                 </a:solidFill>
                 <a:latin typeface="Calibri"/>
               </a:rPr>
-              <a:t>RESULT 7 · DOMAIN ADAPTATION (7/7)</a:t>
+              <a:t>RESULT 7 · DOMAIN ADAPTATION (8/8)</a:t>
             </a:r>
           </a:p>
         </p:txBody>
@@ -23538,7 +23539,7 @@
                 </a:solidFill>
                 <a:latin typeface="Calibri"/>
               </a:rPr>
-              <a:t>29</a:t>
+              <a:t>30</a:t>
             </a:r>
           </a:p>
         </p:txBody>
@@ -23599,7 +23600,7 @@
                 </a:solidFill>
                 <a:latin typeface="Calibri"/>
               </a:rPr>
-              <a:t>RESULT 7 · DOMAIN ADAPTATION (3/7)</a:t>
+              <a:t>RESULT 7 · DOMAIN ADAPTATION (3/8)</a:t>
             </a:r>
           </a:p>
         </p:txBody>
@@ -23898,6 +23899,595 @@
                 <a:latin typeface="Calibri"/>
               </a:rPr>
               <a:t>25</a:t>
+            </a:r>
+          </a:p>
+        </p:txBody>
+      </p:sp>
+    </p:spTree>
+  </p:cSld>
+  <p:clrMapOvr>
+    <a:masterClrMapping/>
+  </p:clrMapOvr>
+</p:sld>
+</file>
+
+<file path=ppt/slides/slide33.xml><?xml version="1.0" encoding="utf-8"?>
+<p:sld xmlns:a="http://schemas.openxmlformats.org/drawingml/2006/main" xmlns:p="http://schemas.openxmlformats.org/presentationml/2006/main" xmlns:r="http://schemas.openxmlformats.org/officeDocument/2006/relationships">
+  <p:cSld>
+    <p:bg>
+      <p:bgPr>
+        <a:solidFill>
+          <a:srgbClr val="FFFFFF"/>
+        </a:solidFill>
+        <a:effectLst/>
+      </p:bgPr>
+    </p:bg>
+    <p:spTree>
+      <p:nvGrpSpPr>
+        <p:cNvPr id="1" name=""/>
+        <p:cNvGrpSpPr/>
+        <p:nvPr/>
+      </p:nvGrpSpPr>
+      <p:grpSpPr/>
+      <p:sp>
+        <p:nvSpPr>
+          <p:cNvPr id="2" name="TextBox 1"/>
+          <p:cNvSpPr txBox="1"/>
+          <p:nvPr/>
+        </p:nvSpPr>
+        <p:spPr>
+          <a:xfrm>
+            <a:off x="548640" y="292608"/>
+            <a:ext cx="9144000" cy="292608"/>
+          </a:xfrm>
+          <a:prstGeom prst="rect">
+            <a:avLst/>
+          </a:prstGeom>
+          <a:noFill/>
+        </p:spPr>
+        <p:txBody>
+          <a:bodyPr wrap="square" anchor="t" lIns="0" rIns="0" tIns="0" bIns="0">
+            <a:spAutoFit/>
+          </a:bodyPr>
+          <a:lstStyle/>
+          <a:p>
+            <a:pPr algn="l"/>
+            <a:r>
+              <a:rPr sz="1050" b="1" i="0">
+                <a:solidFill>
+                  <a:srgbClr val="2A78D6"/>
+                </a:solidFill>
+                <a:latin typeface="Calibri"/>
+              </a:rPr>
+              <a:t>RESULT 7 · DOMAIN ADAPTATION (7/8)</a:t>
+            </a:r>
+          </a:p>
+        </p:txBody>
+      </p:sp>
+      <p:sp>
+        <p:nvSpPr>
+          <p:cNvPr id="3" name="TextBox 2"/>
+          <p:cNvSpPr txBox="1"/>
+          <p:nvPr/>
+        </p:nvSpPr>
+        <p:spPr>
+          <a:xfrm>
+            <a:off x="548640" y="566928"/>
+            <a:ext cx="10972800" cy="548640"/>
+          </a:xfrm>
+          <a:prstGeom prst="rect">
+            <a:avLst/>
+          </a:prstGeom>
+          <a:noFill/>
+        </p:spPr>
+        <p:txBody>
+          <a:bodyPr wrap="square" anchor="t" lIns="0" rIns="0" tIns="0" bIns="0">
+            <a:spAutoFit/>
+          </a:bodyPr>
+          <a:lstStyle/>
+          <a:p>
+            <a:pPr algn="l"/>
+            <a:r>
+              <a:rPr sz="2400" b="1" i="0">
+                <a:solidFill>
+                  <a:srgbClr val="1E2761"/>
+                </a:solidFill>
+                <a:latin typeface="Cambria"/>
+              </a:rPr>
+              <a:t>추가 시도: EATA (ICML 2022) — SHOT을 넘지 못함</a:t>
+            </a:r>
+          </a:p>
+        </p:txBody>
+      </p:sp>
+      <p:sp>
+        <p:nvSpPr>
+          <p:cNvPr id="4" name="TextBox 3"/>
+          <p:cNvSpPr txBox="1"/>
+          <p:nvPr/>
+        </p:nvSpPr>
+        <p:spPr>
+          <a:xfrm>
+            <a:off x="548640" y="1200000"/>
+            <a:ext cx="11091672" cy="1150000"/>
+          </a:xfrm>
+          <a:prstGeom prst="rect">
+            <a:avLst/>
+          </a:prstGeom>
+          <a:noFill/>
+        </p:spPr>
+        <p:txBody>
+          <a:bodyPr wrap="square" anchor="t" lIns="0" rIns="0" tIns="0" bIns="0">
+            <a:spAutoFit/>
+          </a:bodyPr>
+          <a:lstStyle/>
+          <a:p>
+            <a:pPr algn="l"/>
+            <a:r>
+              <a:rPr sz="1300" b="0" i="0">
+                <a:solidFill>
+                  <a:srgbClr val="1A1A1A"/>
+                </a:solidFill>
+                <a:latin typeface="Calibri"/>
+              </a:rPr>
+              <a:t>Niu et al., ICML 2022 (공식 코드: mr-eggplant/EATA). TENT와 같은 지점(BN affine만 학습)에서 출발해 ① 불확실하거나(entropy 높음) 중복되는 샘플은 적응에서 제외하고 ② source test셋 Fisher information으로 “원본 가중치에서 너무 멀어지지 않게” 정규화한다.</a:t>
+            </a:r>
+          </a:p>
+        </p:txBody>
+      </p:sp>
+      <p:graphicFrame>
+        <p:nvGraphicFramePr>
+          <p:cNvPr id="7" name="Table"/>
+          <p:cNvGraphicFramePr>
+            <a:graphicFrameLocks noGrp="1"/>
+          </p:cNvGraphicFramePr>
+          <p:nvPr/>
+        </p:nvGraphicFramePr>
+        <p:xfrm>
+          <a:off x="548640" y="2500000"/>
+          <a:ext cx="9800000" cy="2240000"/>
+        </p:xfrm>
+        <a:graphic>
+          <a:graphicData uri="http://schemas.openxmlformats.org/drawingml/2006/table">
+            <a:tbl>
+              <a:tblPr firstRow="1" bandRow="1">
+                <a:tableStyleId>{5C22544A-7EE6-4342-B048-85BDC9FD1C3A}</a:tableStyleId>
+              </a:tblPr>
+              <a:tblGrid>
+                <a:gridCol w="2600000"/>
+                <a:gridCol w="2400000"/>
+                <a:gridCol w="2400000"/>
+                <a:gridCol w="2400000"/>
+              </a:tblGrid>
+              <a:tr h="560000">
+                <a:tc>
+                  <a:txBody>
+                    <a:bodyPr/>
+                    <a:lstStyle/>
+                    <a:p>
+                      <a:pPr algn="ctr"/>
+                      <a:r>
+                        <a:rPr sz="1200" b="1">
+                          <a:solidFill>
+                            <a:srgbClr val="FFFFFF"/>
+                          </a:solidFill>
+                        </a:rPr>
+                        <a:t>데이터셋</a:t>
+                      </a:r>
+                    </a:p>
+                  </a:txBody>
+                  <a:tcPr anchor="ctr">
+                    <a:solidFill>
+                      <a:srgbClr val="1E2761"/>
+                    </a:solidFill>
+                  </a:tcPr>
+                </a:tc>
+                <a:tc>
+                  <a:txBody>
+                    <a:bodyPr/>
+                    <a:lstStyle/>
+                    <a:p>
+                      <a:pPr algn="ctr"/>
+                      <a:r>
+                        <a:rPr sz="1200" b="1">
+                          <a:solidFill>
+                            <a:srgbClr val="FFFFFF"/>
+                          </a:solidFill>
+                        </a:rPr>
+                        <a:t>Source+마스킹</a:t>
+                      </a:r>
+                    </a:p>
+                  </a:txBody>
+                  <a:tcPr anchor="ctr">
+                    <a:solidFill>
+                      <a:srgbClr val="1E2761"/>
+                    </a:solidFill>
+                  </a:tcPr>
+                </a:tc>
+                <a:tc>
+                  <a:txBody>
+                    <a:bodyPr/>
+                    <a:lstStyle/>
+                    <a:p>
+                      <a:pPr algn="ctr"/>
+                      <a:r>
+                        <a:rPr sz="1200" b="1">
+                          <a:solidFill>
+                            <a:srgbClr val="FFFFFF"/>
+                          </a:solidFill>
+                        </a:rPr>
+                        <a:t>SHOT+마스킹(최종)</a:t>
+                      </a:r>
+                    </a:p>
+                  </a:txBody>
+                  <a:tcPr anchor="ctr">
+                    <a:solidFill>
+                      <a:srgbClr val="1E2761"/>
+                    </a:solidFill>
+                  </a:tcPr>
+                </a:tc>
+                <a:tc>
+                  <a:txBody>
+                    <a:bodyPr/>
+                    <a:lstStyle/>
+                    <a:p>
+                      <a:pPr algn="ctr"/>
+                      <a:r>
+                        <a:rPr sz="1200" b="1">
+                          <a:solidFill>
+                            <a:srgbClr val="FFFFFF"/>
+                          </a:solidFill>
+                        </a:rPr>
+                        <a:t>EATA+마스킹</a:t>
+                      </a:r>
+                    </a:p>
+                  </a:txBody>
+                  <a:tcPr anchor="ctr">
+                    <a:solidFill>
+                      <a:srgbClr val="1E2761"/>
+                    </a:solidFill>
+                  </a:tcPr>
+                </a:tc>
+              </a:tr>
+              <a:tr h="560000">
+                <a:tc>
+                  <a:txBody>
+                    <a:bodyPr/>
+                    <a:lstStyle/>
+                    <a:p>
+                      <a:pPr algn="ctr"/>
+                      <a:r>
+                        <a:rPr sz="1200" b="0">
+                          <a:solidFill>
+                            <a:srgbClr val="1A1A1A"/>
+                          </a:solidFill>
+                        </a:rPr>
+                        <a:t>Taiwan</a:t>
+                      </a:r>
+                    </a:p>
+                  </a:txBody>
+                  <a:tcPr anchor="ctr">
+                    <a:solidFill>
+                      <a:srgbClr val="FFFFFF"/>
+                    </a:solidFill>
+                  </a:tcPr>
+                </a:tc>
+                <a:tc>
+                  <a:txBody>
+                    <a:bodyPr/>
+                    <a:lstStyle/>
+                    <a:p>
+                      <a:pPr algn="ctr"/>
+                      <a:r>
+                        <a:rPr sz="1200" b="0">
+                          <a:solidFill>
+                            <a:srgbClr val="1A1A1A"/>
+                          </a:solidFill>
+                        </a:rPr>
+                        <a:t>32.48%</a:t>
+                      </a:r>
+                    </a:p>
+                  </a:txBody>
+                  <a:tcPr anchor="ctr">
+                    <a:solidFill>
+                      <a:srgbClr val="FFFFFF"/>
+                    </a:solidFill>
+                  </a:tcPr>
+                </a:tc>
+                <a:tc>
+                  <a:txBody>
+                    <a:bodyPr/>
+                    <a:lstStyle/>
+                    <a:p>
+                      <a:pPr algn="ctr"/>
+                      <a:r>
+                        <a:rPr sz="1200" b="1">
+                          <a:solidFill>
+                            <a:srgbClr val="1A1A1A"/>
+                          </a:solidFill>
+                        </a:rPr>
+                        <a:t>42.04%</a:t>
+                      </a:r>
+                    </a:p>
+                  </a:txBody>
+                  <a:tcPr anchor="ctr">
+                    <a:solidFill>
+                      <a:srgbClr val="FFFFFF"/>
+                    </a:solidFill>
+                  </a:tcPr>
+                </a:tc>
+                <a:tc>
+                  <a:txBody>
+                    <a:bodyPr/>
+                    <a:lstStyle/>
+                    <a:p>
+                      <a:pPr algn="ctr"/>
+                      <a:r>
+                        <a:rPr sz="1200" b="0">
+                          <a:solidFill>
+                            <a:srgbClr val="1A1A1A"/>
+                          </a:solidFill>
+                        </a:rPr>
+                        <a:t>35.35%</a:t>
+                      </a:r>
+                    </a:p>
+                  </a:txBody>
+                  <a:tcPr anchor="ctr">
+                    <a:solidFill>
+                      <a:srgbClr val="FFFFFF"/>
+                    </a:solidFill>
+                  </a:tcPr>
+                </a:tc>
+              </a:tr>
+              <a:tr h="560000">
+                <a:tc>
+                  <a:txBody>
+                    <a:bodyPr/>
+                    <a:lstStyle/>
+                    <a:p>
+                      <a:pPr algn="ctr"/>
+                      <a:r>
+                        <a:rPr sz="1200" b="0">
+                          <a:solidFill>
+                            <a:srgbClr val="1A1A1A"/>
+                          </a:solidFill>
+                        </a:rPr>
+                        <a:t>Bangladesh</a:t>
+                      </a:r>
+                    </a:p>
+                  </a:txBody>
+                  <a:tcPr anchor="ctr">
+                    <a:solidFill>
+                      <a:srgbClr val="EEF3FC"/>
+                    </a:solidFill>
+                  </a:tcPr>
+                </a:tc>
+                <a:tc>
+                  <a:txBody>
+                    <a:bodyPr/>
+                    <a:lstStyle/>
+                    <a:p>
+                      <a:pPr algn="ctr"/>
+                      <a:r>
+                        <a:rPr sz="1200" b="0">
+                          <a:solidFill>
+                            <a:srgbClr val="1A1A1A"/>
+                          </a:solidFill>
+                        </a:rPr>
+                        <a:t>22.34%</a:t>
+                      </a:r>
+                    </a:p>
+                  </a:txBody>
+                  <a:tcPr anchor="ctr">
+                    <a:solidFill>
+                      <a:srgbClr val="EEF3FC"/>
+                    </a:solidFill>
+                  </a:tcPr>
+                </a:tc>
+                <a:tc>
+                  <a:txBody>
+                    <a:bodyPr/>
+                    <a:lstStyle/>
+                    <a:p>
+                      <a:pPr algn="ctr"/>
+                      <a:r>
+                        <a:rPr sz="1200" b="1">
+                          <a:solidFill>
+                            <a:srgbClr val="1A1A1A"/>
+                          </a:solidFill>
+                        </a:rPr>
+                        <a:t>30.79%</a:t>
+                      </a:r>
+                    </a:p>
+                  </a:txBody>
+                  <a:tcPr anchor="ctr">
+                    <a:solidFill>
+                      <a:srgbClr val="EEF3FC"/>
+                    </a:solidFill>
+                  </a:tcPr>
+                </a:tc>
+                <a:tc>
+                  <a:txBody>
+                    <a:bodyPr/>
+                    <a:lstStyle/>
+                    <a:p>
+                      <a:pPr algn="ctr"/>
+                      <a:r>
+                        <a:rPr sz="1200" b="0">
+                          <a:solidFill>
+                            <a:srgbClr val="1A1A1A"/>
+                          </a:solidFill>
+                        </a:rPr>
+                        <a:t>20.89%</a:t>
+                      </a:r>
+                    </a:p>
+                  </a:txBody>
+                  <a:tcPr anchor="ctr">
+                    <a:solidFill>
+                      <a:srgbClr val="EEF3FC"/>
+                    </a:solidFill>
+                  </a:tcPr>
+                </a:tc>
+              </a:tr>
+              <a:tr h="560000">
+                <a:tc>
+                  <a:txBody>
+                    <a:bodyPr/>
+                    <a:lstStyle/>
+                    <a:p>
+                      <a:pPr algn="ctr"/>
+                      <a:r>
+                        <a:rPr sz="1200" b="0">
+                          <a:solidFill>
+                            <a:srgbClr val="1A1A1A"/>
+                          </a:solidFill>
+                        </a:rPr>
+                        <a:t>PlantDoc</a:t>
+                      </a:r>
+                    </a:p>
+                  </a:txBody>
+                  <a:tcPr anchor="ctr">
+                    <a:solidFill>
+                      <a:srgbClr val="FFFFFF"/>
+                    </a:solidFill>
+                  </a:tcPr>
+                </a:tc>
+                <a:tc>
+                  <a:txBody>
+                    <a:bodyPr/>
+                    <a:lstStyle/>
+                    <a:p>
+                      <a:pPr algn="ctr"/>
+                      <a:r>
+                        <a:rPr sz="1200" b="1">
+                          <a:solidFill>
+                            <a:srgbClr val="1A1A1A"/>
+                          </a:solidFill>
+                        </a:rPr>
+                        <a:t>20.31%</a:t>
+                      </a:r>
+                    </a:p>
+                  </a:txBody>
+                  <a:tcPr anchor="ctr">
+                    <a:solidFill>
+                      <a:srgbClr val="FFFFFF"/>
+                    </a:solidFill>
+                  </a:tcPr>
+                </a:tc>
+                <a:tc>
+                  <a:txBody>
+                    <a:bodyPr/>
+                    <a:lstStyle/>
+                    <a:p>
+                      <a:pPr algn="ctr"/>
+                      <a:r>
+                        <a:rPr sz="1200" b="0">
+                          <a:solidFill>
+                            <a:srgbClr val="1A1A1A"/>
+                          </a:solidFill>
+                        </a:rPr>
+                        <a:t>19.46%</a:t>
+                      </a:r>
+                    </a:p>
+                  </a:txBody>
+                  <a:tcPr anchor="ctr">
+                    <a:solidFill>
+                      <a:srgbClr val="FFFFFF"/>
+                    </a:solidFill>
+                  </a:tcPr>
+                </a:tc>
+                <a:tc>
+                  <a:txBody>
+                    <a:bodyPr/>
+                    <a:lstStyle/>
+                    <a:p>
+                      <a:pPr algn="ctr"/>
+                      <a:r>
+                        <a:rPr sz="1200" b="0">
+                          <a:solidFill>
+                            <a:srgbClr val="1A1A1A"/>
+                          </a:solidFill>
+                        </a:rPr>
+                        <a:t>12.27%</a:t>
+                      </a:r>
+                    </a:p>
+                  </a:txBody>
+                  <a:tcPr anchor="ctr">
+                    <a:solidFill>
+                      <a:srgbClr val="FFFFFF"/>
+                    </a:solidFill>
+                  </a:tcPr>
+                </a:tc>
+              </a:tr>
+            </a:tbl>
+          </a:graphicData>
+        </a:graphic>
+      </p:graphicFrame>
+      <p:sp>
+        <p:nvSpPr>
+          <p:cNvPr id="6" name="TextBox 4"/>
+          <p:cNvSpPr txBox="1"/>
+          <p:nvPr/>
+        </p:nvSpPr>
+        <p:spPr>
+          <a:xfrm>
+            <a:off x="548640" y="4850000"/>
+            <a:ext cx="11091672" cy="1450000"/>
+          </a:xfrm>
+          <a:prstGeom prst="rect">
+            <a:avLst/>
+          </a:prstGeom>
+          <a:noFill/>
+        </p:spPr>
+        <p:txBody>
+          <a:bodyPr wrap="square" anchor="t" lIns="0" rIns="0" tIns="0" bIns="0">
+            <a:spAutoFit/>
+          </a:bodyPr>
+          <a:lstStyle/>
+          <a:p>
+            <a:pPr algn="l"/>
+            <a:r>
+              <a:rPr sz="1300" b="0" i="1">
+                <a:solidFill>
+                  <a:srgbClr val="5B5E6B"/>
+                </a:solidFill>
+                <a:latin typeface="Calibri"/>
+              </a:rPr>
+              <a:t>논문 기본 lr(1e-3)로는 거의 적응이 안 일어나 lr=0.1(100배)로 캘리브레이션했다 — entropy·다양성 필터가 ImageNet 1000클래스·대량 스트림 기준이라 클래스 3~8개뿐인 우리 설정엔 유효 gradient가 너무 작았다. 그래도 Taiwan만 마스킹-only를 넘었을 뿐 SHOT은 어디서도 못 넘었고, Bangladesh· PlantDoc은 마스킹-only보다도 낮았다(collapse는 아님) — SHOT을 최종안으로 유지한다.</a:t>
+            </a:r>
+          </a:p>
+        </p:txBody>
+      </p:sp>
+      <p:sp>
+        <p:nvSpPr>
+          <p:cNvPr id="9" name="TextBox 5"/>
+          <p:cNvSpPr txBox="1"/>
+          <p:nvPr/>
+        </p:nvSpPr>
+        <p:spPr>
+          <a:xfrm>
+            <a:off x="11430000" y="6446520"/>
+            <a:ext cx="548640" cy="274320"/>
+          </a:xfrm>
+          <a:prstGeom prst="rect">
+            <a:avLst/>
+          </a:prstGeom>
+          <a:noFill/>
+        </p:spPr>
+        <p:txBody>
+          <a:bodyPr wrap="square" anchor="t" lIns="0" rIns="0" tIns="0" bIns="0">
+            <a:spAutoFit/>
+          </a:bodyPr>
+          <a:lstStyle/>
+          <a:p>
+            <a:pPr algn="r"/>
+            <a:r>
+              <a:rPr sz="1000" b="0" i="0">
+                <a:solidFill>
+                  <a:srgbClr val="5B5E6B"/>
+                </a:solidFill>
+                <a:latin typeface="Calibri"/>
+              </a:rPr>
+              <a:t>29</a:t>
             </a:r>
           </a:p>
         </p:txBody>

</xml_diff>

<commit_message>
docs: PPT에 SHOT 심층 진단·UPA/R-GV/UCon-SFDA 종합 슬라이드 2장 추가 (8/10, 9/10)
RESULT 7 섹션을 8장에서 10장으로 확장 — 심층 진단(oracle 상한실험 표 + 클래스별
precision/recall 핵심 발견) 슬라이드와 UPA(APS/CACL)·R-GV·UCon-SFDA 종합 비교
슬라이드를 신규 추가. 기존 "최종 승자: SHOT" 슬라이드를 "SHOT + APS"로 갱신해
Taiwan 44.59%(F1 0.426) 최종 수치와 APS 컬럼을 테이블에 반영. 전체 슬라이드
번호(1/10~10/10)·푸터 번호 재정렬.

Co-Authored-By: Claude Sonnet 5 <noreply@anthropic.com>
</commit_message>
<xml_diff>
--- a/docs/CNN_토마토_병해분류_V2_진행보고.pptx
+++ b/docs/CNN_토마토_병해분류_V2_진행보고.pptx
@@ -35,6 +35,8 @@
     <p:sldId id="284" r:id="rId28"/>
     <p:sldId id="285" r:id="rId29"/>
     <p:sldId id="288" r:id="rId38"/>
+    <p:sldId id="290" r:id="rId40"/>
+    <p:sldId id="289" r:id="rId39"/>
     <p:sldId id="286" r:id="rId36"/>
     <p:sldId id="277" r:id="rId30"/>
     <p:sldId id="278" r:id="rId31"/>
@@ -17552,7 +17554,7 @@
                 </a:solidFill>
                 <a:latin typeface="Calibri"/>
               </a:rPr>
-              <a:t>RESULT 7 · DOMAIN ADAPTATION (1/8)</a:t>
+              <a:t>RESULT 7 · DOMAIN ADAPTATION (1/10)</a:t>
             </a:r>
           </a:p>
         </p:txBody>
@@ -18311,7 +18313,7 @@
                 </a:solidFill>
                 <a:latin typeface="Calibri"/>
               </a:rPr>
-              <a:t>RESULT 7 · DOMAIN ADAPTATION (2/8)</a:t>
+              <a:t>RESULT 7 · DOMAIN ADAPTATION (2/10)</a:t>
             </a:r>
           </a:p>
         </p:txBody>
@@ -18951,7 +18953,7 @@
                 </a:solidFill>
                 <a:latin typeface="Calibri"/>
               </a:rPr>
-              <a:t>RESULT 7 · DOMAIN ADAPTATION (4/8)</a:t>
+              <a:t>RESULT 7 · DOMAIN ADAPTATION (4/10)</a:t>
             </a:r>
           </a:p>
         </p:txBody>
@@ -18986,7 +18988,7 @@
                 </a:solidFill>
                 <a:latin typeface="Cambria"/>
               </a:rPr>
-              <a:t>최종 승자: SHOT (Pseudo-labeling + Info-max)</a:t>
+              <a:t>최종 승자: SHOT + APS (Pseudo-labeling + Info-max + 신뢰도 기반 선택)</a:t>
             </a:r>
           </a:p>
         </p:txBody>
@@ -19234,7 +19236,7 @@
         </p:nvGraphicFramePr>
         <p:xfrm>
           <a:off x="548640" y="2300000"/>
-          <a:ext cx="8800000" cy="2480000"/>
+          <a:ext cx="10300000" cy="2480000"/>
         </p:xfrm>
         <a:graphic>
           <a:graphicData uri="http://schemas.openxmlformats.org/drawingml/2006/table">
@@ -19243,34 +19245,11 @@
                 <a:tableStyleId>{5C22544A-7EE6-4342-B048-85BDC9FD1C3A}</a:tableStyleId>
               </a:tblPr>
               <a:tblGrid>
-                <a:gridCol w="1700000">
-                  <a:extLst>
-                    <a:ext uri="{9D8B030D-6E8A-4147-A177-3AD203B41FA5}">
-                      <a16:colId xmlns:a16="http://schemas.microsoft.com/office/drawing/2014/main" val="20000"/>
-                    </a:ext>
-                  </a:extLst>
-                </a:gridCol>
-                <a:gridCol w="2100000">
-                  <a:extLst>
-                    <a:ext uri="{9D8B030D-6E8A-4147-A177-3AD203B41FA5}">
-                      <a16:colId xmlns:a16="http://schemas.microsoft.com/office/drawing/2014/main" val="20001"/>
-                    </a:ext>
-                  </a:extLst>
-                </a:gridCol>
-                <a:gridCol w="2100000">
-                  <a:extLst>
-                    <a:ext uri="{9D8B030D-6E8A-4147-A177-3AD203B41FA5}">
-                      <a16:colId xmlns:a16="http://schemas.microsoft.com/office/drawing/2014/main" val="20002"/>
-                    </a:ext>
-                  </a:extLst>
-                </a:gridCol>
-                <a:gridCol w="2900000">
-                  <a:extLst>
-                    <a:ext uri="{9D8B030D-6E8A-4147-A177-3AD203B41FA5}">
-                      <a16:colId xmlns:a16="http://schemas.microsoft.com/office/drawing/2014/main" val="20003"/>
-                    </a:ext>
-                  </a:extLst>
-                </a:gridCol>
+                <a:gridCol w="1700000"/>
+                <a:gridCol w="1900000"/>
+                <a:gridCol w="1900000"/>
+                <a:gridCol w="1900000"/>
+                <a:gridCol w="2900000"/>
               </a:tblGrid>
               <a:tr h="620000">
                 <a:tc>
@@ -19361,11 +19340,28 @@
                     </a:solidFill>
                   </a:tcPr>
                 </a:tc>
-                <a:extLst>
-                  <a:ext uri="{0D108BD9-81ED-4DB2-BD59-A6C34878D82A}">
-                    <a16:rowId xmlns:a16="http://schemas.microsoft.com/office/drawing/2014/main" val="10000"/>
-                  </a:ext>
-                </a:extLst>
+                <a:tc>
+                  <a:txBody>
+                    <a:bodyPr/>
+                    <a:lstStyle/>
+                    <a:p>
+                      <a:pPr algn="ctr"/>
+                      <a:r>
+                        <a:rPr sz="1200" b="1">
+                          <a:solidFill>
+                            <a:srgbClr val="FFFFFF"/>
+                          </a:solidFill>
+                        </a:rPr>
+                        <a:t>SHOT+APS+마스킹(최종)</a:t>
+                      </a:r>
+                    </a:p>
+                  </a:txBody>
+                  <a:tcPr anchor="ctr">
+                    <a:solidFill>
+                      <a:srgbClr val="1E2761"/>
+                    </a:solidFill>
+                  </a:tcPr>
+                </a:tc>
               </a:tr>
               <a:tr h="620000">
                 <a:tc>
@@ -19441,12 +19437,34 @@
                     <a:p>
                       <a:pPr algn="ctr"/>
                       <a:r>
+                        <a:rPr sz="1200" b="0">
+                          <a:solidFill>
+                            <a:srgbClr val="1A1A1A"/>
+                          </a:solidFill>
+                        </a:rPr>
+                        <a:t>42.04%</a:t>
+                      </a:r>
+                    </a:p>
+                  </a:txBody>
+                  <a:tcPr anchor="ctr">
+                    <a:solidFill>
+                      <a:srgbClr val="FFFFFF"/>
+                    </a:solidFill>
+                  </a:tcPr>
+                </a:tc>
+                <a:tc>
+                  <a:txBody>
+                    <a:bodyPr/>
+                    <a:lstStyle/>
+                    <a:p>
+                      <a:pPr algn="ctr"/>
+                      <a:r>
                         <a:rPr sz="1200" b="1">
                           <a:solidFill>
                             <a:srgbClr val="1A1A1A"/>
                           </a:solidFill>
                         </a:rPr>
-                        <a:t>42.04%</a:t>
+                        <a:t>44.59% (F1 0.426)</a:t>
                       </a:r>
                     </a:p>
                   </a:txBody>
@@ -19456,11 +19474,6 @@
                     </a:solidFill>
                   </a:tcPr>
                 </a:tc>
-                <a:extLst>
-                  <a:ext uri="{0D108BD9-81ED-4DB2-BD59-A6C34878D82A}">
-                    <a16:rowId xmlns:a16="http://schemas.microsoft.com/office/drawing/2014/main" val="10001"/>
-                  </a:ext>
-                </a:extLst>
               </a:tr>
               <a:tr h="620000">
                 <a:tc>
@@ -19551,11 +19564,28 @@
                     </a:solidFill>
                   </a:tcPr>
                 </a:tc>
-                <a:extLst>
-                  <a:ext uri="{0D108BD9-81ED-4DB2-BD59-A6C34878D82A}">
-                    <a16:rowId xmlns:a16="http://schemas.microsoft.com/office/drawing/2014/main" val="10002"/>
-                  </a:ext>
-                </a:extLst>
+                <a:tc>
+                  <a:txBody>
+                    <a:bodyPr/>
+                    <a:lstStyle/>
+                    <a:p>
+                      <a:pPr algn="ctr"/>
+                      <a:r>
+                        <a:rPr sz="1200" b="0">
+                          <a:solidFill>
+                            <a:srgbClr val="1A1A1A"/>
+                          </a:solidFill>
+                        </a:rPr>
+                        <a:t>30.52% (거의 동일)</a:t>
+                      </a:r>
+                    </a:p>
+                  </a:txBody>
+                  <a:tcPr anchor="ctr">
+                    <a:solidFill>
+                      <a:srgbClr val="EEF3FC"/>
+                    </a:solidFill>
+                  </a:tcPr>
+                </a:tc>
               </a:tr>
               <a:tr h="620000">
                 <a:tc>
@@ -19587,12 +19617,34 @@
                     <a:p>
                       <a:pPr algn="ctr"/>
                       <a:r>
+                        <a:rPr sz="1200" b="1">
+                          <a:solidFill>
+                            <a:srgbClr val="1A1A1A"/>
+                          </a:solidFill>
+                        </a:rPr>
+                        <a:t>20.31%</a:t>
+                      </a:r>
+                    </a:p>
+                  </a:txBody>
+                  <a:tcPr anchor="ctr">
+                    <a:solidFill>
+                      <a:srgbClr val="FFFFFF"/>
+                    </a:solidFill>
+                  </a:tcPr>
+                </a:tc>
+                <a:tc>
+                  <a:txBody>
+                    <a:bodyPr/>
+                    <a:lstStyle/>
+                    <a:p>
+                      <a:pPr algn="ctr"/>
+                      <a:r>
                         <a:rPr sz="1200" b="0">
                           <a:solidFill>
                             <a:srgbClr val="1A1A1A"/>
                           </a:solidFill>
                         </a:rPr>
-                        <a:t>20.31%</a:t>
+                        <a:t>14.81%</a:t>
                       </a:r>
                     </a:p>
                   </a:txBody>
@@ -19614,7 +19666,7 @@
                             <a:srgbClr val="1A1A1A"/>
                           </a:solidFill>
                         </a:rPr>
-                        <a:t>14.81%</a:t>
+                        <a:t>19.46% (F1 0.182)</a:t>
                       </a:r>
                     </a:p>
                   </a:txBody>
@@ -19631,12 +19683,12 @@
                     <a:p>
                       <a:pPr algn="ctr"/>
                       <a:r>
-                        <a:rPr sz="1200" b="1">
-                          <a:solidFill>
-                            <a:srgbClr val="1A1A1A"/>
-                          </a:solidFill>
-                        </a:rPr>
-                        <a:t>19.46% (F1 0.182 1위)</a:t>
+                        <a:rPr sz="1200" b="0">
+                          <a:solidFill>
+                            <a:srgbClr val="1A1A1A"/>
+                          </a:solidFill>
+                        </a:rPr>
+                        <a:t>19.04% (F1 0.180)</a:t>
                       </a:r>
                     </a:p>
                   </a:txBody>
@@ -19646,11 +19698,6 @@
                     </a:solidFill>
                   </a:tcPr>
                 </a:tc>
-                <a:extLst>
-                  <a:ext uri="{0D108BD9-81ED-4DB2-BD59-A6C34878D82A}">
-                    <a16:rowId xmlns:a16="http://schemas.microsoft.com/office/drawing/2014/main" val="10003"/>
-                  </a:ext>
-                </a:extLst>
               </a:tr>
             </a:tbl>
           </a:graphicData>
@@ -19686,7 +19733,7 @@
                 </a:solidFill>
                 <a:latin typeface="Calibri"/>
               </a:rPr>
-              <a:t>AdaBN/TENT와 달리 SHOT은 3개 데이터셋 전부에서 collapse 없이 안정적으로 잘 됐다 — 데이터셋마다 다른 방법을 골라야 했던 AdaBN/TENT와 달리 튜닝 없이 두루 통하는 유일한 방법이다.</a:t>
+              <a:t>AdaBN/TENT와 달리 SHOT은 3개 데이터셋 전부에서 collapse 없이 안정적으로 잘 됐다. 여기에 신뢰도 기반 pseudo-label 재할당(APS, gamma=1.0)을 더해 Taiwan을 42.04%→44.59%로 끌어올렸다 — 마스킹+SHOT(epoch=2)+APS(gamma=1.0)를 최종 권장 파이프라인으로 정했다.</a:t>
             </a:r>
           </a:p>
         </p:txBody>
@@ -19789,7 +19836,7 @@
                 </a:solidFill>
                 <a:latin typeface="Calibri"/>
               </a:rPr>
-              <a:t>RESULT 7 · DOMAIN ADAPTATION (5/8)</a:t>
+              <a:t>RESULT 7 · DOMAIN ADAPTATION (5/10)</a:t>
             </a:r>
           </a:p>
         </p:txBody>
@@ -20318,7 +20365,7 @@
                 </a:solidFill>
                 <a:latin typeface="Calibri"/>
               </a:rPr>
-              <a:t>RESULT 7 · DOMAIN ADAPTATION (6/8)</a:t>
+              <a:t>RESULT 7 · DOMAIN ADAPTATION (6/10)</a:t>
             </a:r>
           </a:p>
         </p:txBody>
@@ -20388,7 +20435,7 @@
                 </a:solidFill>
                 <a:latin typeface="Calibri"/>
               </a:rPr>
-              <a:t>최종 권장: Class-restriction 마스킹은 항상 적용 + SHOT(epoch=2)을 기본 적응 방법으로 사용</a:t>
+              <a:t>최종 권장: Class-restriction 마스킹은 항상 적용 + SHOT(epoch=2)+APS(gamma=1.0)를 기본 적응 방법으로 사용</a:t>
             </a:r>
           </a:p>
         </p:txBody>
@@ -20458,7 +20505,7 @@
                 </a:solidFill>
                 <a:latin typeface="Calibri"/>
               </a:rPr>
-              <a:t>남은 과제: 지금은 seed42 단일 실행 결과다. tiny_cnn_c(96px·bicubic)를 seed123/2026에서 추가 학습해 이 비교 전체를 3-seed로 재검증할 계획이다(seed123 학습 진행 중).</a:t>
+              <a:t>남은 과제: 이 비교는 아직 seed42 단일 실행 기준이다(최신 후속 방법 비교는 다음 슬라이드부터). tiny_cnn_c(96px·bicubic)를 seed123/2026까지 추가 학습 완료해 이 비교 전체를 3-seed로 재검증하는 중이다.</a:t>
             </a:r>
           </a:p>
         </p:txBody>
@@ -21525,7 +21572,7 @@
                 </a:solidFill>
                 <a:latin typeface="Calibri"/>
               </a:rPr>
-              <a:t>31</a:t>
+              <a:t>33</a:t>
             </a:r>
           </a:p>
         </p:txBody>
@@ -22947,7 +22994,7 @@
                 </a:solidFill>
                 <a:latin typeface="Calibri"/>
               </a:rPr>
-              <a:t>32</a:t>
+              <a:t>34</a:t>
             </a:r>
           </a:p>
         </p:txBody>
@@ -23008,7 +23055,7 @@
                 </a:solidFill>
                 <a:latin typeface="Calibri"/>
               </a:rPr>
-              <a:t>RESULT 7 · DOMAIN ADAPTATION (8/8)</a:t>
+              <a:t>RESULT 7 · DOMAIN ADAPTATION (10/10)</a:t>
             </a:r>
           </a:p>
         </p:txBody>
@@ -23539,7 +23586,7 @@
                 </a:solidFill>
                 <a:latin typeface="Calibri"/>
               </a:rPr>
-              <a:t>30</a:t>
+              <a:t>32</a:t>
             </a:r>
           </a:p>
         </p:txBody>
@@ -23600,7 +23647,7 @@
                 </a:solidFill>
                 <a:latin typeface="Calibri"/>
               </a:rPr>
-              <a:t>RESULT 7 · DOMAIN ADAPTATION (3/8)</a:t>
+              <a:t>RESULT 7 · DOMAIN ADAPTATION (3/10)</a:t>
             </a:r>
           </a:p>
         </p:txBody>
@@ -23959,7 +24006,7 @@
                 </a:solidFill>
                 <a:latin typeface="Calibri"/>
               </a:rPr>
-              <a:t>RESULT 7 · DOMAIN ADAPTATION (7/8)</a:t>
+              <a:t>RESULT 7 · DOMAIN ADAPTATION (7/10)</a:t>
             </a:r>
           </a:p>
         </p:txBody>
@@ -24488,6 +24535,1185 @@
                 <a:latin typeface="Calibri"/>
               </a:rPr>
               <a:t>29</a:t>
+            </a:r>
+          </a:p>
+        </p:txBody>
+      </p:sp>
+    </p:spTree>
+  </p:cSld>
+  <p:clrMapOvr>
+    <a:masterClrMapping/>
+  </p:clrMapOvr>
+</p:sld>
+</file>
+
+<file path=ppt/slides/slide34.xml><?xml version="1.0" encoding="utf-8"?>
+<p:sld xmlns:a="http://schemas.openxmlformats.org/drawingml/2006/main" xmlns:p="http://schemas.openxmlformats.org/presentationml/2006/main" xmlns:r="http://schemas.openxmlformats.org/officeDocument/2006/relationships">
+  <p:cSld>
+    <p:bg>
+      <p:bgPr>
+        <a:solidFill>
+          <a:srgbClr val="FFFFFF"/>
+        </a:solidFill>
+        <a:effectLst/>
+      </p:bgPr>
+    </p:bg>
+    <p:spTree>
+      <p:nvGrpSpPr>
+        <p:cNvPr id="1" name=""/>
+        <p:cNvGrpSpPr/>
+        <p:nvPr/>
+      </p:nvGrpSpPr>
+      <p:grpSpPr/>
+      <p:sp>
+        <p:nvSpPr>
+          <p:cNvPr id="2" name="TextBox 1"/>
+          <p:cNvSpPr txBox="1"/>
+          <p:nvPr/>
+        </p:nvSpPr>
+        <p:spPr>
+          <a:xfrm>
+            <a:off x="548640" y="292608"/>
+            <a:ext cx="9144000" cy="292608"/>
+          </a:xfrm>
+          <a:prstGeom prst="rect">
+            <a:avLst/>
+          </a:prstGeom>
+          <a:noFill/>
+        </p:spPr>
+        <p:txBody>
+          <a:bodyPr wrap="square" anchor="t" lIns="0" rIns="0" tIns="0" bIns="0">
+            <a:spAutoFit/>
+          </a:bodyPr>
+          <a:lstStyle/>
+          <a:p>
+            <a:pPr algn="l"/>
+            <a:r>
+              <a:rPr sz="1050" b="1" i="0">
+                <a:solidFill>
+                  <a:srgbClr val="2A78D6"/>
+                </a:solidFill>
+                <a:latin typeface="Calibri"/>
+              </a:rPr>
+              <a:t>RESULT 7 · DOMAIN ADAPTATION (9/10)</a:t>
+            </a:r>
+          </a:p>
+        </p:txBody>
+      </p:sp>
+      <p:sp>
+        <p:nvSpPr>
+          <p:cNvPr id="3" name="TextBox 2"/>
+          <p:cNvSpPr txBox="1"/>
+          <p:nvPr/>
+        </p:nvSpPr>
+        <p:spPr>
+          <a:xfrm>
+            <a:off x="548640" y="566928"/>
+            <a:ext cx="10972800" cy="548640"/>
+          </a:xfrm>
+          <a:prstGeom prst="rect">
+            <a:avLst/>
+          </a:prstGeom>
+          <a:noFill/>
+        </p:spPr>
+        <p:txBody>
+          <a:bodyPr wrap="square" anchor="t" lIns="0" rIns="0" tIns="0" bIns="0">
+            <a:spAutoFit/>
+          </a:bodyPr>
+          <a:lstStyle/>
+          <a:p>
+            <a:pPr algn="l"/>
+            <a:r>
+              <a:rPr sz="2400" b="1" i="0">
+                <a:solidFill>
+                  <a:srgbClr val="1E2761"/>
+                </a:solidFill>
+                <a:latin typeface="Cambria"/>
+              </a:rPr>
+              <a:t>추가 방법 종합: UPA(APS·CACL) · R-GV · UCon-SFDA</a:t>
+            </a:r>
+          </a:p>
+        </p:txBody>
+      </p:sp>
+      <p:sp>
+        <p:nvSpPr>
+          <p:cNvPr id="4" name="TextBox 3"/>
+          <p:cNvSpPr txBox="1"/>
+          <p:nvPr/>
+        </p:nvSpPr>
+        <p:spPr>
+          <a:xfrm>
+            <a:off x="548640" y="1200000"/>
+            <a:ext cx="11091672" cy="1150000"/>
+          </a:xfrm>
+          <a:prstGeom prst="rect">
+            <a:avLst/>
+          </a:prstGeom>
+          <a:noFill/>
+        </p:spPr>
+        <p:txBody>
+          <a:bodyPr wrap="square" anchor="t" lIns="0" rIns="0" tIns="0" bIns="0">
+            <a:spAutoFit/>
+          </a:bodyPr>
+          <a:lstStyle/>
+          <a:p>
+            <a:pPr algn="l"/>
+            <a:r>
+              <a:rPr sz="1300" b="0" i="0">
+                <a:solidFill>
+                  <a:srgbClr val="1A1A1A"/>
+                </a:solidFill>
+                <a:latin typeface="Calibri"/>
+              </a:rPr>
+              <a:t>SHOT 심층 진단을 바탕으로 최신 SFDA 방법 3가지를 추가 검토했다 — UPA의 두 구성요소(APS/CACL)를 분리 시도, R-GV(CVPR 2025)는 포스터 기반 근사 구현, UCon-SFDA(ICLR 2025)는 논문 본문까지 확인 후 구현은 보류했다.</a:t>
+            </a:r>
+          </a:p>
+        </p:txBody>
+      </p:sp>
+      <p:graphicFrame>
+        <p:nvGraphicFramePr>
+          <p:cNvPr id="7" name="Table"/>
+          <p:cNvGraphicFramePr>
+            <a:graphicFrameLocks noGrp="1"/>
+          </p:cNvGraphicFramePr>
+          <p:nvPr/>
+        </p:nvGraphicFramePr>
+        <p:xfrm>
+          <a:off x="548640" y="2500000"/>
+          <a:ext cx="10300000" cy="2240000"/>
+        </p:xfrm>
+        <a:graphic>
+          <a:graphicData uri="http://schemas.openxmlformats.org/drawingml/2006/table">
+            <a:tbl>
+              <a:tblPr firstRow="1" bandRow="1">
+                <a:tableStyleId>{5C22544A-7EE6-4342-B048-85BDC9FD1C3A}</a:tableStyleId>
+              </a:tblPr>
+              <a:tblGrid>
+                <a:gridCol w="3400000"/>
+                <a:gridCol w="2300000"/>
+                <a:gridCol w="2300000"/>
+                <a:gridCol w="2300000"/>
+              </a:tblGrid>
+              <a:tr h="560000">
+                <a:tc>
+                  <a:txBody>
+                    <a:bodyPr/>
+                    <a:lstStyle/>
+                    <a:p>
+                      <a:pPr algn="ctr"/>
+                      <a:r>
+                        <a:rPr sz="1200" b="1">
+                          <a:solidFill>
+                            <a:srgbClr val="FFFFFF"/>
+                          </a:solidFill>
+                        </a:rPr>
+                        <a:t>방법</a:t>
+                      </a:r>
+                    </a:p>
+                  </a:txBody>
+                  <a:tcPr anchor="ctr">
+                    <a:solidFill>
+                      <a:srgbClr val="1E2761"/>
+                    </a:solidFill>
+                  </a:tcPr>
+                </a:tc>
+                <a:tc>
+                  <a:txBody>
+                    <a:bodyPr/>
+                    <a:lstStyle/>
+                    <a:p>
+                      <a:pPr algn="ctr"/>
+                      <a:r>
+                        <a:rPr sz="1200" b="1">
+                          <a:solidFill>
+                            <a:srgbClr val="FFFFFF"/>
+                          </a:solidFill>
+                        </a:rPr>
+                        <a:t>Taiwan</a:t>
+                      </a:r>
+                    </a:p>
+                  </a:txBody>
+                  <a:tcPr anchor="ctr">
+                    <a:solidFill>
+                      <a:srgbClr val="1E2761"/>
+                    </a:solidFill>
+                  </a:tcPr>
+                </a:tc>
+                <a:tc>
+                  <a:txBody>
+                    <a:bodyPr/>
+                    <a:lstStyle/>
+                    <a:p>
+                      <a:pPr algn="ctr"/>
+                      <a:r>
+                        <a:rPr sz="1200" b="1">
+                          <a:solidFill>
+                            <a:srgbClr val="FFFFFF"/>
+                          </a:solidFill>
+                        </a:rPr>
+                        <a:t>Bangladesh</a:t>
+                      </a:r>
+                    </a:p>
+                  </a:txBody>
+                  <a:tcPr anchor="ctr">
+                    <a:solidFill>
+                      <a:srgbClr val="1E2761"/>
+                    </a:solidFill>
+                  </a:tcPr>
+                </a:tc>
+                <a:tc>
+                  <a:txBody>
+                    <a:bodyPr/>
+                    <a:lstStyle/>
+                    <a:p>
+                      <a:pPr algn="ctr"/>
+                      <a:r>
+                        <a:rPr sz="1200" b="1">
+                          <a:solidFill>
+                            <a:srgbClr val="FFFFFF"/>
+                          </a:solidFill>
+                        </a:rPr>
+                        <a:t>PlantDoc</a:t>
+                      </a:r>
+                    </a:p>
+                  </a:txBody>
+                  <a:tcPr anchor="ctr">
+                    <a:solidFill>
+                      <a:srgbClr val="1E2761"/>
+                    </a:solidFill>
+                  </a:tcPr>
+                </a:tc>
+              </a:tr>
+              <a:tr h="560000">
+                <a:tc>
+                  <a:txBody>
+                    <a:bodyPr/>
+                    <a:lstStyle/>
+                    <a:p>
+                      <a:pPr algn="ctr"/>
+                      <a:r>
+                        <a:rPr sz="1200" b="0">
+                          <a:solidFill>
+                            <a:srgbClr val="1A1A1A"/>
+                          </a:solidFill>
+                        </a:rPr>
+                        <a:t>SHOT+APS+마스킹(최종)</a:t>
+                      </a:r>
+                    </a:p>
+                  </a:txBody>
+                  <a:tcPr anchor="ctr">
+                    <a:solidFill>
+                      <a:srgbClr val="FFFFFF"/>
+                    </a:solidFill>
+                  </a:tcPr>
+                </a:tc>
+                <a:tc>
+                  <a:txBody>
+                    <a:bodyPr/>
+                    <a:lstStyle/>
+                    <a:p>
+                      <a:pPr algn="ctr"/>
+                      <a:r>
+                        <a:rPr sz="1200" b="1">
+                          <a:solidFill>
+                            <a:srgbClr val="1A1A1A"/>
+                          </a:solidFill>
+                        </a:rPr>
+                        <a:t>44.59%</a:t>
+                      </a:r>
+                    </a:p>
+                  </a:txBody>
+                  <a:tcPr anchor="ctr">
+                    <a:solidFill>
+                      <a:srgbClr val="FFFFFF"/>
+                    </a:solidFill>
+                  </a:tcPr>
+                </a:tc>
+                <a:tc>
+                  <a:txBody>
+                    <a:bodyPr/>
+                    <a:lstStyle/>
+                    <a:p>
+                      <a:pPr algn="ctr"/>
+                      <a:r>
+                        <a:rPr sz="1200" b="1">
+                          <a:solidFill>
+                            <a:srgbClr val="1A1A1A"/>
+                          </a:solidFill>
+                        </a:rPr>
+                        <a:t>30.52%</a:t>
+                      </a:r>
+                    </a:p>
+                  </a:txBody>
+                  <a:tcPr anchor="ctr">
+                    <a:solidFill>
+                      <a:srgbClr val="FFFFFF"/>
+                    </a:solidFill>
+                  </a:tcPr>
+                </a:tc>
+                <a:tc>
+                  <a:txBody>
+                    <a:bodyPr/>
+                    <a:lstStyle/>
+                    <a:p>
+                      <a:pPr algn="ctr"/>
+                      <a:r>
+                        <a:rPr sz="1200" b="1">
+                          <a:solidFill>
+                            <a:srgbClr val="1A1A1A"/>
+                          </a:solidFill>
+                        </a:rPr>
+                        <a:t>19.04%</a:t>
+                      </a:r>
+                    </a:p>
+                  </a:txBody>
+                  <a:tcPr anchor="ctr">
+                    <a:solidFill>
+                      <a:srgbClr val="FFFFFF"/>
+                    </a:solidFill>
+                  </a:tcPr>
+                </a:tc>
+              </a:tr>
+              <a:tr h="560000">
+                <a:tc>
+                  <a:txBody>
+                    <a:bodyPr/>
+                    <a:lstStyle/>
+                    <a:p>
+                      <a:pPr algn="ctr"/>
+                      <a:r>
+                        <a:rPr sz="1200" b="0">
+                          <a:solidFill>
+                            <a:srgbClr val="1A1A1A"/>
+                          </a:solidFill>
+                        </a:rPr>
+                        <a:t>SHOT+APS+CACL</a:t>
+                      </a:r>
+                    </a:p>
+                  </a:txBody>
+                  <a:tcPr anchor="ctr">
+                    <a:solidFill>
+                      <a:srgbClr val="EEF3FC"/>
+                    </a:solidFill>
+                  </a:tcPr>
+                </a:tc>
+                <a:tc>
+                  <a:txBody>
+                    <a:bodyPr/>
+                    <a:lstStyle/>
+                    <a:p>
+                      <a:pPr algn="ctr"/>
+                      <a:r>
+                        <a:rPr sz="1200" b="0">
+                          <a:solidFill>
+                            <a:srgbClr val="1A1A1A"/>
+                          </a:solidFill>
+                        </a:rPr>
+                        <a:t>33~38%대</a:t>
+                      </a:r>
+                    </a:p>
+                  </a:txBody>
+                  <a:tcPr anchor="ctr">
+                    <a:solidFill>
+                      <a:srgbClr val="EEF3FC"/>
+                    </a:solidFill>
+                  </a:tcPr>
+                </a:tc>
+                <a:tc>
+                  <a:txBody>
+                    <a:bodyPr/>
+                    <a:lstStyle/>
+                    <a:p>
+                      <a:pPr algn="ctr"/>
+                      <a:r>
+                        <a:rPr sz="1200" b="0">
+                          <a:solidFill>
+                            <a:srgbClr val="1A1A1A"/>
+                          </a:solidFill>
+                        </a:rPr>
+                        <a:t>중립</a:t>
+                      </a:r>
+                    </a:p>
+                  </a:txBody>
+                  <a:tcPr anchor="ctr">
+                    <a:solidFill>
+                      <a:srgbClr val="EEF3FC"/>
+                    </a:solidFill>
+                  </a:tcPr>
+                </a:tc>
+                <a:tc>
+                  <a:txBody>
+                    <a:bodyPr/>
+                    <a:lstStyle/>
+                    <a:p>
+                      <a:pPr algn="ctr"/>
+                      <a:r>
+                        <a:rPr sz="1200" b="0">
+                          <a:solidFill>
+                            <a:srgbClr val="1A1A1A"/>
+                          </a:solidFill>
+                        </a:rPr>
+                        <a:t>중립</a:t>
+                      </a:r>
+                    </a:p>
+                  </a:txBody>
+                  <a:tcPr anchor="ctr">
+                    <a:solidFill>
+                      <a:srgbClr val="EEF3FC"/>
+                    </a:solidFill>
+                  </a:tcPr>
+                </a:tc>
+              </a:tr>
+              <a:tr h="560000">
+                <a:tc>
+                  <a:txBody>
+                    <a:bodyPr/>
+                    <a:lstStyle/>
+                    <a:p>
+                      <a:pPr algn="ctr"/>
+                      <a:r>
+                        <a:rPr sz="1200" b="0">
+                          <a:solidFill>
+                            <a:srgbClr val="1A1A1A"/>
+                          </a:solidFill>
+                        </a:rPr>
+                        <a:t>R-GV(alignment 제외, 근사)</a:t>
+                      </a:r>
+                    </a:p>
+                  </a:txBody>
+                  <a:tcPr anchor="ctr">
+                    <a:solidFill>
+                      <a:srgbClr val="FFFFFF"/>
+                    </a:solidFill>
+                  </a:tcPr>
+                </a:tc>
+                <a:tc>
+                  <a:txBody>
+                    <a:bodyPr/>
+                    <a:lstStyle/>
+                    <a:p>
+                      <a:pPr algn="ctr"/>
+                      <a:r>
+                        <a:rPr sz="1200" b="0">
+                          <a:solidFill>
+                            <a:srgbClr val="1A1A1A"/>
+                          </a:solidFill>
+                        </a:rPr>
+                        <a:t>36.94%</a:t>
+                      </a:r>
+                    </a:p>
+                  </a:txBody>
+                  <a:tcPr anchor="ctr">
+                    <a:solidFill>
+                      <a:srgbClr val="FFFFFF"/>
+                    </a:solidFill>
+                  </a:tcPr>
+                </a:tc>
+                <a:tc>
+                  <a:txBody>
+                    <a:bodyPr/>
+                    <a:lstStyle/>
+                    <a:p>
+                      <a:pPr algn="ctr"/>
+                      <a:r>
+                        <a:rPr sz="1200" b="0">
+                          <a:solidFill>
+                            <a:srgbClr val="1A1A1A"/>
+                          </a:solidFill>
+                        </a:rPr>
+                        <a:t>30.61%</a:t>
+                      </a:r>
+                    </a:p>
+                  </a:txBody>
+                  <a:tcPr anchor="ctr">
+                    <a:solidFill>
+                      <a:srgbClr val="FFFFFF"/>
+                    </a:solidFill>
+                  </a:tcPr>
+                </a:tc>
+                <a:tc>
+                  <a:txBody>
+                    <a:bodyPr/>
+                    <a:lstStyle/>
+                    <a:p>
+                      <a:pPr algn="ctr"/>
+                      <a:r>
+                        <a:rPr sz="1200" b="0">
+                          <a:solidFill>
+                            <a:srgbClr val="1A1A1A"/>
+                          </a:solidFill>
+                        </a:rPr>
+                        <a:t>17.07%</a:t>
+                      </a:r>
+                    </a:p>
+                  </a:txBody>
+                  <a:tcPr anchor="ctr">
+                    <a:solidFill>
+                      <a:srgbClr val="FFFFFF"/>
+                    </a:solidFill>
+                  </a:tcPr>
+                </a:tc>
+              </a:tr>
+              <a:tr h="560000">
+                <a:tc>
+                  <a:txBody>
+                    <a:bodyPr/>
+                    <a:lstStyle/>
+                    <a:p>
+                      <a:pPr algn="ctr"/>
+                      <a:r>
+                        <a:rPr sz="1200" b="0">
+                          <a:solidFill>
+                            <a:srgbClr val="1A1A1A"/>
+                          </a:solidFill>
+                        </a:rPr>
+                        <a:t>UCon-SFDA</a:t>
+                      </a:r>
+                    </a:p>
+                  </a:txBody>
+                  <a:tcPr anchor="ctr">
+                    <a:solidFill>
+                      <a:srgbClr val="EEF3FC"/>
+                    </a:solidFill>
+                  </a:tcPr>
+                </a:tc>
+                <a:tc>
+                  <a:txBody>
+                    <a:bodyPr/>
+                    <a:lstStyle/>
+                    <a:p>
+                      <a:pPr algn="ctr"/>
+                      <a:r>
+                        <a:rPr sz="1200" b="0">
+                          <a:solidFill>
+                            <a:srgbClr val="1A1A1A"/>
+                          </a:solidFill>
+                        </a:rPr>
+                        <a:t>구현 보류</a:t>
+                      </a:r>
+                    </a:p>
+                  </a:txBody>
+                  <a:tcPr anchor="ctr">
+                    <a:solidFill>
+                      <a:srgbClr val="EEF3FC"/>
+                    </a:solidFill>
+                  </a:tcPr>
+                </a:tc>
+                <a:tc>
+                  <a:txBody>
+                    <a:bodyPr/>
+                    <a:lstStyle/>
+                    <a:p>
+                      <a:pPr algn="ctr"/>
+                      <a:r>
+                        <a:rPr sz="1200" b="0">
+                          <a:solidFill>
+                            <a:srgbClr val="1A1A1A"/>
+                          </a:solidFill>
+                        </a:rPr>
+                        <a:t>구현 보류</a:t>
+                      </a:r>
+                    </a:p>
+                  </a:txBody>
+                  <a:tcPr anchor="ctr">
+                    <a:solidFill>
+                      <a:srgbClr val="EEF3FC"/>
+                    </a:solidFill>
+                  </a:tcPr>
+                </a:tc>
+                <a:tc>
+                  <a:txBody>
+                    <a:bodyPr/>
+                    <a:lstStyle/>
+                    <a:p>
+                      <a:pPr algn="ctr"/>
+                      <a:r>
+                        <a:rPr sz="1200" b="0">
+                          <a:solidFill>
+                            <a:srgbClr val="1A1A1A"/>
+                          </a:solidFill>
+                        </a:rPr>
+                        <a:t>구현 보류</a:t>
+                      </a:r>
+                    </a:p>
+                  </a:txBody>
+                  <a:tcPr anchor="ctr">
+                    <a:solidFill>
+                      <a:srgbClr val="EEF3FC"/>
+                    </a:solidFill>
+                  </a:tcPr>
+                </a:tc>
+              </a:tr>
+            </a:tbl>
+          </a:graphicData>
+        </a:graphic>
+      </p:graphicFrame>
+      <p:sp>
+        <p:nvSpPr>
+          <p:cNvPr id="6" name="TextBox 4"/>
+          <p:cNvSpPr txBox="1"/>
+          <p:nvPr/>
+        </p:nvSpPr>
+        <p:spPr>
+          <a:xfrm>
+            <a:off x="548640" y="5050000"/>
+            <a:ext cx="11091672" cy="1300000"/>
+          </a:xfrm>
+          <a:prstGeom prst="rect">
+            <a:avLst/>
+          </a:prstGeom>
+          <a:noFill/>
+        </p:spPr>
+        <p:txBody>
+          <a:bodyPr wrap="square" anchor="t" lIns="0" rIns="0" tIns="0" bIns="0">
+            <a:spAutoFit/>
+          </a:bodyPr>
+          <a:lstStyle/>
+          <a:p>
+            <a:pPr algn="l"/>
+            <a:r>
+              <a:rPr sz="1250" b="0" i="1">
+                <a:solidFill>
+                  <a:srgbClr val="5B5E6B"/>
+                </a:solidFill>
+                <a:latin typeface="Calibri"/>
+              </a:rPr>
+              <a:t>APS(K=4 KNN 재투표, gamma=1.0)만 Taiwan을 개선(42.04%→44.59%); CACL(confident set 내 contrastive loss)과 R-GV의 semantic alignment는 공통적으로 더 나쁘다 — 고정된 classifier(head.fc)와 이를 움직이려는 contrastive/alignment loss가 구조적으로 안 맞는 것으로 보인다. UCon-SFDA는 CACL과 같은 계열(contrastive loss + partial-label)이라 같은 문제를 겪을 가능성이 높고 하이퍼파라미터도 5개(λ_CL, λ_DC, λ_PL, τ, K_PL)로 많아, 구현하지 않고 판단 근거만 기록으로 남긴다.</a:t>
+            </a:r>
+          </a:p>
+        </p:txBody>
+      </p:sp>
+      <p:sp>
+        <p:nvSpPr>
+          <p:cNvPr id="9" name="TextBox 5"/>
+          <p:cNvSpPr txBox="1"/>
+          <p:nvPr/>
+        </p:nvSpPr>
+        <p:spPr>
+          <a:xfrm>
+            <a:off x="11430000" y="6446520"/>
+            <a:ext cx="548640" cy="274320"/>
+          </a:xfrm>
+          <a:prstGeom prst="rect">
+            <a:avLst/>
+          </a:prstGeom>
+          <a:noFill/>
+        </p:spPr>
+        <p:txBody>
+          <a:bodyPr wrap="square" anchor="t" lIns="0" rIns="0" tIns="0" bIns="0">
+            <a:spAutoFit/>
+          </a:bodyPr>
+          <a:lstStyle/>
+          <a:p>
+            <a:pPr algn="r"/>
+            <a:r>
+              <a:rPr sz="1000" b="0" i="0">
+                <a:solidFill>
+                  <a:srgbClr val="5B5E6B"/>
+                </a:solidFill>
+                <a:latin typeface="Calibri"/>
+              </a:rPr>
+              <a:t>31</a:t>
+            </a:r>
+          </a:p>
+        </p:txBody>
+      </p:sp>
+    </p:spTree>
+  </p:cSld>
+  <p:clrMapOvr>
+    <a:masterClrMapping/>
+  </p:clrMapOvr>
+</p:sld>
+</file>
+
+<file path=ppt/slides/slide35.xml><?xml version="1.0" encoding="utf-8"?>
+<p:sld xmlns:a="http://schemas.openxmlformats.org/drawingml/2006/main" xmlns:p="http://schemas.openxmlformats.org/presentationml/2006/main" xmlns:r="http://schemas.openxmlformats.org/officeDocument/2006/relationships">
+  <p:cSld>
+    <p:bg>
+      <p:bgPr>
+        <a:solidFill>
+          <a:srgbClr val="FFFFFF"/>
+        </a:solidFill>
+        <a:effectLst/>
+      </p:bgPr>
+    </p:bg>
+    <p:spTree>
+      <p:nvGrpSpPr>
+        <p:cNvPr id="1" name=""/>
+        <p:cNvGrpSpPr/>
+        <p:nvPr/>
+      </p:nvGrpSpPr>
+      <p:grpSpPr/>
+      <p:sp>
+        <p:nvSpPr>
+          <p:cNvPr id="2" name="TextBox 1"/>
+          <p:cNvSpPr txBox="1"/>
+          <p:nvPr/>
+        </p:nvSpPr>
+        <p:spPr>
+          <a:xfrm>
+            <a:off x="548640" y="292608"/>
+            <a:ext cx="9144000" cy="292608"/>
+          </a:xfrm>
+          <a:prstGeom prst="rect">
+            <a:avLst/>
+          </a:prstGeom>
+          <a:noFill/>
+        </p:spPr>
+        <p:txBody>
+          <a:bodyPr wrap="square" anchor="t" lIns="0" rIns="0" tIns="0" bIns="0">
+            <a:spAutoFit/>
+          </a:bodyPr>
+          <a:lstStyle/>
+          <a:p>
+            <a:pPr algn="l"/>
+            <a:r>
+              <a:rPr sz="1050" b="1" i="0">
+                <a:solidFill>
+                  <a:srgbClr val="2A78D6"/>
+                </a:solidFill>
+                <a:latin typeface="Calibri"/>
+              </a:rPr>
+              <a:t>RESULT 7 · DOMAIN ADAPTATION (8/10)</a:t>
+            </a:r>
+          </a:p>
+        </p:txBody>
+      </p:sp>
+      <p:sp>
+        <p:nvSpPr>
+          <p:cNvPr id="3" name="TextBox 2"/>
+          <p:cNvSpPr txBox="1"/>
+          <p:nvPr/>
+        </p:nvSpPr>
+        <p:spPr>
+          <a:xfrm>
+            <a:off x="548640" y="566928"/>
+            <a:ext cx="10972800" cy="548640"/>
+          </a:xfrm>
+          <a:prstGeom prst="rect">
+            <a:avLst/>
+          </a:prstGeom>
+          <a:noFill/>
+        </p:spPr>
+        <p:txBody>
+          <a:bodyPr wrap="square" anchor="t" lIns="0" rIns="0" tIns="0" bIns="0">
+            <a:spAutoFit/>
+          </a:bodyPr>
+          <a:lstStyle/>
+          <a:p>
+            <a:pPr algn="l"/>
+            <a:r>
+              <a:rPr sz="2400" b="1" i="0">
+                <a:solidFill>
+                  <a:srgbClr val="1E2761"/>
+                </a:solidFill>
+                <a:latin typeface="Cambria"/>
+              </a:rPr>
+              <a:t>심층 진단: SHOT은 정확히 어디서 성공·실패하는가</a:t>
+            </a:r>
+          </a:p>
+        </p:txBody>
+      </p:sp>
+      <p:sp>
+        <p:nvSpPr>
+          <p:cNvPr id="4" name="TextBox 3"/>
+          <p:cNvSpPr txBox="1"/>
+          <p:nvPr/>
+        </p:nvSpPr>
+        <p:spPr>
+          <a:xfrm>
+            <a:off x="548640" y="1200000"/>
+            <a:ext cx="11091672" cy="1150000"/>
+          </a:xfrm>
+          <a:prstGeom prst="rect">
+            <a:avLst/>
+          </a:prstGeom>
+          <a:noFill/>
+        </p:spPr>
+        <p:txBody>
+          <a:bodyPr wrap="square" anchor="t" lIns="0" rIns="0" tIns="0" bIns="0">
+            <a:spAutoFit/>
+          </a:bodyPr>
+          <a:lstStyle/>
+          <a:p>
+            <a:pPr algn="l"/>
+            <a:r>
+              <a:rPr sz="1300" b="0" i="0">
+                <a:solidFill>
+                  <a:srgbClr val="1A1A1A"/>
+                </a:solidFill>
+                <a:latin typeface="Calibri"/>
+              </a:rPr>
+              <a:t>target label을 적응에는 전혀 안 쓰고 진단에만 쓰는 세 가지 분석을 추가했다: ① epoch별 pseudo-label 정확도 추적 ② 초기 클래스별 precision/recall 비교 ③ Oracle 상한 실험(실제 정답으로 fine-tuning, stratified 70/30 train/eval 분리).</a:t>
+            </a:r>
+          </a:p>
+        </p:txBody>
+      </p:sp>
+      <p:graphicFrame>
+        <p:nvGraphicFramePr>
+          <p:cNvPr id="7" name="Table"/>
+          <p:cNvGraphicFramePr>
+            <a:graphicFrameLocks noGrp="1"/>
+          </p:cNvGraphicFramePr>
+          <p:nvPr/>
+        </p:nvGraphicFramePr>
+        <p:xfrm>
+          <a:off x="548640" y="2500000"/>
+          <a:ext cx="9800000" cy="1680000"/>
+        </p:xfrm>
+        <a:graphic>
+          <a:graphicData uri="http://schemas.openxmlformats.org/drawingml/2006/table">
+            <a:tbl>
+              <a:tblPr firstRow="1" bandRow="1">
+                <a:tableStyleId>{5C22544A-7EE6-4342-B048-85BDC9FD1C3A}</a:tableStyleId>
+              </a:tblPr>
+              <a:tblGrid>
+                <a:gridCol w="2800000"/>
+                <a:gridCol w="3200000"/>
+                <a:gridCol w="3800000"/>
+              </a:tblGrid>
+              <a:tr h="560000">
+                <a:tc>
+                  <a:txBody>
+                    <a:bodyPr/>
+                    <a:lstStyle/>
+                    <a:p>
+                      <a:pPr algn="ctr"/>
+                      <a:r>
+                        <a:rPr sz="1200" b="1">
+                          <a:solidFill>
+                            <a:srgbClr val="FFFFFF"/>
+                          </a:solidFill>
+                        </a:rPr>
+                        <a:t>데이터셋</a:t>
+                      </a:r>
+                    </a:p>
+                  </a:txBody>
+                  <a:tcPr anchor="ctr">
+                    <a:solidFill>
+                      <a:srgbClr val="1E2761"/>
+                    </a:solidFill>
+                  </a:tcPr>
+                </a:tc>
+                <a:tc>
+                  <a:txBody>
+                    <a:bodyPr/>
+                    <a:lstStyle/>
+                    <a:p>
+                      <a:pPr algn="ctr"/>
+                      <a:r>
+                        <a:rPr sz="1200" b="1">
+                          <a:solidFill>
+                            <a:srgbClr val="FFFFFF"/>
+                          </a:solidFill>
+                        </a:rPr>
+                        <a:t>Source(eval split)</a:t>
+                      </a:r>
+                    </a:p>
+                  </a:txBody>
+                  <a:tcPr anchor="ctr">
+                    <a:solidFill>
+                      <a:srgbClr val="1E2761"/>
+                    </a:solidFill>
+                  </a:tcPr>
+                </a:tc>
+                <a:tc>
+                  <a:txBody>
+                    <a:bodyPr/>
+                    <a:lstStyle/>
+                    <a:p>
+                      <a:pPr algn="ctr"/>
+                      <a:r>
+                        <a:rPr sz="1200" b="1">
+                          <a:solidFill>
+                            <a:srgbClr val="FFFFFF"/>
+                          </a:solidFill>
+                        </a:rPr>
+                        <a:t>Oracle(정답으로 학습)</a:t>
+                      </a:r>
+                    </a:p>
+                  </a:txBody>
+                  <a:tcPr anchor="ctr">
+                    <a:solidFill>
+                      <a:srgbClr val="1E2761"/>
+                    </a:solidFill>
+                  </a:tcPr>
+                </a:tc>
+              </a:tr>
+              <a:tr h="560000">
+                <a:tc>
+                  <a:txBody>
+                    <a:bodyPr/>
+                    <a:lstStyle/>
+                    <a:p>
+                      <a:pPr algn="ctr"/>
+                      <a:r>
+                        <a:rPr sz="1200" b="0">
+                          <a:solidFill>
+                            <a:srgbClr val="1A1A1A"/>
+                          </a:solidFill>
+                        </a:rPr>
+                        <a:t>Taiwan</a:t>
+                      </a:r>
+                    </a:p>
+                  </a:txBody>
+                  <a:tcPr anchor="ctr">
+                    <a:solidFill>
+                      <a:srgbClr val="FFFFFF"/>
+                    </a:solidFill>
+                  </a:tcPr>
+                </a:tc>
+                <a:tc>
+                  <a:txBody>
+                    <a:bodyPr/>
+                    <a:lstStyle/>
+                    <a:p>
+                      <a:pPr algn="ctr"/>
+                      <a:r>
+                        <a:rPr sz="1200" b="0">
+                          <a:solidFill>
+                            <a:srgbClr val="1A1A1A"/>
+                          </a:solidFill>
+                        </a:rPr>
+                        <a:t>33.68%</a:t>
+                      </a:r>
+                    </a:p>
+                  </a:txBody>
+                  <a:tcPr anchor="ctr">
+                    <a:solidFill>
+                      <a:srgbClr val="FFFFFF"/>
+                    </a:solidFill>
+                  </a:tcPr>
+                </a:tc>
+                <a:tc>
+                  <a:txBody>
+                    <a:bodyPr/>
+                    <a:lstStyle/>
+                    <a:p>
+                      <a:pPr algn="ctr"/>
+                      <a:r>
+                        <a:rPr sz="1200" b="1">
+                          <a:solidFill>
+                            <a:srgbClr val="1A1A1A"/>
+                          </a:solidFill>
+                        </a:rPr>
+                        <a:t>70.53% (+36.9%p)</a:t>
+                      </a:r>
+                    </a:p>
+                  </a:txBody>
+                  <a:tcPr anchor="ctr">
+                    <a:solidFill>
+                      <a:srgbClr val="FFFFFF"/>
+                    </a:solidFill>
+                  </a:tcPr>
+                </a:tc>
+              </a:tr>
+              <a:tr h="560000">
+                <a:tc>
+                  <a:txBody>
+                    <a:bodyPr/>
+                    <a:lstStyle/>
+                    <a:p>
+                      <a:pPr algn="ctr"/>
+                      <a:r>
+                        <a:rPr sz="1200" b="0">
+                          <a:solidFill>
+                            <a:srgbClr val="1A1A1A"/>
+                          </a:solidFill>
+                        </a:rPr>
+                        <a:t>Bangladesh</a:t>
+                      </a:r>
+                    </a:p>
+                  </a:txBody>
+                  <a:tcPr anchor="ctr">
+                    <a:solidFill>
+                      <a:srgbClr val="EEF3FC"/>
+                    </a:solidFill>
+                  </a:tcPr>
+                </a:tc>
+                <a:tc>
+                  <a:txBody>
+                    <a:bodyPr/>
+                    <a:lstStyle/>
+                    <a:p>
+                      <a:pPr algn="ctr"/>
+                      <a:r>
+                        <a:rPr sz="1200" b="0">
+                          <a:solidFill>
+                            <a:srgbClr val="1A1A1A"/>
+                          </a:solidFill>
+                        </a:rPr>
+                        <a:t>22.96%</a:t>
+                      </a:r>
+                    </a:p>
+                  </a:txBody>
+                  <a:tcPr anchor="ctr">
+                    <a:solidFill>
+                      <a:srgbClr val="EEF3FC"/>
+                    </a:solidFill>
+                  </a:tcPr>
+                </a:tc>
+                <a:tc>
+                  <a:txBody>
+                    <a:bodyPr/>
+                    <a:lstStyle/>
+                    <a:p>
+                      <a:pPr algn="ctr"/>
+                      <a:r>
+                        <a:rPr sz="1200" b="1">
+                          <a:solidFill>
+                            <a:srgbClr val="1A1A1A"/>
+                          </a:solidFill>
+                        </a:rPr>
+                        <a:t>58.61% (+35.7%p)</a:t>
+                      </a:r>
+                    </a:p>
+                  </a:txBody>
+                  <a:tcPr anchor="ctr">
+                    <a:solidFill>
+                      <a:srgbClr val="EEF3FC"/>
+                    </a:solidFill>
+                  </a:tcPr>
+                </a:tc>
+              </a:tr>
+              <a:tr h="560000">
+                <a:tc>
+                  <a:txBody>
+                    <a:bodyPr/>
+                    <a:lstStyle/>
+                    <a:p>
+                      <a:pPr algn="ctr"/>
+                      <a:r>
+                        <a:rPr sz="1200" b="0">
+                          <a:solidFill>
+                            <a:srgbClr val="1A1A1A"/>
+                          </a:solidFill>
+                        </a:rPr>
+                        <a:t>PlantDoc</a:t>
+                      </a:r>
+                    </a:p>
+                  </a:txBody>
+                  <a:tcPr anchor="ctr">
+                    <a:solidFill>
+                      <a:srgbClr val="FFFFFF"/>
+                    </a:solidFill>
+                  </a:tcPr>
+                </a:tc>
+                <a:tc>
+                  <a:txBody>
+                    <a:bodyPr/>
+                    <a:lstStyle/>
+                    <a:p>
+                      <a:pPr algn="ctr"/>
+                      <a:r>
+                        <a:rPr sz="1200" b="0">
+                          <a:solidFill>
+                            <a:srgbClr val="1A1A1A"/>
+                          </a:solidFill>
+                        </a:rPr>
+                        <a:t>23.47%</a:t>
+                      </a:r>
+                    </a:p>
+                  </a:txBody>
+                  <a:tcPr anchor="ctr">
+                    <a:solidFill>
+                      <a:srgbClr val="FFFFFF"/>
+                    </a:solidFill>
+                  </a:tcPr>
+                </a:tc>
+                <a:tc>
+                  <a:txBody>
+                    <a:bodyPr/>
+                    <a:lstStyle/>
+                    <a:p>
+                      <a:pPr algn="ctr"/>
+                      <a:r>
+                        <a:rPr sz="1200" b="1">
+                          <a:solidFill>
+                            <a:srgbClr val="1A1A1A"/>
+                          </a:solidFill>
+                        </a:rPr>
+                        <a:t>23.47% (변화 없음)</a:t>
+                      </a:r>
+                    </a:p>
+                  </a:txBody>
+                  <a:tcPr anchor="ctr">
+                    <a:solidFill>
+                      <a:srgbClr val="FFFFFF"/>
+                    </a:solidFill>
+                  </a:tcPr>
+                </a:tc>
+              </a:tr>
+            </a:tbl>
+          </a:graphicData>
+        </a:graphic>
+      </p:graphicFrame>
+      <p:sp>
+        <p:nvSpPr>
+          <p:cNvPr id="6" name="TextBox 4"/>
+          <p:cNvSpPr txBox="1"/>
+          <p:nvPr/>
+        </p:nvSpPr>
+        <p:spPr>
+          <a:xfrm>
+            <a:off x="548640" y="4400000"/>
+            <a:ext cx="11091672" cy="1900000"/>
+          </a:xfrm>
+          <a:prstGeom prst="rect">
+            <a:avLst/>
+          </a:prstGeom>
+          <a:noFill/>
+        </p:spPr>
+        <p:txBody>
+          <a:bodyPr wrap="square" anchor="t" lIns="0" rIns="0" tIns="0" bIns="0">
+            <a:spAutoFit/>
+          </a:bodyPr>
+          <a:lstStyle/>
+          <a:p>
+            <a:pPr algn="l"/>
+            <a:r>
+              <a:rPr sz="1250" b="0" i="1">
+                <a:solidFill>
+                  <a:srgbClr val="5B5E6B"/>
+                </a:solidFill>
+                <a:latin typeface="Calibri"/>
+              </a:rPr>
+              <a:t>① Taiwan: healthy가 0% precision·recall로 Late_blight에 흡수되는 사각지대(SHOT 후에도 그대로). ② Bangladesh: SHOT이 Late_blight 쏠림을 Target_Spot 쏠림으로 옮길 뿐(recall 0→43%, 대신 Late_blight 60→22%). ③ PlantDoc: source 단계에서 이미 3개 클래스가 0%이고, SHOT을 거쳐도 기존 클래스 recall이 반토막나며 상쇄된다. Oracle 결과: Taiwan·Bangladesh는 정답만 있으면 2배 이상 뛰어 pseudo-label 품질이 핵심 병목임을 확인. PlantDoc은 train 정확도만 19%→27%로 오르고 eval은 그대로(과적합) — 병목이 feature 표현력 자체라는 신호.</a:t>
+            </a:r>
+          </a:p>
+        </p:txBody>
+      </p:sp>
+      <p:sp>
+        <p:nvSpPr>
+          <p:cNvPr id="9" name="TextBox 5"/>
+          <p:cNvSpPr txBox="1"/>
+          <p:nvPr/>
+        </p:nvSpPr>
+        <p:spPr>
+          <a:xfrm>
+            <a:off x="11430000" y="6446520"/>
+            <a:ext cx="548640" cy="274320"/>
+          </a:xfrm>
+          <a:prstGeom prst="rect">
+            <a:avLst/>
+          </a:prstGeom>
+          <a:noFill/>
+        </p:spPr>
+        <p:txBody>
+          <a:bodyPr wrap="square" anchor="t" lIns="0" rIns="0" tIns="0" bIns="0">
+            <a:spAutoFit/>
+          </a:bodyPr>
+          <a:lstStyle/>
+          <a:p>
+            <a:pPr algn="r"/>
+            <a:r>
+              <a:rPr sz="1000" b="0" i="0">
+                <a:solidFill>
+                  <a:srgbClr val="5B5E6B"/>
+                </a:solidFill>
+                <a:latin typeface="Calibri"/>
+              </a:rPr>
+              <a:t>30</a:t>
             </a:r>
           </a:p>
         </p:txBody>

</xml_diff>

<commit_message>
feat: tiny_cnn_c 3-seed DA 검증 완료 — APS 개선은 noise로 판명, SHOT(epoch=2) 단독을 최종안으로 재확정
seed123/2026까지 Source/AdaBN/SHOT/SHOT+APS 전체를 재평가해 3-seed 평균±표준편차를 확보했다.
seed42 단일 실행에서는 APS가 Taiwan을 42.04%→44.59%로 개선하는 것처럼 보였지만, 3-seed 평균으로는
SHOT+APS가 모든 데이터셋에서 SHOT 단독보다 오히려 근소하게 낮고 그 차이가 seed 간 표준편차
(5~6%p)보다 작아 noise 범위를 벗어나지 못한다. 단일 seed로 하이퍼파라미터/구성요소를 확정하면
안 된다는 교훈과 함께, 최종 권장 파이프라인을 "마스킹 + SHOT(epoch=2)"(APS 제외)로 되돌렸다.

README의 "최종 승자" 절과 가설 1 재검증 결과를 갱신하고, PPT RESULT 7 섹션에 3-seed 검증 전용
슬라이드(5/11)를 신규 추가해 10장→11장으로 확장, 전체 슬라이드 번호/푸터를 재정렬했다.

Co-Authored-By: Claude Sonnet 5 <noreply@anthropic.com>
</commit_message>
<xml_diff>
--- a/docs/CNN_토마토_병해분류_V2_진행보고.pptx
+++ b/docs/CNN_토마토_병해분류_V2_진행보고.pptx
@@ -32,6 +32,7 @@
     <p:sldId id="282" r:id="rId26"/>
     <p:sldId id="287" r:id="rId37"/>
     <p:sldId id="283" r:id="rId27"/>
+    <p:sldId id="291" r:id="rId41"/>
     <p:sldId id="284" r:id="rId28"/>
     <p:sldId id="285" r:id="rId29"/>
     <p:sldId id="288" r:id="rId38"/>
@@ -17554,7 +17555,7 @@
                 </a:solidFill>
                 <a:latin typeface="Calibri"/>
               </a:rPr>
-              <a:t>RESULT 7 · DOMAIN ADAPTATION (1/10)</a:t>
+              <a:t>RESULT 7 · DOMAIN ADAPTATION (1/11)</a:t>
             </a:r>
           </a:p>
         </p:txBody>
@@ -18313,7 +18314,7 @@
                 </a:solidFill>
                 <a:latin typeface="Calibri"/>
               </a:rPr>
-              <a:t>RESULT 7 · DOMAIN ADAPTATION (2/10)</a:t>
+              <a:t>RESULT 7 · DOMAIN ADAPTATION (2/11)</a:t>
             </a:r>
           </a:p>
         </p:txBody>
@@ -18953,7 +18954,7 @@
                 </a:solidFill>
                 <a:latin typeface="Calibri"/>
               </a:rPr>
-              <a:t>RESULT 7 · DOMAIN ADAPTATION (4/10)</a:t>
+              <a:t>RESULT 7 · DOMAIN ADAPTATION (4/11)</a:t>
             </a:r>
           </a:p>
         </p:txBody>
@@ -18988,7 +18989,7 @@
                 </a:solidFill>
                 <a:latin typeface="Cambria"/>
               </a:rPr>
-              <a:t>최종 승자: SHOT + APS (Pseudo-labeling + Info-max + 신뢰도 기반 선택)</a:t>
+              <a:t>최종 승자: SHOT (Pseudo-labeling + Info-max) — APS는 3-seed에서 기각</a:t>
             </a:r>
           </a:p>
         </p:txBody>
@@ -19330,7 +19331,7 @@
                             <a:srgbClr val="FFFFFF"/>
                           </a:solidFill>
                         </a:rPr>
-                        <a:t>SHOT+마스킹(epoch=2)</a:t>
+                        <a:t>SHOT+마스킹(epoch=2, 최종)</a:t>
                       </a:r>
                     </a:p>
                   </a:txBody>
@@ -19352,7 +19353,7 @@
                             <a:srgbClr val="FFFFFF"/>
                           </a:solidFill>
                         </a:rPr>
-                        <a:t>SHOT+APS+마스킹(최종)</a:t>
+                        <a:t>SHOT+APS+마스킹</a:t>
                       </a:r>
                     </a:p>
                   </a:txBody>
@@ -19437,29 +19438,29 @@
                     <a:p>
                       <a:pPr algn="ctr"/>
                       <a:r>
+                        <a:rPr sz="1200" b="1">
+                          <a:solidFill>
+                            <a:srgbClr val="1A1A1A"/>
+                          </a:solidFill>
+                        </a:rPr>
+                        <a:t>42.04%</a:t>
+                      </a:r>
+                    </a:p>
+                  </a:txBody>
+                  <a:tcPr anchor="ctr">
+                    <a:solidFill>
+                      <a:srgbClr val="FFFFFF"/>
+                    </a:solidFill>
+                  </a:tcPr>
+                </a:tc>
+                <a:tc>
+                  <a:txBody>
+                    <a:bodyPr/>
+                    <a:lstStyle/>
+                    <a:p>
+                      <a:pPr algn="ctr"/>
+                      <a:r>
                         <a:rPr sz="1200" b="0">
-                          <a:solidFill>
-                            <a:srgbClr val="1A1A1A"/>
-                          </a:solidFill>
-                        </a:rPr>
-                        <a:t>42.04%</a:t>
-                      </a:r>
-                    </a:p>
-                  </a:txBody>
-                  <a:tcPr anchor="ctr">
-                    <a:solidFill>
-                      <a:srgbClr val="FFFFFF"/>
-                    </a:solidFill>
-                  </a:tcPr>
-                </a:tc>
-                <a:tc>
-                  <a:txBody>
-                    <a:bodyPr/>
-                    <a:lstStyle/>
-                    <a:p>
-                      <a:pPr algn="ctr"/>
-                      <a:r>
-                        <a:rPr sz="1200" b="1">
                           <a:solidFill>
                             <a:srgbClr val="1A1A1A"/>
                           </a:solidFill>
@@ -19617,51 +19618,51 @@
                     <a:p>
                       <a:pPr algn="ctr"/>
                       <a:r>
+                        <a:rPr sz="1200" b="0">
+                          <a:solidFill>
+                            <a:srgbClr val="1A1A1A"/>
+                          </a:solidFill>
+                        </a:rPr>
+                        <a:t>20.31%</a:t>
+                      </a:r>
+                    </a:p>
+                  </a:txBody>
+                  <a:tcPr anchor="ctr">
+                    <a:solidFill>
+                      <a:srgbClr val="FFFFFF"/>
+                    </a:solidFill>
+                  </a:tcPr>
+                </a:tc>
+                <a:tc>
+                  <a:txBody>
+                    <a:bodyPr/>
+                    <a:lstStyle/>
+                    <a:p>
+                      <a:pPr algn="ctr"/>
+                      <a:r>
+                        <a:rPr sz="1200" b="0">
+                          <a:solidFill>
+                            <a:srgbClr val="1A1A1A"/>
+                          </a:solidFill>
+                        </a:rPr>
+                        <a:t>14.81%</a:t>
+                      </a:r>
+                    </a:p>
+                  </a:txBody>
+                  <a:tcPr anchor="ctr">
+                    <a:solidFill>
+                      <a:srgbClr val="FFFFFF"/>
+                    </a:solidFill>
+                  </a:tcPr>
+                </a:tc>
+                <a:tc>
+                  <a:txBody>
+                    <a:bodyPr/>
+                    <a:lstStyle/>
+                    <a:p>
+                      <a:pPr algn="ctr"/>
+                      <a:r>
                         <a:rPr sz="1200" b="1">
-                          <a:solidFill>
-                            <a:srgbClr val="1A1A1A"/>
-                          </a:solidFill>
-                        </a:rPr>
-                        <a:t>20.31%</a:t>
-                      </a:r>
-                    </a:p>
-                  </a:txBody>
-                  <a:tcPr anchor="ctr">
-                    <a:solidFill>
-                      <a:srgbClr val="FFFFFF"/>
-                    </a:solidFill>
-                  </a:tcPr>
-                </a:tc>
-                <a:tc>
-                  <a:txBody>
-                    <a:bodyPr/>
-                    <a:lstStyle/>
-                    <a:p>
-                      <a:pPr algn="ctr"/>
-                      <a:r>
-                        <a:rPr sz="1200" b="0">
-                          <a:solidFill>
-                            <a:srgbClr val="1A1A1A"/>
-                          </a:solidFill>
-                        </a:rPr>
-                        <a:t>14.81%</a:t>
-                      </a:r>
-                    </a:p>
-                  </a:txBody>
-                  <a:tcPr anchor="ctr">
-                    <a:solidFill>
-                      <a:srgbClr val="FFFFFF"/>
-                    </a:solidFill>
-                  </a:tcPr>
-                </a:tc>
-                <a:tc>
-                  <a:txBody>
-                    <a:bodyPr/>
-                    <a:lstStyle/>
-                    <a:p>
-                      <a:pPr algn="ctr"/>
-                      <a:r>
-                        <a:rPr sz="1200" b="0">
                           <a:solidFill>
                             <a:srgbClr val="1A1A1A"/>
                           </a:solidFill>
@@ -19733,7 +19734,7 @@
                 </a:solidFill>
                 <a:latin typeface="Calibri"/>
               </a:rPr>
-              <a:t>AdaBN/TENT와 달리 SHOT은 3개 데이터셋 전부에서 collapse 없이 안정적으로 잘 됐다. 여기에 신뢰도 기반 pseudo-label 재할당(APS, gamma=1.0)을 더해 Taiwan을 42.04%→44.59%로 끌어올렸다 — 마스킹+SHOT(epoch=2)+APS(gamma=1.0)를 최종 권장 파이프라인으로 정했다.</a:t>
+              <a:t>AdaBN/TENT와 달리 SHOT은 3개 데이터셋 전부에서 collapse 없이 안정적으로 잘 됐다 — 마스킹+SHOT(epoch=2)이 최종 권장 파이프라인이다. APS(신뢰도 기반 재할당)는 seed42에서만 Taiwan을 44.59%로 끌어올려 보였으나, 3-seed로 검증하니 평균은 SHOT 단독보다 오히려 낮아 noise로 판명됐다(5/11 슬라이드 참고) — 기본값에서 제외한다.</a:t>
             </a:r>
           </a:p>
         </p:txBody>
@@ -19836,7 +19837,7 @@
                 </a:solidFill>
                 <a:latin typeface="Calibri"/>
               </a:rPr>
-              <a:t>RESULT 7 · DOMAIN ADAPTATION (5/10)</a:t>
+              <a:t>RESULT 7 · DOMAIN ADAPTATION (6/11)</a:t>
             </a:r>
           </a:p>
         </p:txBody>
@@ -20297,7 +20298,7 @@
                 </a:solidFill>
                 <a:latin typeface="Calibri"/>
               </a:rPr>
-              <a:t>27</a:t>
+              <a:t>28</a:t>
             </a:r>
           </a:p>
         </p:txBody>
@@ -20365,7 +20366,7 @@
                 </a:solidFill>
                 <a:latin typeface="Calibri"/>
               </a:rPr>
-              <a:t>RESULT 7 · DOMAIN ADAPTATION (6/10)</a:t>
+              <a:t>RESULT 7 · DOMAIN ADAPTATION (7/11)</a:t>
             </a:r>
           </a:p>
         </p:txBody>
@@ -20435,7 +20436,7 @@
                 </a:solidFill>
                 <a:latin typeface="Calibri"/>
               </a:rPr>
-              <a:t>최종 권장: Class-restriction 마스킹은 항상 적용 + SHOT(epoch=2)+APS(gamma=1.0)를 기본 적응 방법으로 사용</a:t>
+              <a:t>최종 권장: Class-restriction 마스킹은 항상 적용 + SHOT(epoch=2)을 기본 적응 방법으로 사용</a:t>
             </a:r>
           </a:p>
         </p:txBody>
@@ -20505,7 +20506,7 @@
                 </a:solidFill>
                 <a:latin typeface="Calibri"/>
               </a:rPr>
-              <a:t>남은 과제: 이 비교는 아직 seed42 단일 실행 기준이다(최신 후속 방법 비교는 다음 슬라이드부터). tiny_cnn_c(96px·bicubic)를 seed123/2026까지 추가 학습 완료해 이 비교 전체를 3-seed로 재검증하는 중이다.</a:t>
+              <a:t>3-seed 검증 완료: seed123/2026까지 추가 학습해 재평가한 결과, SHOT(epoch=2)의 3-seed 평균이 SHOT+APS보다 모든 데이터셋에서 근소하게 높았다 — 그래서 APS 없는 순수 SHOT을 최종으로 확정했다(5/11 슬라이드에 평균±표준편차 표 참고).</a:t>
             </a:r>
           </a:p>
         </p:txBody>
@@ -20540,7 +20541,7 @@
                 </a:solidFill>
                 <a:latin typeface="Calibri"/>
               </a:rPr>
-              <a:t>28</a:t>
+              <a:t>29</a:t>
             </a:r>
           </a:p>
         </p:txBody>
@@ -21572,7 +21573,7 @@
                 </a:solidFill>
                 <a:latin typeface="Calibri"/>
               </a:rPr>
-              <a:t>33</a:t>
+              <a:t>34</a:t>
             </a:r>
           </a:p>
         </p:txBody>
@@ -22994,7 +22995,7 @@
                 </a:solidFill>
                 <a:latin typeface="Calibri"/>
               </a:rPr>
-              <a:t>34</a:t>
+              <a:t>35</a:t>
             </a:r>
           </a:p>
         </p:txBody>
@@ -23055,7 +23056,7 @@
                 </a:solidFill>
                 <a:latin typeface="Calibri"/>
               </a:rPr>
-              <a:t>RESULT 7 · DOMAIN ADAPTATION (10/10)</a:t>
+              <a:t>RESULT 7 · DOMAIN ADAPTATION (11/11)</a:t>
             </a:r>
           </a:p>
         </p:txBody>
@@ -23586,7 +23587,7 @@
                 </a:solidFill>
                 <a:latin typeface="Calibri"/>
               </a:rPr>
-              <a:t>32</a:t>
+              <a:t>33</a:t>
             </a:r>
           </a:p>
         </p:txBody>
@@ -23647,7 +23648,7 @@
                 </a:solidFill>
                 <a:latin typeface="Calibri"/>
               </a:rPr>
-              <a:t>RESULT 7 · DOMAIN ADAPTATION (3/10)</a:t>
+              <a:t>RESULT 7 · DOMAIN ADAPTATION (3/11)</a:t>
             </a:r>
           </a:p>
         </p:txBody>
@@ -24006,7 +24007,7 @@
                 </a:solidFill>
                 <a:latin typeface="Calibri"/>
               </a:rPr>
-              <a:t>RESULT 7 · DOMAIN ADAPTATION (7/10)</a:t>
+              <a:t>RESULT 7 · DOMAIN ADAPTATION (8/11)</a:t>
             </a:r>
           </a:p>
         </p:txBody>
@@ -24534,7 +24535,7 @@
                 </a:solidFill>
                 <a:latin typeface="Calibri"/>
               </a:rPr>
-              <a:t>29</a:t>
+              <a:t>30</a:t>
             </a:r>
           </a:p>
         </p:txBody>
@@ -24595,7 +24596,7 @@
                 </a:solidFill>
                 <a:latin typeface="Calibri"/>
               </a:rPr>
-              <a:t>RESULT 7 · DOMAIN ADAPTATION (9/10)</a:t>
+              <a:t>RESULT 7 · DOMAIN ADAPTATION (10/11)</a:t>
             </a:r>
           </a:p>
         </p:txBody>
@@ -25213,7 +25214,7 @@
                 </a:solidFill>
                 <a:latin typeface="Calibri"/>
               </a:rPr>
-              <a:t>31</a:t>
+              <a:t>32</a:t>
             </a:r>
           </a:p>
         </p:txBody>
@@ -25274,7 +25275,7 @@
                 </a:solidFill>
                 <a:latin typeface="Calibri"/>
               </a:rPr>
-              <a:t>RESULT 7 · DOMAIN ADAPTATION (8/10)</a:t>
+              <a:t>RESULT 7 · DOMAIN ADAPTATION (9/11)</a:t>
             </a:r>
           </a:p>
         </p:txBody>
@@ -25713,7 +25714,686 @@
                 </a:solidFill>
                 <a:latin typeface="Calibri"/>
               </a:rPr>
-              <a:t>30</a:t>
+              <a:t>31</a:t>
+            </a:r>
+          </a:p>
+        </p:txBody>
+      </p:sp>
+    </p:spTree>
+  </p:cSld>
+  <p:clrMapOvr>
+    <a:masterClrMapping/>
+  </p:clrMapOvr>
+</p:sld>
+</file>
+
+<file path=ppt/slides/slide36.xml><?xml version="1.0" encoding="utf-8"?>
+<p:sld xmlns:a="http://schemas.openxmlformats.org/drawingml/2006/main" xmlns:p="http://schemas.openxmlformats.org/presentationml/2006/main" xmlns:r="http://schemas.openxmlformats.org/officeDocument/2006/relationships">
+  <p:cSld>
+    <p:bg>
+      <p:bgPr>
+        <a:solidFill>
+          <a:srgbClr val="FFFFFF"/>
+        </a:solidFill>
+        <a:effectLst/>
+      </p:bgPr>
+    </p:bg>
+    <p:spTree>
+      <p:nvGrpSpPr>
+        <p:cNvPr id="1" name=""/>
+        <p:cNvGrpSpPr/>
+        <p:nvPr/>
+      </p:nvGrpSpPr>
+      <p:grpSpPr/>
+      <p:sp>
+        <p:nvSpPr>
+          <p:cNvPr id="2" name="TextBox 1"/>
+          <p:cNvSpPr txBox="1"/>
+          <p:nvPr/>
+        </p:nvSpPr>
+        <p:spPr>
+          <a:xfrm>
+            <a:off x="548640" y="292608"/>
+            <a:ext cx="9144000" cy="292608"/>
+          </a:xfrm>
+          <a:prstGeom prst="rect">
+            <a:avLst/>
+          </a:prstGeom>
+          <a:noFill/>
+        </p:spPr>
+        <p:txBody>
+          <a:bodyPr wrap="square" anchor="t" lIns="0" rIns="0" tIns="0" bIns="0">
+            <a:spAutoFit/>
+          </a:bodyPr>
+          <a:lstStyle/>
+          <a:p>
+            <a:pPr algn="l"/>
+            <a:r>
+              <a:rPr sz="1050" b="1" i="0">
+                <a:solidFill>
+                  <a:srgbClr val="2A78D6"/>
+                </a:solidFill>
+                <a:latin typeface="Calibri"/>
+              </a:rPr>
+              <a:t>RESULT 7 · DOMAIN ADAPTATION (5/11)</a:t>
+            </a:r>
+          </a:p>
+        </p:txBody>
+      </p:sp>
+      <p:sp>
+        <p:nvSpPr>
+          <p:cNvPr id="3" name="TextBox 2"/>
+          <p:cNvSpPr txBox="1"/>
+          <p:nvPr/>
+        </p:nvSpPr>
+        <p:spPr>
+          <a:xfrm>
+            <a:off x="548640" y="566928"/>
+            <a:ext cx="10972800" cy="548640"/>
+          </a:xfrm>
+          <a:prstGeom prst="rect">
+            <a:avLst/>
+          </a:prstGeom>
+          <a:noFill/>
+        </p:spPr>
+        <p:txBody>
+          <a:bodyPr wrap="square" anchor="t" lIns="0" rIns="0" tIns="0" bIns="0">
+            <a:spAutoFit/>
+          </a:bodyPr>
+          <a:lstStyle/>
+          <a:p>
+            <a:pPr algn="l"/>
+            <a:r>
+              <a:rPr sz="2400" b="1" i="0">
+                <a:solidFill>
+                  <a:srgbClr val="1E2761"/>
+                </a:solidFill>
+                <a:latin typeface="Cambria"/>
+              </a:rPr>
+              <a:t>3-seed 검증: APS의 개선은 noise 범위였다</a:t>
+            </a:r>
+          </a:p>
+        </p:txBody>
+      </p:sp>
+      <p:sp>
+        <p:nvSpPr>
+          <p:cNvPr id="4" name="TextBox 3"/>
+          <p:cNvSpPr txBox="1"/>
+          <p:nvPr/>
+        </p:nvSpPr>
+        <p:spPr>
+          <a:xfrm>
+            <a:off x="548640" y="1200000"/>
+            <a:ext cx="11091672" cy="1000000"/>
+          </a:xfrm>
+          <a:prstGeom prst="rect">
+            <a:avLst/>
+          </a:prstGeom>
+          <a:noFill/>
+        </p:spPr>
+        <p:txBody>
+          <a:bodyPr wrap="square" anchor="t" lIns="0" rIns="0" tIns="0" bIns="0">
+            <a:spAutoFit/>
+          </a:bodyPr>
+          <a:lstStyle/>
+          <a:p>
+            <a:pPr algn="l"/>
+            <a:r>
+              <a:rPr sz="1300" b="0" i="0">
+                <a:solidFill>
+                  <a:srgbClr val="1A1A1A"/>
+                </a:solidFill>
+                <a:latin typeface="Calibri"/>
+              </a:rPr>
+              <a:t>seed42 하나로는 어떤 개선이 진짜인지 운인지 구분이 안 된다. tiny_cnn_c(96px·bicubic)를 seed123/2026에서 추가 학습해 Source/AdaBN/SHOT/SHOT+APS 비교를 3-seed 평균±표준편차로 다시 봤다.</a:t>
+            </a:r>
+          </a:p>
+        </p:txBody>
+      </p:sp>
+      <p:graphicFrame>
+        <p:nvGraphicFramePr>
+          <p:cNvPr id="7" name="Table"/>
+          <p:cNvGraphicFramePr>
+            <a:graphicFrameLocks noGrp="1"/>
+          </p:cNvGraphicFramePr>
+          <p:nvPr/>
+        </p:nvGraphicFramePr>
+        <p:xfrm>
+          <a:off x="548640" y="2350000"/>
+          <a:ext cx="10300000" cy="2400000"/>
+        </p:xfrm>
+        <a:graphic>
+          <a:graphicData uri="http://schemas.openxmlformats.org/drawingml/2006/table">
+            <a:tbl>
+              <a:tblPr firstRow="1" bandRow="1">
+                <a:tableStyleId>{5C22544A-7EE6-4342-B048-85BDC9FD1C3A}</a:tableStyleId>
+              </a:tblPr>
+              <a:tblGrid>
+                <a:gridCol w="3400000"/>
+                <a:gridCol w="2300000"/>
+                <a:gridCol w="2300000"/>
+                <a:gridCol w="2300000"/>
+              </a:tblGrid>
+              <a:tr h="560000">
+                <a:tc>
+                  <a:txBody>
+                    <a:bodyPr/>
+                    <a:lstStyle/>
+                    <a:p>
+                      <a:pPr algn="ctr"/>
+                      <a:r>
+                        <a:rPr sz="1200" b="1">
+                          <a:solidFill>
+                            <a:srgbClr val="FFFFFF"/>
+                          </a:solidFill>
+                        </a:rPr>
+                        <a:t>방법</a:t>
+                      </a:r>
+                    </a:p>
+                  </a:txBody>
+                  <a:tcPr anchor="ctr">
+                    <a:solidFill>
+                      <a:srgbClr val="1E2761"/>
+                    </a:solidFill>
+                  </a:tcPr>
+                </a:tc>
+                <a:tc>
+                  <a:txBody>
+                    <a:bodyPr/>
+                    <a:lstStyle/>
+                    <a:p>
+                      <a:pPr algn="ctr"/>
+                      <a:r>
+                        <a:rPr sz="1200" b="1">
+                          <a:solidFill>
+                            <a:srgbClr val="FFFFFF"/>
+                          </a:solidFill>
+                        </a:rPr>
+                        <a:t>Taiwan</a:t>
+                      </a:r>
+                    </a:p>
+                  </a:txBody>
+                  <a:tcPr anchor="ctr">
+                    <a:solidFill>
+                      <a:srgbClr val="1E2761"/>
+                    </a:solidFill>
+                  </a:tcPr>
+                </a:tc>
+                <a:tc>
+                  <a:txBody>
+                    <a:bodyPr/>
+                    <a:lstStyle/>
+                    <a:p>
+                      <a:pPr algn="ctr"/>
+                      <a:r>
+                        <a:rPr sz="1200" b="1">
+                          <a:solidFill>
+                            <a:srgbClr val="FFFFFF"/>
+                          </a:solidFill>
+                        </a:rPr>
+                        <a:t>Bangladesh</a:t>
+                      </a:r>
+                    </a:p>
+                  </a:txBody>
+                  <a:tcPr anchor="ctr">
+                    <a:solidFill>
+                      <a:srgbClr val="1E2761"/>
+                    </a:solidFill>
+                  </a:tcPr>
+                </a:tc>
+                <a:tc>
+                  <a:txBody>
+                    <a:bodyPr/>
+                    <a:lstStyle/>
+                    <a:p>
+                      <a:pPr algn="ctr"/>
+                      <a:r>
+                        <a:rPr sz="1200" b="1">
+                          <a:solidFill>
+                            <a:srgbClr val="FFFFFF"/>
+                          </a:solidFill>
+                        </a:rPr>
+                        <a:t>PlantDoc</a:t>
+                      </a:r>
+                    </a:p>
+                  </a:txBody>
+                  <a:tcPr anchor="ctr">
+                    <a:solidFill>
+                      <a:srgbClr val="1E2761"/>
+                    </a:solidFill>
+                  </a:tcPr>
+                </a:tc>
+              </a:tr>
+              <a:tr h="560000">
+                <a:tc>
+                  <a:txBody>
+                    <a:bodyPr/>
+                    <a:lstStyle/>
+                    <a:p>
+                      <a:pPr algn="ctr"/>
+                      <a:r>
+                        <a:rPr sz="1200" b="0">
+                          <a:solidFill>
+                            <a:srgbClr val="1A1A1A"/>
+                          </a:solidFill>
+                        </a:rPr>
+                        <a:t>Source+마스킹</a:t>
+                      </a:r>
+                    </a:p>
+                  </a:txBody>
+                  <a:tcPr anchor="ctr">
+                    <a:solidFill>
+                      <a:srgbClr val="FFFFFF"/>
+                    </a:solidFill>
+                  </a:tcPr>
+                </a:tc>
+                <a:tc>
+                  <a:txBody>
+                    <a:bodyPr/>
+                    <a:lstStyle/>
+                    <a:p>
+                      <a:pPr algn="ctr"/>
+                      <a:r>
+                        <a:rPr sz="1200" b="0">
+                          <a:solidFill>
+                            <a:srgbClr val="1A1A1A"/>
+                          </a:solidFill>
+                        </a:rPr>
+                        <a:t>32.27% ±0.79</a:t>
+                      </a:r>
+                    </a:p>
+                  </a:txBody>
+                  <a:tcPr anchor="ctr">
+                    <a:solidFill>
+                      <a:srgbClr val="FFFFFF"/>
+                    </a:solidFill>
+                  </a:tcPr>
+                </a:tc>
+                <a:tc>
+                  <a:txBody>
+                    <a:bodyPr/>
+                    <a:lstStyle/>
+                    <a:p>
+                      <a:pPr algn="ctr"/>
+                      <a:r>
+                        <a:rPr sz="1200" b="0">
+                          <a:solidFill>
+                            <a:srgbClr val="1A1A1A"/>
+                          </a:solidFill>
+                        </a:rPr>
+                        <a:t>16.50% ±4.58</a:t>
+                      </a:r>
+                    </a:p>
+                  </a:txBody>
+                  <a:tcPr anchor="ctr">
+                    <a:solidFill>
+                      <a:srgbClr val="FFFFFF"/>
+                    </a:solidFill>
+                  </a:tcPr>
+                </a:tc>
+                <a:tc>
+                  <a:txBody>
+                    <a:bodyPr/>
+                    <a:lstStyle/>
+                    <a:p>
+                      <a:pPr algn="ctr"/>
+                      <a:r>
+                        <a:rPr sz="1200" b="0">
+                          <a:solidFill>
+                            <a:srgbClr val="1A1A1A"/>
+                          </a:solidFill>
+                        </a:rPr>
+                        <a:t>20.17% ±1.79</a:t>
+                      </a:r>
+                    </a:p>
+                  </a:txBody>
+                  <a:tcPr anchor="ctr">
+                    <a:solidFill>
+                      <a:srgbClr val="FFFFFF"/>
+                    </a:solidFill>
+                  </a:tcPr>
+                </a:tc>
+              </a:tr>
+              <a:tr h="560000">
+                <a:tc>
+                  <a:txBody>
+                    <a:bodyPr/>
+                    <a:lstStyle/>
+                    <a:p>
+                      <a:pPr algn="ctr"/>
+                      <a:r>
+                        <a:rPr sz="1200" b="0">
+                          <a:solidFill>
+                            <a:srgbClr val="1A1A1A"/>
+                          </a:solidFill>
+                        </a:rPr>
+                        <a:t>AdaBN+마스킹</a:t>
+                      </a:r>
+                    </a:p>
+                  </a:txBody>
+                  <a:tcPr anchor="ctr">
+                    <a:solidFill>
+                      <a:srgbClr val="EEF3FC"/>
+                    </a:solidFill>
+                  </a:tcPr>
+                </a:tc>
+                <a:tc>
+                  <a:txBody>
+                    <a:bodyPr/>
+                    <a:lstStyle/>
+                    <a:p>
+                      <a:pPr algn="ctr"/>
+                      <a:r>
+                        <a:rPr sz="1200" b="0">
+                          <a:solidFill>
+                            <a:srgbClr val="1A1A1A"/>
+                          </a:solidFill>
+                        </a:rPr>
+                        <a:t>35.24% ±2.57</a:t>
+                      </a:r>
+                    </a:p>
+                  </a:txBody>
+                  <a:tcPr anchor="ctr">
+                    <a:solidFill>
+                      <a:srgbClr val="EEF3FC"/>
+                    </a:solidFill>
+                  </a:tcPr>
+                </a:tc>
+                <a:tc>
+                  <a:txBody>
+                    <a:bodyPr/>
+                    <a:lstStyle/>
+                    <a:p>
+                      <a:pPr algn="ctr"/>
+                      <a:r>
+                        <a:rPr sz="1200" b="0">
+                          <a:solidFill>
+                            <a:srgbClr val="1A1A1A"/>
+                          </a:solidFill>
+                        </a:rPr>
+                        <a:t>15.14% ±2.44</a:t>
+                      </a:r>
+                    </a:p>
+                  </a:txBody>
+                  <a:tcPr anchor="ctr">
+                    <a:solidFill>
+                      <a:srgbClr val="EEF3FC"/>
+                    </a:solidFill>
+                  </a:tcPr>
+                </a:tc>
+                <a:tc>
+                  <a:txBody>
+                    <a:bodyPr/>
+                    <a:lstStyle/>
+                    <a:p>
+                      <a:pPr algn="ctr"/>
+                      <a:r>
+                        <a:rPr sz="1200" b="0">
+                          <a:solidFill>
+                            <a:srgbClr val="1A1A1A"/>
+                          </a:solidFill>
+                        </a:rPr>
+                        <a:t>16.83% ±1.80</a:t>
+                      </a:r>
+                    </a:p>
+                  </a:txBody>
+                  <a:tcPr anchor="ctr">
+                    <a:solidFill>
+                      <a:srgbClr val="EEF3FC"/>
+                    </a:solidFill>
+                  </a:tcPr>
+                </a:tc>
+              </a:tr>
+              <a:tr h="560000">
+                <a:tc>
+                  <a:txBody>
+                    <a:bodyPr/>
+                    <a:lstStyle/>
+                    <a:p>
+                      <a:pPr algn="ctr"/>
+                      <a:r>
+                        <a:rPr sz="1200" b="0">
+                          <a:solidFill>
+                            <a:srgbClr val="1A1A1A"/>
+                          </a:solidFill>
+                        </a:rPr>
+                        <a:t>SHOT+마스킹(최종)</a:t>
+                      </a:r>
+                    </a:p>
+                  </a:txBody>
+                  <a:tcPr anchor="ctr">
+                    <a:solidFill>
+                      <a:srgbClr val="FFFFFF"/>
+                    </a:solidFill>
+                  </a:tcPr>
+                </a:tc>
+                <a:tc>
+                  <a:txBody>
+                    <a:bodyPr/>
+                    <a:lstStyle/>
+                    <a:p>
+                      <a:pPr algn="ctr"/>
+                      <a:r>
+                        <a:rPr sz="1200" b="1">
+                          <a:solidFill>
+                            <a:srgbClr val="1A1A1A"/>
+                          </a:solidFill>
+                        </a:rPr>
+                        <a:t>37.58% ±5.86</a:t>
+                      </a:r>
+                    </a:p>
+                  </a:txBody>
+                  <a:tcPr anchor="ctr">
+                    <a:solidFill>
+                      <a:srgbClr val="FFFFFF"/>
+                    </a:solidFill>
+                  </a:tcPr>
+                </a:tc>
+                <a:tc>
+                  <a:txBody>
+                    <a:bodyPr/>
+                    <a:lstStyle/>
+                    <a:p>
+                      <a:pPr algn="ctr"/>
+                      <a:r>
+                        <a:rPr sz="1200" b="1">
+                          <a:solidFill>
+                            <a:srgbClr val="1A1A1A"/>
+                          </a:solidFill>
+                        </a:rPr>
+                        <a:t>24.28% ±5.62</a:t>
+                      </a:r>
+                    </a:p>
+                  </a:txBody>
+                  <a:tcPr anchor="ctr">
+                    <a:solidFill>
+                      <a:srgbClr val="FFFFFF"/>
+                    </a:solidFill>
+                  </a:tcPr>
+                </a:tc>
+                <a:tc>
+                  <a:txBody>
+                    <a:bodyPr/>
+                    <a:lstStyle/>
+                    <a:p>
+                      <a:pPr algn="ctr"/>
+                      <a:r>
+                        <a:rPr sz="1200" b="1">
+                          <a:solidFill>
+                            <a:srgbClr val="1A1A1A"/>
+                          </a:solidFill>
+                        </a:rPr>
+                        <a:t>19.75% ±1.40</a:t>
+                      </a:r>
+                    </a:p>
+                  </a:txBody>
+                  <a:tcPr anchor="ctr">
+                    <a:solidFill>
+                      <a:srgbClr val="FFFFFF"/>
+                    </a:solidFill>
+                  </a:tcPr>
+                </a:tc>
+              </a:tr>
+              <a:tr h="560000">
+                <a:tc>
+                  <a:txBody>
+                    <a:bodyPr/>
+                    <a:lstStyle/>
+                    <a:p>
+                      <a:pPr algn="ctr"/>
+                      <a:r>
+                        <a:rPr sz="1200" b="0">
+                          <a:solidFill>
+                            <a:srgbClr val="1A1A1A"/>
+                          </a:solidFill>
+                        </a:rPr>
+                        <a:t>SHOT+APS+마스킹</a:t>
+                      </a:r>
+                    </a:p>
+                  </a:txBody>
+                  <a:tcPr anchor="ctr">
+                    <a:solidFill>
+                      <a:srgbClr val="EEF3FC"/>
+                    </a:solidFill>
+                  </a:tcPr>
+                </a:tc>
+                <a:tc>
+                  <a:txBody>
+                    <a:bodyPr/>
+                    <a:lstStyle/>
+                    <a:p>
+                      <a:pPr algn="ctr"/>
+                      <a:r>
+                        <a:rPr sz="1200" b="0">
+                          <a:solidFill>
+                            <a:srgbClr val="1A1A1A"/>
+                          </a:solidFill>
+                        </a:rPr>
+                        <a:t>36.41% ±6.29</a:t>
+                      </a:r>
+                    </a:p>
+                  </a:txBody>
+                  <a:tcPr anchor="ctr">
+                    <a:solidFill>
+                      <a:srgbClr val="EEF3FC"/>
+                    </a:solidFill>
+                  </a:tcPr>
+                </a:tc>
+                <a:tc>
+                  <a:txBody>
+                    <a:bodyPr/>
+                    <a:lstStyle/>
+                    <a:p>
+                      <a:pPr algn="ctr"/>
+                      <a:r>
+                        <a:rPr sz="1200" b="0">
+                          <a:solidFill>
+                            <a:srgbClr val="1A1A1A"/>
+                          </a:solidFill>
+                        </a:rPr>
+                        <a:t>24.07% ±4.88</a:t>
+                      </a:r>
+                    </a:p>
+                  </a:txBody>
+                  <a:tcPr anchor="ctr">
+                    <a:solidFill>
+                      <a:srgbClr val="EEF3FC"/>
+                    </a:solidFill>
+                  </a:tcPr>
+                </a:tc>
+                <a:tc>
+                  <a:txBody>
+                    <a:bodyPr/>
+                    <a:lstStyle/>
+                    <a:p>
+                      <a:pPr algn="ctr"/>
+                      <a:r>
+                        <a:rPr sz="1200" b="0">
+                          <a:solidFill>
+                            <a:srgbClr val="1A1A1A"/>
+                          </a:solidFill>
+                        </a:rPr>
+                        <a:t>18.95% ±0.69</a:t>
+                      </a:r>
+                    </a:p>
+                  </a:txBody>
+                  <a:tcPr anchor="ctr">
+                    <a:solidFill>
+                      <a:srgbClr val="EEF3FC"/>
+                    </a:solidFill>
+                  </a:tcPr>
+                </a:tc>
+              </a:tr>
+            </a:tbl>
+          </a:graphicData>
+        </a:graphic>
+      </p:graphicFrame>
+      <p:sp>
+        <p:nvSpPr>
+          <p:cNvPr id="6" name="TextBox 4"/>
+          <p:cNvSpPr txBox="1"/>
+          <p:nvPr/>
+        </p:nvSpPr>
+        <p:spPr>
+          <a:xfrm>
+            <a:off x="548640" y="5050000"/>
+            <a:ext cx="11091672" cy="1300000"/>
+          </a:xfrm>
+          <a:prstGeom prst="rect">
+            <a:avLst/>
+          </a:prstGeom>
+          <a:noFill/>
+        </p:spPr>
+        <p:txBody>
+          <a:bodyPr wrap="square" anchor="t" lIns="0" rIns="0" tIns="0" bIns="0">
+            <a:spAutoFit/>
+          </a:bodyPr>
+          <a:lstStyle/>
+          <a:p>
+            <a:pPr algn="l"/>
+            <a:r>
+              <a:rPr sz="1200" b="0" i="1">
+                <a:solidFill>
+                  <a:srgbClr val="5B5E6B"/>
+                </a:solidFill>
+                <a:latin typeface="Calibri"/>
+              </a:rPr>
+              <a:t>seed42 단일 실행에서는 APS가 Taiwan을 42.04%→44.59%로 개선하는 것처럼 보였지만, 3-seed 평균으로 보면 SHOT+APS가 SHOT보다 모든 데이터셋에서 오히려 근소하게 낮다(Taiwan -1.17%p, Bangladesh -0.21%p, PlantDoc -0.80%p) — 그 차이는 표준편차(5~6%p)보다 작아 noise 범위를 벗어나지 못한다. seed42가 APS에 우연히 유리했던 것일 뿐이라 판단해, 최종 파이프라인을 APS 없는 순수 SHOT(epoch=2)로 확정한다. SHOT 자체도 seed 표준편차가 5~6%p로 커서, 단일 seed 결과를 과신하면 안 된다는 것도 같이 확인했다.</a:t>
+            </a:r>
+          </a:p>
+        </p:txBody>
+      </p:sp>
+      <p:sp>
+        <p:nvSpPr>
+          <p:cNvPr id="9" name="TextBox 5"/>
+          <p:cNvSpPr txBox="1"/>
+          <p:nvPr/>
+        </p:nvSpPr>
+        <p:spPr>
+          <a:xfrm>
+            <a:off x="11430000" y="6446520"/>
+            <a:ext cx="548640" cy="274320"/>
+          </a:xfrm>
+          <a:prstGeom prst="rect">
+            <a:avLst/>
+          </a:prstGeom>
+          <a:noFill/>
+        </p:spPr>
+        <p:txBody>
+          <a:bodyPr wrap="square" anchor="t" lIns="0" rIns="0" tIns="0" bIns="0">
+            <a:spAutoFit/>
+          </a:bodyPr>
+          <a:lstStyle/>
+          <a:p>
+            <a:pPr algn="r"/>
+            <a:r>
+              <a:rPr sz="1000" b="0" i="0">
+                <a:solidFill>
+                  <a:srgbClr val="5B5E6B"/>
+                </a:solidFill>
+                <a:latin typeface="Calibri"/>
+              </a:rPr>
+              <a:t>27</a:t>
             </a:r>
           </a:p>
         </p:txBody>

</xml_diff>

<commit_message>
feat: SHOT+AaD 채택 이후 추가 탐색(confident-prototype/prototype-sharpen/TTA) 전부 기각 — PPT·README 상세 반영
최종 채택된 SHOT+AaD(weight=1.0)를 더 밀어올릴 수 있는지 세 가지 다른 메커니즘을 추가 구현하고
테스트했다:

1. confident-prototype(hard, --shot-confident-prototype-frac): 클래스 중심을 확신도 상위 N%
   샘플만의 단순 평균으로 구함. seed42에서 Taiwan의 healthy 블라인드스팟을 실제로 풀었지만
   (recall 0%→34.9%), 3-seed 검증에서 seed123이 17.52%(랜덤 확률 이하)로 완전 붕괴 — 기각.
2. prototype-sharpen(soft, --shot-prototype-sharpen-gamma): weight를 거듭제곱해 부드럽게 강조.
   극단적으로 무너지진 않지만 SHOT+AaD를 못 넘어 기각.
3. TTA(--shot-tta-hflip): pseudo-label 생성 시 좌우반전 평균으로 입력 노이즈 감소. Bangladesh만
   소폭 개선, Taiwan은 하락, AaD와 결합해도 이득 없음 — 기각.

Taiwan epoch=7+AaD도 3-seed 검증(43.42%±10.52, epoch=2 대비 평균은 높지만 표준편차도 2배라
n=3으로는 불확실 — 참고 기록만 남기고 미채택).

지금까지 8개 방향 중 3-seed 검증을 통과한 것은 SHOT+AaD(weight=1.0, 공통) 하나뿐임을
README·PPT(RESULT 7, 9장으로 확장) 양쪽에 상세히 기록했다.

Co-Authored-By: Claude Sonnet 5 <noreply@anthropic.com>
</commit_message>
<xml_diff>
--- a/docs/CNN_토마토_병해분류_V2_진행보고.pptx
+++ b/docs/CNN_토마토_병해분류_V2_진행보고.pptx
@@ -33,6 +33,7 @@
     <p:sldId id="290" r:id="rId40"/>
     <p:sldId id="294" r:id="rId44"/>
     <p:sldId id="295" r:id="rId45"/>
+    <p:sldId id="298" r:id="rId48"/>
     <p:sldId id="296" r:id="rId46"/>
     <p:sldId id="297" r:id="rId47"/>
     <p:sldId id="286" r:id="rId36"/>
@@ -18516,7 +18517,7 @@
                 </a:solidFill>
                 <a:latin typeface="Calibri"/>
               </a:rPr>
-              <a:t>31</a:t>
+              <a:t>32</a:t>
             </a:r>
           </a:p>
         </p:txBody>
@@ -19938,7 +19939,7 @@
                 </a:solidFill>
                 <a:latin typeface="Calibri"/>
               </a:rPr>
-              <a:t>32</a:t>
+              <a:t>33</a:t>
             </a:r>
           </a:p>
         </p:txBody>
@@ -19999,7 +20000,7 @@
                 </a:solidFill>
                 <a:latin typeface="Calibri"/>
               </a:rPr>
-              <a:t>RESULT 7 · DOMAIN ADAPTATION (8/8)</a:t>
+              <a:t>RESULT 7 · DOMAIN ADAPTATION (9/9)</a:t>
             </a:r>
           </a:p>
         </p:txBody>
@@ -20530,7 +20531,7 @@
                 </a:solidFill>
                 <a:latin typeface="Calibri"/>
               </a:rPr>
-              <a:t>30</a:t>
+              <a:t>31</a:t>
             </a:r>
           </a:p>
         </p:txBody>
@@ -20591,7 +20592,7 @@
                 </a:solidFill>
                 <a:latin typeface="Calibri"/>
               </a:rPr>
-              <a:t>RESULT 7 · DOMAIN ADAPTATION (3/8)</a:t>
+              <a:t>RESULT 7 · DOMAIN ADAPTATION (3/9)</a:t>
             </a:r>
           </a:p>
         </p:txBody>
@@ -21091,7 +21092,7 @@
                 </a:solidFill>
                 <a:latin typeface="Calibri"/>
               </a:rPr>
-              <a:t>RESULT 7 · DOMAIN ADAPTATION (2/8)</a:t>
+              <a:t>RESULT 7 · DOMAIN ADAPTATION (2/9)</a:t>
             </a:r>
           </a:p>
         </p:txBody>
@@ -21584,7 +21585,7 @@
                 </a:solidFill>
                 <a:latin typeface="Calibri"/>
               </a:rPr>
-              <a:t>Taiwan만 오라클 실측값이 60%를 넘는다(70.53%) — 하이퍼파라미터를 끝까지 밀면 seed42 한 번은 63%까지 봤지만, 3-seed로 검증하면 46.39% ±12.46으로 재현되지 않았다(6/8 슬라이드). Bangladesh는 오라클 실측값(58.61%) 자체가 60%에 못 미쳐 “완벽한 적응 기법”을 찾아도 구조적으로 60%를 보장할 수 없고, PlantDoc은 정답을 줘도 23%라 적응 문제가 아니라 feature 표현력의 문제다 — source 학습 데이터·증강을 바꾸지 않는 한(이 프로젝트 범위 밖) 더 올릴 수 없다는 게 최종 진단이다.</a:t>
+              <a:t>Taiwan만 오라클 실측값이 60%를 넘는다(70.53%) — 하이퍼파라미터를 끝까지 밀면 seed42 한 번은 63%까지 봤지만, 3-seed로 검증하면 46.39% ±12.46으로 재현되지 않았다(7/9 슬라이드). Bangladesh는 오라클 실측값(58.61%) 자체가 60%에 못 미쳐 “완벽한 적응 기법”을 찾아도 구조적으로 60%를 보장할 수 없고, PlantDoc은 정답을 줘도 23%라 적응 문제가 아니라 feature 표현력의 문제다 — source 학습 데이터·증강을 바꾸지 않는 한(이 프로젝트 범위 밖) 더 올릴 수 없다는 게 최종 진단이다.</a:t>
             </a:r>
           </a:p>
         </p:txBody>
@@ -21680,7 +21681,7 @@
                 </a:solidFill>
                 <a:latin typeface="Calibri"/>
               </a:rPr>
-              <a:t>RESULT 7 · DOMAIN ADAPTATION (1/8)</a:t>
+              <a:t>RESULT 7 · DOMAIN ADAPTATION (1/9)</a:t>
             </a:r>
           </a:p>
         </p:txBody>
@@ -22359,7 +22360,7 @@
                 </a:solidFill>
                 <a:latin typeface="Calibri"/>
               </a:rPr>
-              <a:t>RESULT 7 · DOMAIN ADAPTATION (4/8)</a:t>
+              <a:t>RESULT 7 · DOMAIN ADAPTATION (4/9)</a:t>
             </a:r>
           </a:p>
         </p:txBody>
@@ -23971,7 +23972,7 @@
                 </a:solidFill>
                 <a:latin typeface="Calibri"/>
               </a:rPr>
-              <a:t>RESULT 7 · DOMAIN ADAPTATION (5/8)</a:t>
+              <a:t>RESULT 7 · DOMAIN ADAPTATION (5/9)</a:t>
             </a:r>
           </a:p>
         </p:txBody>
@@ -24920,7 +24921,7 @@
                 </a:solidFill>
                 <a:latin typeface="Calibri"/>
               </a:rPr>
-              <a:t>RESULT 7 · DOMAIN ADAPTATION (6/8)</a:t>
+              <a:t>RESULT 7 · DOMAIN ADAPTATION (7/9)</a:t>
             </a:r>
           </a:p>
         </p:txBody>
@@ -25596,7 +25597,7 @@
                 </a:solidFill>
                 <a:latin typeface="Calibri"/>
               </a:rPr>
-              <a:t>Taiwan은 epoch·weight를 올릴수록 계속 좋아지다 epoch=10에서 과적합으로 꺾인다. Bangladesh는 epoch=4·weight=2.0(class_balance+balanced_cap 병행)에서 정점(34.42%) 후 하락한다. 하지만 두 정점(63.06%, 34.42%) 모두 seed42 단일 실행이고, 3-seed로 검증하면 재현되지 않았다(1/8 슬라이드 데이터와 같은 결론) — 그래서 최종 채택은 정점이 아니라 epoch=2(공통 고정값)다.</a:t>
+              <a:t>Taiwan은 epoch·weight를 올릴수록 계속 좋아지다 epoch=10에서 과적합으로 꺾인다. Bangladesh는 epoch=4·weight=2.0(class_balance+balanced_cap 병행)에서 정점(34.42%) 후 하락한다. 하지만 두 정점(63.06%, 34.42%) 모두 seed42 단일 실행이고, 3-seed로 검증하면 재현되지 않았다(1/9 슬라이드 데이터와 같은 결론) — 그래서 최종 채택은 정점이 아니라 epoch=2(공통 고정값)다.</a:t>
             </a:r>
           </a:p>
         </p:txBody>
@@ -25631,7 +25632,7 @@
                 </a:solidFill>
                 <a:latin typeface="Calibri"/>
               </a:rPr>
-              <a:t>28</a:t>
+              <a:t>29</a:t>
             </a:r>
           </a:p>
         </p:txBody>
@@ -25692,7 +25693,7 @@
                 </a:solidFill>
                 <a:latin typeface="Calibri"/>
               </a:rPr>
-              <a:t>RESULT 7 · DOMAIN ADAPTATION (7/8)</a:t>
+              <a:t>RESULT 7 · DOMAIN ADAPTATION (8/9)</a:t>
             </a:r>
           </a:p>
         </p:txBody>
@@ -26490,7 +26491,909 @@
                 </a:solidFill>
                 <a:latin typeface="Calibri"/>
               </a:rPr>
-              <a:t>29</a:t>
+              <a:t>30</a:t>
+            </a:r>
+          </a:p>
+        </p:txBody>
+      </p:sp>
+    </p:spTree>
+  </p:cSld>
+  <p:clrMapOvr>
+    <a:masterClrMapping/>
+  </p:clrMapOvr>
+</p:sld>
+</file>
+
+<file path=ppt/slides/slide43.xml><?xml version="1.0" encoding="utf-8"?>
+<p:sld xmlns:a="http://schemas.openxmlformats.org/drawingml/2006/main" xmlns:p="http://schemas.openxmlformats.org/presentationml/2006/main" xmlns:r="http://schemas.openxmlformats.org/officeDocument/2006/relationships">
+  <p:cSld>
+    <p:bg>
+      <p:bgPr>
+        <a:solidFill>
+          <a:srgbClr val="FFFFFF"/>
+        </a:solidFill>
+        <a:effectLst/>
+      </p:bgPr>
+    </p:bg>
+    <p:spTree>
+      <p:nvGrpSpPr>
+        <p:cNvPr id="1" name=""/>
+        <p:cNvGrpSpPr/>
+        <p:nvPr/>
+      </p:nvGrpSpPr>
+      <p:grpSpPr/>
+      <p:sp>
+        <p:nvSpPr>
+          <p:cNvPr id="2" name="TextBox 1"/>
+          <p:cNvSpPr txBox="1"/>
+          <p:nvPr/>
+        </p:nvSpPr>
+        <p:spPr>
+          <a:xfrm>
+            <a:off x="548640" y="292608"/>
+            <a:ext cx="9144000" cy="292608"/>
+          </a:xfrm>
+          <a:prstGeom prst="rect">
+            <a:avLst/>
+          </a:prstGeom>
+          <a:noFill/>
+        </p:spPr>
+        <p:txBody>
+          <a:bodyPr wrap="square" anchor="t" lIns="0" rIns="0" tIns="0" bIns="0">
+            <a:spAutoFit/>
+          </a:bodyPr>
+          <a:lstStyle/>
+          <a:p>
+            <a:pPr algn="l"/>
+            <a:r>
+              <a:rPr sz="1050" b="1" i="0">
+                <a:solidFill>
+                  <a:srgbClr val="2A78D6"/>
+                </a:solidFill>
+                <a:latin typeface="Calibri"/>
+              </a:rPr>
+              <a:t>RESULT 7 · DOMAIN ADAPTATION (6/9)</a:t>
+            </a:r>
+          </a:p>
+        </p:txBody>
+      </p:sp>
+      <p:sp>
+        <p:nvSpPr>
+          <p:cNvPr id="3" name="TextBox 2"/>
+          <p:cNvSpPr txBox="1"/>
+          <p:nvPr/>
+        </p:nvSpPr>
+        <p:spPr>
+          <a:xfrm>
+            <a:off x="548640" y="566928"/>
+            <a:ext cx="10972800" cy="548640"/>
+          </a:xfrm>
+          <a:prstGeom prst="rect">
+            <a:avLst/>
+          </a:prstGeom>
+          <a:noFill/>
+        </p:spPr>
+        <p:txBody>
+          <a:bodyPr wrap="square" anchor="t" lIns="0" rIns="0" tIns="0" bIns="0">
+            <a:spAutoFit/>
+          </a:bodyPr>
+          <a:lstStyle/>
+          <a:p>
+            <a:pPr algn="l"/>
+            <a:r>
+              <a:rPr sz="2100" b="1" i="0">
+                <a:solidFill>
+                  <a:srgbClr val="1E2761"/>
+                </a:solidFill>
+                <a:latin typeface="Cambria"/>
+              </a:rPr>
+              <a:t>최종 채택 이후 추가 탐색: Prototype 개선 · TTA</a:t>
+            </a:r>
+          </a:p>
+        </p:txBody>
+      </p:sp>
+      <p:sp>
+        <p:nvSpPr>
+          <p:cNvPr id="4" name="TextBox 3"/>
+          <p:cNvSpPr txBox="1"/>
+          <p:nvPr/>
+        </p:nvSpPr>
+        <p:spPr>
+          <a:xfrm>
+            <a:off x="548640" y="1150000"/>
+            <a:ext cx="11091672" cy="1050000"/>
+          </a:xfrm>
+          <a:prstGeom prst="rect">
+            <a:avLst/>
+          </a:prstGeom>
+          <a:noFill/>
+        </p:spPr>
+        <p:txBody>
+          <a:bodyPr wrap="square" anchor="t" lIns="0" rIns="0" tIns="0" bIns="0">
+            <a:spAutoFit/>
+          </a:bodyPr>
+          <a:lstStyle/>
+          <a:p>
+            <a:pPr algn="l"/>
+            <a:r>
+              <a:rPr sz="1200" b="0" i="0">
+                <a:solidFill>
+                  <a:srgbClr val="1A1A1A"/>
+                </a:solidFill>
+                <a:latin typeface="Calibri"/>
+              </a:rPr>
+              <a:t>SHOT+AaD(weight=1.0)를 최종 채택한 뒤, 이를 더 밀어올릴 수 있는지 두 가지 다른 메커니즘을 추가로 시도했다 — 클러스터 중심(prototype)의 품질을 높이는 방법과, pseudo-label을 만들 때 입력 자체의 노이즈를 줄이는 TTA(좌우반전 평균). 전부 SHOT+AaD를 최종으로 유지하는 결론으로 끝났다.</a:t>
+            </a:r>
+          </a:p>
+        </p:txBody>
+      </p:sp>
+      <p:graphicFrame>
+        <p:nvGraphicFramePr>
+          <p:cNvPr id="7" name="Table"/>
+          <p:cNvGraphicFramePr>
+            <a:graphicFrameLocks noGrp="1"/>
+          </p:cNvGraphicFramePr>
+          <p:nvPr/>
+        </p:nvGraphicFramePr>
+        <p:xfrm>
+          <a:off x="548640" y="2300000"/>
+          <a:ext cx="11400000" cy="2200000"/>
+        </p:xfrm>
+        <a:graphic>
+          <a:graphicData uri="http://schemas.openxmlformats.org/drawingml/2006/table">
+            <a:tbl>
+              <a:tblPr firstRow="1" bandRow="1">
+                <a:tableStyleId>{5C22544A-7EE6-4342-B048-85BDC9FD1C3A}</a:tableStyleId>
+              </a:tblPr>
+              <a:tblGrid>
+                <a:gridCol w="3000000"/>
+                <a:gridCol w="1900000"/>
+                <a:gridCol w="1900000"/>
+                <a:gridCol w="1700000"/>
+                <a:gridCol w="2900000"/>
+              </a:tblGrid>
+              <a:tr h="440000">
+                <a:tc>
+                  <a:txBody>
+                    <a:bodyPr/>
+                    <a:lstStyle/>
+                    <a:p>
+                      <a:pPr algn="ctr"/>
+                      <a:r>
+                        <a:rPr sz="1050" b="1">
+                          <a:solidFill>
+                            <a:srgbClr val="FFFFFF"/>
+                          </a:solidFill>
+                        </a:rPr>
+                        <a:t>방법</a:t>
+                      </a:r>
+                    </a:p>
+                  </a:txBody>
+                  <a:tcPr anchor="ctr">
+                    <a:solidFill>
+                      <a:srgbClr val="1E2761"/>
+                    </a:solidFill>
+                  </a:tcPr>
+                </a:tc>
+                <a:tc>
+                  <a:txBody>
+                    <a:bodyPr/>
+                    <a:lstStyle/>
+                    <a:p>
+                      <a:pPr algn="ctr"/>
+                      <a:r>
+                        <a:rPr sz="1050" b="1">
+                          <a:solidFill>
+                            <a:srgbClr val="FFFFFF"/>
+                          </a:solidFill>
+                        </a:rPr>
+                        <a:t>Taiwan</a:t>
+                      </a:r>
+                    </a:p>
+                  </a:txBody>
+                  <a:tcPr anchor="ctr">
+                    <a:solidFill>
+                      <a:srgbClr val="1E2761"/>
+                    </a:solidFill>
+                  </a:tcPr>
+                </a:tc>
+                <a:tc>
+                  <a:txBody>
+                    <a:bodyPr/>
+                    <a:lstStyle/>
+                    <a:p>
+                      <a:pPr algn="ctr"/>
+                      <a:r>
+                        <a:rPr sz="1050" b="1">
+                          <a:solidFill>
+                            <a:srgbClr val="FFFFFF"/>
+                          </a:solidFill>
+                        </a:rPr>
+                        <a:t>Bangladesh</a:t>
+                      </a:r>
+                    </a:p>
+                  </a:txBody>
+                  <a:tcPr anchor="ctr">
+                    <a:solidFill>
+                      <a:srgbClr val="1E2761"/>
+                    </a:solidFill>
+                  </a:tcPr>
+                </a:tc>
+                <a:tc>
+                  <a:txBody>
+                    <a:bodyPr/>
+                    <a:lstStyle/>
+                    <a:p>
+                      <a:pPr algn="ctr"/>
+                      <a:r>
+                        <a:rPr sz="1050" b="1">
+                          <a:solidFill>
+                            <a:srgbClr val="FFFFFF"/>
+                          </a:solidFill>
+                        </a:rPr>
+                        <a:t>PlantDoc</a:t>
+                      </a:r>
+                    </a:p>
+                  </a:txBody>
+                  <a:tcPr anchor="ctr">
+                    <a:solidFill>
+                      <a:srgbClr val="1E2761"/>
+                    </a:solidFill>
+                  </a:tcPr>
+                </a:tc>
+                <a:tc>
+                  <a:txBody>
+                    <a:bodyPr/>
+                    <a:lstStyle/>
+                    <a:p>
+                      <a:pPr algn="ctr"/>
+                      <a:r>
+                        <a:rPr sz="1050" b="1">
+                          <a:solidFill>
+                            <a:srgbClr val="FFFFFF"/>
+                          </a:solidFill>
+                        </a:rPr>
+                        <a:t>검증 결과</a:t>
+                      </a:r>
+                    </a:p>
+                  </a:txBody>
+                  <a:tcPr anchor="ctr">
+                    <a:solidFill>
+                      <a:srgbClr val="1E2761"/>
+                    </a:solidFill>
+                  </a:tcPr>
+                </a:tc>
+              </a:tr>
+              <a:tr h="440000">
+                <a:tc>
+                  <a:txBody>
+                    <a:bodyPr/>
+                    <a:lstStyle/>
+                    <a:p>
+                      <a:pPr algn="ctr"/>
+                      <a:r>
+                        <a:rPr sz="1050" b="0">
+                          <a:solidFill>
+                            <a:srgbClr val="1A1A1A"/>
+                          </a:solidFill>
+                        </a:rPr>
+                        <a:t>confident-prototype(hard, frac=0.5)</a:t>
+                      </a:r>
+                    </a:p>
+                  </a:txBody>
+                  <a:tcPr anchor="ctr">
+                    <a:solidFill>
+                      <a:srgbClr val="FFFFFF"/>
+                    </a:solidFill>
+                  </a:tcPr>
+                </a:tc>
+                <a:tc>
+                  <a:txBody>
+                    <a:bodyPr/>
+                    <a:lstStyle/>
+                    <a:p>
+                      <a:pPr algn="ctr"/>
+                      <a:r>
+                        <a:rPr sz="1050" b="0">
+                          <a:solidFill>
+                            <a:srgbClr val="1A1A1A"/>
+                          </a:solidFill>
+                        </a:rPr>
+                        <a:t>45.22%*</a:t>
+                      </a:r>
+                    </a:p>
+                  </a:txBody>
+                  <a:tcPr anchor="ctr">
+                    <a:solidFill>
+                      <a:srgbClr val="FFFFFF"/>
+                    </a:solidFill>
+                  </a:tcPr>
+                </a:tc>
+                <a:tc>
+                  <a:txBody>
+                    <a:bodyPr/>
+                    <a:lstStyle/>
+                    <a:p>
+                      <a:pPr algn="ctr"/>
+                      <a:r>
+                        <a:rPr sz="1050" b="0">
+                          <a:solidFill>
+                            <a:srgbClr val="1A1A1A"/>
+                          </a:solidFill>
+                        </a:rPr>
+                        <a:t>27.07%</a:t>
+                      </a:r>
+                    </a:p>
+                  </a:txBody>
+                  <a:tcPr anchor="ctr">
+                    <a:solidFill>
+                      <a:srgbClr val="FFFFFF"/>
+                    </a:solidFill>
+                  </a:tcPr>
+                </a:tc>
+                <a:tc>
+                  <a:txBody>
+                    <a:bodyPr/>
+                    <a:lstStyle/>
+                    <a:p>
+                      <a:pPr algn="ctr"/>
+                      <a:r>
+                        <a:rPr sz="1050" b="0">
+                          <a:solidFill>
+                            <a:srgbClr val="1A1A1A"/>
+                          </a:solidFill>
+                        </a:rPr>
+                        <a:t>20.17%</a:t>
+                      </a:r>
+                    </a:p>
+                  </a:txBody>
+                  <a:tcPr anchor="ctr">
+                    <a:solidFill>
+                      <a:srgbClr val="FFFFFF"/>
+                    </a:solidFill>
+                  </a:tcPr>
+                </a:tc>
+                <a:tc>
+                  <a:txBody>
+                    <a:bodyPr/>
+                    <a:lstStyle/>
+                    <a:p>
+                      <a:pPr algn="ctr"/>
+                      <a:r>
+                        <a:rPr sz="1050" b="1">
+                          <a:solidFill>
+                            <a:srgbClr val="B3401A"/>
+                          </a:solidFill>
+                        </a:rPr>
+                        <a:t>3-seed: 31.85%±11.33 → 기각</a:t>
+                      </a:r>
+                    </a:p>
+                  </a:txBody>
+                  <a:tcPr anchor="ctr">
+                    <a:solidFill>
+                      <a:srgbClr val="FFFFFF"/>
+                    </a:solidFill>
+                  </a:tcPr>
+                </a:tc>
+              </a:tr>
+              <a:tr h="440000">
+                <a:tc>
+                  <a:txBody>
+                    <a:bodyPr/>
+                    <a:lstStyle/>
+                    <a:p>
+                      <a:pPr algn="ctr"/>
+                      <a:r>
+                        <a:rPr sz="1050" b="0">
+                          <a:solidFill>
+                            <a:srgbClr val="1A1A1A"/>
+                          </a:solidFill>
+                        </a:rPr>
+                        <a:t>prototype-sharpen(soft, γ=2~4)</a:t>
+                      </a:r>
+                    </a:p>
+                  </a:txBody>
+                  <a:tcPr anchor="ctr">
+                    <a:solidFill>
+                      <a:srgbClr val="EEF3FC"/>
+                    </a:solidFill>
+                  </a:tcPr>
+                </a:tc>
+                <a:tc>
+                  <a:txBody>
+                    <a:bodyPr/>
+                    <a:lstStyle/>
+                    <a:p>
+                      <a:pPr algn="ctr"/>
+                      <a:r>
+                        <a:rPr sz="1050" b="0">
+                          <a:solidFill>
+                            <a:srgbClr val="1A1A1A"/>
+                          </a:solidFill>
+                        </a:rPr>
+                        <a:t>40.5~42.4%</a:t>
+                      </a:r>
+                    </a:p>
+                  </a:txBody>
+                  <a:tcPr anchor="ctr">
+                    <a:solidFill>
+                      <a:srgbClr val="EEF3FC"/>
+                    </a:solidFill>
+                  </a:tcPr>
+                </a:tc>
+                <a:tc>
+                  <a:txBody>
+                    <a:bodyPr/>
+                    <a:lstStyle/>
+                    <a:p>
+                      <a:pPr algn="ctr"/>
+                      <a:r>
+                        <a:rPr sz="1050" b="0">
+                          <a:solidFill>
+                            <a:srgbClr val="1A1A1A"/>
+                          </a:solidFill>
+                        </a:rPr>
+                        <a:t>29.8~30.1%</a:t>
+                      </a:r>
+                    </a:p>
+                  </a:txBody>
+                  <a:tcPr anchor="ctr">
+                    <a:solidFill>
+                      <a:srgbClr val="EEF3FC"/>
+                    </a:solidFill>
+                  </a:tcPr>
+                </a:tc>
+                <a:tc>
+                  <a:txBody>
+                    <a:bodyPr/>
+                    <a:lstStyle/>
+                    <a:p>
+                      <a:pPr algn="ctr"/>
+                      <a:r>
+                        <a:rPr sz="1050" b="0">
+                          <a:solidFill>
+                            <a:srgbClr val="1A1A1A"/>
+                          </a:solidFill>
+                        </a:rPr>
+                        <a:t>18.3%</a:t>
+                      </a:r>
+                    </a:p>
+                  </a:txBody>
+                  <a:tcPr anchor="ctr">
+                    <a:solidFill>
+                      <a:srgbClr val="EEF3FC"/>
+                    </a:solidFill>
+                  </a:tcPr>
+                </a:tc>
+                <a:tc>
+                  <a:txBody>
+                    <a:bodyPr/>
+                    <a:lstStyle/>
+                    <a:p>
+                      <a:pPr algn="ctr"/>
+                      <a:r>
+                        <a:rPr sz="1050" b="0">
+                          <a:solidFill>
+                            <a:srgbClr val="1A1A1A"/>
+                          </a:solidFill>
+                        </a:rPr>
+                        <a:t>단일seed, SHOT 못 넘음</a:t>
+                      </a:r>
+                    </a:p>
+                  </a:txBody>
+                  <a:tcPr anchor="ctr">
+                    <a:solidFill>
+                      <a:srgbClr val="EEF3FC"/>
+                    </a:solidFill>
+                  </a:tcPr>
+                </a:tc>
+              </a:tr>
+              <a:tr h="440000">
+                <a:tc>
+                  <a:txBody>
+                    <a:bodyPr/>
+                    <a:lstStyle/>
+                    <a:p>
+                      <a:pPr algn="ctr"/>
+                      <a:r>
+                        <a:rPr sz="1050" b="0">
+                          <a:solidFill>
+                            <a:srgbClr val="1A1A1A"/>
+                          </a:solidFill>
+                        </a:rPr>
+                        <a:t>TTA(좌우반전 평균)</a:t>
+                      </a:r>
+                    </a:p>
+                  </a:txBody>
+                  <a:tcPr anchor="ctr">
+                    <a:solidFill>
+                      <a:srgbClr val="FFFFFF"/>
+                    </a:solidFill>
+                  </a:tcPr>
+                </a:tc>
+                <a:tc>
+                  <a:txBody>
+                    <a:bodyPr/>
+                    <a:lstStyle/>
+                    <a:p>
+                      <a:pPr algn="ctr"/>
+                      <a:r>
+                        <a:rPr sz="1050" b="0">
+                          <a:solidFill>
+                            <a:srgbClr val="1A1A1A"/>
+                          </a:solidFill>
+                        </a:rPr>
+                        <a:t>40.13%</a:t>
+                      </a:r>
+                    </a:p>
+                  </a:txBody>
+                  <a:tcPr anchor="ctr">
+                    <a:solidFill>
+                      <a:srgbClr val="FFFFFF"/>
+                    </a:solidFill>
+                  </a:tcPr>
+                </a:tc>
+                <a:tc>
+                  <a:txBody>
+                    <a:bodyPr/>
+                    <a:lstStyle/>
+                    <a:p>
+                      <a:pPr algn="ctr"/>
+                      <a:r>
+                        <a:rPr sz="1050" b="0">
+                          <a:solidFill>
+                            <a:srgbClr val="1A1A1A"/>
+                          </a:solidFill>
+                        </a:rPr>
+                        <a:t>31.70%</a:t>
+                      </a:r>
+                    </a:p>
+                  </a:txBody>
+                  <a:tcPr anchor="ctr">
+                    <a:solidFill>
+                      <a:srgbClr val="FFFFFF"/>
+                    </a:solidFill>
+                  </a:tcPr>
+                </a:tc>
+                <a:tc>
+                  <a:txBody>
+                    <a:bodyPr/>
+                    <a:lstStyle/>
+                    <a:p>
+                      <a:pPr algn="ctr"/>
+                      <a:r>
+                        <a:rPr sz="1050" b="0">
+                          <a:solidFill>
+                            <a:srgbClr val="1A1A1A"/>
+                          </a:solidFill>
+                        </a:rPr>
+                        <a:t>18.76%</a:t>
+                      </a:r>
+                    </a:p>
+                  </a:txBody>
+                  <a:tcPr anchor="ctr">
+                    <a:solidFill>
+                      <a:srgbClr val="FFFFFF"/>
+                    </a:solidFill>
+                  </a:tcPr>
+                </a:tc>
+                <a:tc>
+                  <a:txBody>
+                    <a:bodyPr/>
+                    <a:lstStyle/>
+                    <a:p>
+                      <a:pPr algn="ctr"/>
+                      <a:r>
+                        <a:rPr sz="1050" b="0">
+                          <a:solidFill>
+                            <a:srgbClr val="1A1A1A"/>
+                          </a:solidFill>
+                        </a:rPr>
+                        <a:t>단일seed, 혼재(Bangladesh만 소폭↑)</a:t>
+                      </a:r>
+                    </a:p>
+                  </a:txBody>
+                  <a:tcPr anchor="ctr">
+                    <a:solidFill>
+                      <a:srgbClr val="FFFFFF"/>
+                    </a:solidFill>
+                  </a:tcPr>
+                </a:tc>
+              </a:tr>
+              <a:tr h="440000">
+                <a:tc>
+                  <a:txBody>
+                    <a:bodyPr/>
+                    <a:lstStyle/>
+                    <a:p>
+                      <a:pPr algn="ctr"/>
+                      <a:r>
+                        <a:rPr sz="1050" b="0">
+                          <a:solidFill>
+                            <a:srgbClr val="1A1A1A"/>
+                          </a:solidFill>
+                        </a:rPr>
+                        <a:t>TTA + AaD</a:t>
+                      </a:r>
+                    </a:p>
+                  </a:txBody>
+                  <a:tcPr anchor="ctr">
+                    <a:solidFill>
+                      <a:srgbClr val="EEF3FC"/>
+                    </a:solidFill>
+                  </a:tcPr>
+                </a:tc>
+                <a:tc>
+                  <a:txBody>
+                    <a:bodyPr/>
+                    <a:lstStyle/>
+                    <a:p>
+                      <a:pPr algn="ctr"/>
+                      <a:r>
+                        <a:rPr sz="1050" b="0">
+                          <a:solidFill>
+                            <a:srgbClr val="1A1A1A"/>
+                          </a:solidFill>
+                        </a:rPr>
+                        <a:t>39.49%</a:t>
+                      </a:r>
+                    </a:p>
+                  </a:txBody>
+                  <a:tcPr anchor="ctr">
+                    <a:solidFill>
+                      <a:srgbClr val="EEF3FC"/>
+                    </a:solidFill>
+                  </a:tcPr>
+                </a:tc>
+                <a:tc>
+                  <a:txBody>
+                    <a:bodyPr/>
+                    <a:lstStyle/>
+                    <a:p>
+                      <a:pPr algn="ctr"/>
+                      <a:r>
+                        <a:rPr sz="1050" b="0">
+                          <a:solidFill>
+                            <a:srgbClr val="1A1A1A"/>
+                          </a:solidFill>
+                        </a:rPr>
+                        <a:t>32.33%</a:t>
+                      </a:r>
+                    </a:p>
+                  </a:txBody>
+                  <a:tcPr anchor="ctr">
+                    <a:solidFill>
+                      <a:srgbClr val="EEF3FC"/>
+                    </a:solidFill>
+                  </a:tcPr>
+                </a:tc>
+                <a:tc>
+                  <a:txBody>
+                    <a:bodyPr/>
+                    <a:lstStyle/>
+                    <a:p>
+                      <a:pPr algn="ctr"/>
+                      <a:r>
+                        <a:rPr sz="1050" b="0">
+                          <a:solidFill>
+                            <a:srgbClr val="1A1A1A"/>
+                          </a:solidFill>
+                        </a:rPr>
+                        <a:t>—</a:t>
+                      </a:r>
+                    </a:p>
+                  </a:txBody>
+                  <a:tcPr anchor="ctr">
+                    <a:solidFill>
+                      <a:srgbClr val="EEF3FC"/>
+                    </a:solidFill>
+                  </a:tcPr>
+                </a:tc>
+                <a:tc>
+                  <a:txBody>
+                    <a:bodyPr/>
+                    <a:lstStyle/>
+                    <a:p>
+                      <a:pPr algn="ctr"/>
+                      <a:r>
+                        <a:rPr sz="1050" b="0">
+                          <a:solidFill>
+                            <a:srgbClr val="1A1A1A"/>
+                          </a:solidFill>
+                        </a:rPr>
+                        <a:t>단일seed, Taiwan 하락</a:t>
+                      </a:r>
+                    </a:p>
+                  </a:txBody>
+                  <a:tcPr anchor="ctr">
+                    <a:solidFill>
+                      <a:srgbClr val="EEF3FC"/>
+                    </a:solidFill>
+                  </a:tcPr>
+                </a:tc>
+              </a:tr>
+              <a:tr h="440000">
+                <a:tc>
+                  <a:txBody>
+                    <a:bodyPr/>
+                    <a:lstStyle/>
+                    <a:p>
+                      <a:pPr algn="ctr"/>
+                      <a:r>
+                        <a:rPr sz="1050" b="0">
+                          <a:solidFill>
+                            <a:srgbClr val="1A1A1A"/>
+                          </a:solidFill>
+                        </a:rPr>
+                        <a:t>SHOT+AaD, epoch=7(Taiwan만)</a:t>
+                      </a:r>
+                    </a:p>
+                  </a:txBody>
+                  <a:tcPr anchor="ctr">
+                    <a:solidFill>
+                      <a:srgbClr val="FFFFFF"/>
+                    </a:solidFill>
+                  </a:tcPr>
+                </a:tc>
+                <a:tc>
+                  <a:txBody>
+                    <a:bodyPr/>
+                    <a:lstStyle/>
+                    <a:p>
+                      <a:pPr algn="ctr"/>
+                      <a:r>
+                        <a:rPr sz="1050" b="0">
+                          <a:solidFill>
+                            <a:srgbClr val="1A1A1A"/>
+                          </a:solidFill>
+                        </a:rPr>
+                        <a:t>43.42%±10.52</a:t>
+                      </a:r>
+                    </a:p>
+                  </a:txBody>
+                  <a:tcPr anchor="ctr">
+                    <a:solidFill>
+                      <a:srgbClr val="FFFFFF"/>
+                    </a:solidFill>
+                  </a:tcPr>
+                </a:tc>
+                <a:tc>
+                  <a:txBody>
+                    <a:bodyPr/>
+                    <a:lstStyle/>
+                    <a:p>
+                      <a:pPr algn="ctr"/>
+                      <a:r>
+                        <a:rPr sz="1050" b="0">
+                          <a:solidFill>
+                            <a:srgbClr val="1A1A1A"/>
+                          </a:solidFill>
+                        </a:rPr>
+                        <a:t>—</a:t>
+                      </a:r>
+                    </a:p>
+                  </a:txBody>
+                  <a:tcPr anchor="ctr">
+                    <a:solidFill>
+                      <a:srgbClr val="FFFFFF"/>
+                    </a:solidFill>
+                  </a:tcPr>
+                </a:tc>
+                <a:tc>
+                  <a:txBody>
+                    <a:bodyPr/>
+                    <a:lstStyle/>
+                    <a:p>
+                      <a:pPr algn="ctr"/>
+                      <a:r>
+                        <a:rPr sz="1050" b="0">
+                          <a:solidFill>
+                            <a:srgbClr val="1A1A1A"/>
+                          </a:solidFill>
+                        </a:rPr>
+                        <a:t>—</a:t>
+                      </a:r>
+                    </a:p>
+                  </a:txBody>
+                  <a:tcPr anchor="ctr">
+                    <a:solidFill>
+                      <a:srgbClr val="FFFFFF"/>
+                    </a:solidFill>
+                  </a:tcPr>
+                </a:tc>
+                <a:tc>
+                  <a:txBody>
+                    <a:bodyPr/>
+                    <a:lstStyle/>
+                    <a:p>
+                      <a:pPr algn="ctr"/>
+                      <a:r>
+                        <a:rPr sz="1050" b="0">
+                          <a:solidFill>
+                            <a:srgbClr val="1A1A1A"/>
+                          </a:solidFill>
+                        </a:rPr>
+                        <a:t>3-seed: 평균↑ 표준편차도 2배↑ → 채택 보류</a:t>
+                      </a:r>
+                    </a:p>
+                  </a:txBody>
+                  <a:tcPr anchor="ctr">
+                    <a:solidFill>
+                      <a:srgbClr val="FFFFFF"/>
+                    </a:solidFill>
+                  </a:tcPr>
+                </a:tc>
+              </a:tr>
+            </a:tbl>
+          </a:graphicData>
+        </a:graphic>
+      </p:graphicFrame>
+      <p:sp>
+        <p:nvSpPr>
+          <p:cNvPr id="6" name="TextBox 4"/>
+          <p:cNvSpPr txBox="1"/>
+          <p:nvPr/>
+        </p:nvSpPr>
+        <p:spPr>
+          <a:xfrm>
+            <a:off x="548640" y="4650000"/>
+            <a:ext cx="11091672" cy="1700000"/>
+          </a:xfrm>
+          <a:prstGeom prst="rect">
+            <a:avLst/>
+          </a:prstGeom>
+          <a:noFill/>
+        </p:spPr>
+        <p:txBody>
+          <a:bodyPr wrap="square" anchor="t" lIns="0" rIns="0" tIns="0" bIns="0">
+            <a:spAutoFit/>
+          </a:bodyPr>
+          <a:lstStyle/>
+          <a:p>
+            <a:pPr algn="l"/>
+            <a:r>
+              <a:rPr sz="1100" b="0" i="1">
+                <a:solidFill>
+                  <a:srgbClr val="5B5E6B"/>
+                </a:solidFill>
+                <a:latin typeface="Calibri"/>
+              </a:rPr>
+              <a:t>*confident-prototype(hard)는 seed42에서 Taiwan의 healthy 블라인드스팟을 실제로 풀었다(recall 0%→34.9%, precision 84%) — 하지만 3-seed로 검증하니 seed123이 17.52%(3클래스 랜덤 확률보다도 낮음)로 완전히 무너졌다. 작은/애매한 클래스는 “확신 있는 멤버”가 seed에 따라 아예 없거나 전부 오답일 수 있다는 뜻이다. soft 버전(sharpen)·TTA는 극단적으로 무너지진 않지만 SHOT+AaD를 넘는 신호가 보이지 않아 3-seed 검증 없이 기각했다. 지금까지 시도한 8개 방향 중 3-seed 검증을 통과한 것은 SHOT+AaD(weight=1.0, 공통)뿐이다.</a:t>
+            </a:r>
+          </a:p>
+        </p:txBody>
+      </p:sp>
+      <p:sp>
+        <p:nvSpPr>
+          <p:cNvPr id="9" name="TextBox 5"/>
+          <p:cNvSpPr txBox="1"/>
+          <p:nvPr/>
+        </p:nvSpPr>
+        <p:spPr>
+          <a:xfrm>
+            <a:off x="11430000" y="6446520"/>
+            <a:ext cx="548640" cy="274320"/>
+          </a:xfrm>
+          <a:prstGeom prst="rect">
+            <a:avLst/>
+          </a:prstGeom>
+          <a:noFill/>
+        </p:spPr>
+        <p:txBody>
+          <a:bodyPr wrap="square" anchor="t" lIns="0" rIns="0" tIns="0" bIns="0">
+            <a:spAutoFit/>
+          </a:bodyPr>
+          <a:lstStyle/>
+          <a:p>
+            <a:pPr algn="r"/>
+            <a:r>
+              <a:rPr sz="1000" b="0" i="0">
+                <a:solidFill>
+                  <a:srgbClr val="5B5E6B"/>
+                </a:solidFill>
+                <a:latin typeface="Calibri"/>
+              </a:rPr>
+              <a:t>28</a:t>
             </a:r>
           </a:p>
         </p:txBody>

</xml_diff>